<commit_message>
Deploy AMG ecosystem · 2026-04-24 13:18
- Portal público (home, artículos, detección, para-médicos)
- Hub de revisión sistema_piezas_AMG_Hub.html con sidebar Dreamweaver
- Visita Médica PWA (visita-medica-amg/) — 3 ciclos + 4 interactivos offline
- Corpus visual HUB_AMG_PYLORI/ (brand_amg + brand_kicab)
- Documentos ejecutivos (.docx maestro, .xlsx métricas, .pptx pitch)

Firebase RTDB sync: polar-amg-hub-2026 (compartido entre hub y VM)
Org: polar-multimedia · github.com/polar-multimedia/amg-pylori-hub
</commit_message>
<xml_diff>
--- a/Pitch_Ejecutivo_AMG_2026.pptx
+++ b/Pitch_Ejecutivo_AMG_2026.pptx
@@ -2895,7 +2895,7 @@
                 <a:ea typeface="Montserrat" pitchFamily="34" charset="-122"/>
                 <a:cs typeface="Montserrat" pitchFamily="34" charset="-120"/>
               </a:rPr>
-              <a:t>Pitch Ejecutivo v1.0</a:t>
+              <a:t>Pitch Ejecutivo v1.1</a:t>
             </a:r>
             <a:endParaRPr lang="en-US" sz="1200" dirty="0"/>
           </a:p>
@@ -2934,7 +2934,7 @@
                 <a:ea typeface="Inter" pitchFamily="34" charset="-122"/>
                 <a:cs typeface="Inter" pitchFamily="34" charset="-120"/>
               </a:rPr>
-              <a:t>Preparado por Polar Multimedia · 24 de Abril de 2026</a:t>
+              <a:t>Preparado por Polar Multimedia · Abril 2026</a:t>
             </a:r>
             <a:endParaRPr lang="en-US" sz="1100" dirty="0"/>
           </a:p>
@@ -6336,7 +6336,7 @@
                 <a:ea typeface="Montserrat" pitchFamily="34" charset="-122"/>
                 <a:cs typeface="Montserrat" pitchFamily="34" charset="-120"/>
               </a:rPr>
-              <a:t>INFLUENCERS MÉDICOS · CAPA DE CREDIBILIDAD</a:t>
+              <a:t>INFLUENCERS MÉDICOS (KOLs) · 6 PERFILES</a:t>
             </a:r>
             <a:endParaRPr lang="en-US" sz="1100" dirty="0"/>
           </a:p>
@@ -6367,7 +6367,7 @@
               <a:buNone/>
             </a:pPr>
             <a:r>
-              <a:rPr lang="en-US" sz="3200" b="1" dirty="0">
+              <a:rPr lang="en-US" sz="2800" b="1" dirty="0">
                 <a:solidFill>
                   <a:srgbClr val="183888"/>
                 </a:solidFill>
@@ -6375,9 +6375,9 @@
                 <a:ea typeface="Montserrat" pitchFamily="34" charset="-122"/>
                 <a:cs typeface="Montserrat" pitchFamily="34" charset="-120"/>
               </a:rPr>
-              <a:t>3 tiers de KOLs para alcance orgánico diferenciado</a:t>
-            </a:r>
-            <a:endParaRPr lang="en-US" sz="3200" dirty="0"/>
+              <a:t>Roster contratado para amplificación orgánica</a:t>
+            </a:r>
+            <a:endParaRPr lang="en-US" sz="2800" dirty="0"/>
           </a:p>
         </p:txBody>
       </p:sp>
@@ -6389,12 +6389,12 @@
         </p:nvSpPr>
         <p:spPr>
           <a:xfrm>
-            <a:off x="548640" y="1554480"/>
-            <a:ext cx="3657600" cy="4114800"/>
+            <a:off x="548640" y="1371600"/>
+            <a:ext cx="5486400" cy="1508760"/>
           </a:xfrm>
           <a:prstGeom prst="roundRect">
             <a:avLst>
-              <a:gd name="adj" fmla="val 3750"/>
+              <a:gd name="adj" fmla="val 6061"/>
             </a:avLst>
           </a:prstGeom>
           <a:solidFill>
@@ -6416,12 +6416,12 @@
         </p:nvSpPr>
         <p:spPr>
           <a:xfrm>
-            <a:off x="731520" y="1737360"/>
-            <a:ext cx="1188720" cy="320040"/>
+            <a:off x="731520" y="1508760"/>
+            <a:ext cx="502920" cy="274320"/>
           </a:xfrm>
           <a:prstGeom prst="roundRect">
             <a:avLst>
-              <a:gd name="adj" fmla="val 48571"/>
+              <a:gd name="adj" fmla="val 50000"/>
             </a:avLst>
           </a:prstGeom>
           <a:solidFill>
@@ -6443,8 +6443,8 @@
         </p:nvSpPr>
         <p:spPr>
           <a:xfrm>
-            <a:off x="731520" y="1737360"/>
-            <a:ext cx="1188720" cy="320040"/>
+            <a:off x="731520" y="1508760"/>
+            <a:ext cx="502920" cy="274320"/>
           </a:xfrm>
           <a:prstGeom prst="rect">
             <a:avLst/>
@@ -6460,7 +6460,7 @@
               <a:buNone/>
             </a:pPr>
             <a:r>
-              <a:rPr lang="en-US" sz="1000" b="1" dirty="0">
+              <a:rPr lang="en-US" sz="900" b="1" dirty="0">
                 <a:solidFill>
                   <a:srgbClr val="FFFFFF"/>
                 </a:solidFill>
@@ -6468,9 +6468,9 @@
                 <a:ea typeface="Montserrat" pitchFamily="34" charset="-122"/>
                 <a:cs typeface="Montserrat" pitchFamily="34" charset="-120"/>
               </a:rPr>
-              <a:t>Tier 1</a:t>
-            </a:r>
-            <a:endParaRPr lang="en-US" sz="1000" dirty="0"/>
+              <a:t>AMG</a:t>
+            </a:r>
+            <a:endParaRPr lang="en-US" sz="900" dirty="0"/>
           </a:p>
         </p:txBody>
       </p:sp>
@@ -6482,24 +6482,24 @@
         </p:nvSpPr>
         <p:spPr>
           <a:xfrm>
-            <a:off x="731520" y="2194560"/>
-            <a:ext cx="3291840" cy="411480"/>
-          </a:xfrm>
-          <a:prstGeom prst="rect">
-            <a:avLst/>
-          </a:prstGeom>
-          <a:noFill/>
-          <a:ln/>
-        </p:spPr>
-        <p:txBody>
-          <a:bodyPr wrap="square" rtlCol="0" anchor="ctr"/>
-          <a:lstStyle/>
-          <a:p>
-            <a:pPr indent="0" marL="0">
-              <a:buNone/>
-            </a:pPr>
-            <a:r>
-              <a:rPr lang="en-US" sz="1800" b="1" dirty="0">
+            <a:off x="1325880" y="1463040"/>
+            <a:ext cx="4572000" cy="365760"/>
+          </a:xfrm>
+          <a:prstGeom prst="rect">
+            <a:avLst/>
+          </a:prstGeom>
+          <a:noFill/>
+          <a:ln/>
+        </p:spPr>
+        <p:txBody>
+          <a:bodyPr wrap="square" rtlCol="0" anchor="ctr"/>
+          <a:lstStyle/>
+          <a:p>
+            <a:pPr indent="0" marL="0">
+              <a:buNone/>
+            </a:pPr>
+            <a:r>
+              <a:rPr lang="en-US" sz="1300" b="1" dirty="0">
                 <a:solidFill>
                   <a:srgbClr val="183888"/>
                 </a:solidFill>
@@ -6507,9 +6507,9 @@
                 <a:ea typeface="Montserrat" pitchFamily="34" charset="-122"/>
                 <a:cs typeface="Montserrat" pitchFamily="34" charset="-120"/>
               </a:rPr>
-              <a:t>KOLs senior HCP</a:t>
-            </a:r>
-            <a:endParaRPr lang="en-US" sz="1800" dirty="0"/>
+              <a:t>Dr. Luis Raúl Valdovinos</a:t>
+            </a:r>
+            <a:endParaRPr lang="en-US" sz="1300" dirty="0"/>
           </a:p>
         </p:txBody>
       </p:sp>
@@ -6521,24 +6521,24 @@
         </p:nvSpPr>
         <p:spPr>
           <a:xfrm>
-            <a:off x="731520" y="2606040"/>
-            <a:ext cx="3291840" cy="320040"/>
-          </a:xfrm>
-          <a:prstGeom prst="rect">
-            <a:avLst/>
-          </a:prstGeom>
-          <a:noFill/>
-          <a:ln/>
-        </p:spPr>
-        <p:txBody>
-          <a:bodyPr wrap="square" rtlCol="0" anchor="ctr"/>
-          <a:lstStyle/>
-          <a:p>
-            <a:pPr indent="0" marL="0">
-              <a:buNone/>
-            </a:pPr>
-            <a:r>
-              <a:rPr lang="en-US" sz="1100" i="1" dirty="0">
+            <a:off x="1325880" y="1783080"/>
+            <a:ext cx="4572000" cy="274320"/>
+          </a:xfrm>
+          <a:prstGeom prst="rect">
+            <a:avLst/>
+          </a:prstGeom>
+          <a:noFill/>
+          <a:ln/>
+        </p:spPr>
+        <p:txBody>
+          <a:bodyPr wrap="square" rtlCol="0" anchor="ctr"/>
+          <a:lstStyle/>
+          <a:p>
+            <a:pPr indent="0" marL="0">
+              <a:buNone/>
+            </a:pPr>
+            <a:r>
+              <a:rPr lang="en-US" sz="1000" i="1" dirty="0">
                 <a:solidFill>
                   <a:srgbClr val="183888"/>
                 </a:solidFill>
@@ -6546,30 +6546,110 @@
                 <a:ea typeface="Inter" pitchFamily="34" charset="-122"/>
                 <a:cs typeface="Inter" pitchFamily="34" charset="-120"/>
               </a:rPr>
-              <a:t>Especialistas reconocidos</a:t>
-            </a:r>
-            <a:endParaRPr lang="en-US" sz="1100" dirty="0"/>
-          </a:p>
-        </p:txBody>
-      </p:sp>
-      <p:sp>
-        <p:nvSpPr>
-          <p:cNvPr id="10" name="Shape 8"/>
-          <p:cNvSpPr/>
-          <p:nvPr/>
-        </p:nvSpPr>
-        <p:spPr>
-          <a:xfrm>
-            <a:off x="731520" y="3017520"/>
-            <a:ext cx="3291840" cy="0"/>
-          </a:xfrm>
-          <a:prstGeom prst="line">
-            <a:avLst/>
-          </a:prstGeom>
-          <a:noFill/>
+              <a:t>AMG Institucional</a:t>
+            </a:r>
+            <a:endParaRPr lang="en-US" sz="1000" dirty="0"/>
+          </a:p>
+        </p:txBody>
+      </p:sp>
+      <p:sp>
+        <p:nvSpPr>
+          <p:cNvPr id="10" name="Text 8"/>
+          <p:cNvSpPr/>
+          <p:nvPr/>
+        </p:nvSpPr>
+        <p:spPr>
+          <a:xfrm>
+            <a:off x="731520" y="2103120"/>
+            <a:ext cx="5120640" cy="228600"/>
+          </a:xfrm>
+          <a:prstGeom prst="rect">
+            <a:avLst/>
+          </a:prstGeom>
+          <a:noFill/>
+          <a:ln/>
+        </p:spPr>
+        <p:txBody>
+          <a:bodyPr wrap="square" rtlCol="0" anchor="ctr"/>
+          <a:lstStyle/>
+          <a:p>
+            <a:pPr indent="0" marL="0">
+              <a:buNone/>
+            </a:pPr>
+            <a:r>
+              <a:rPr lang="en-US" sz="950" dirty="0">
+                <a:solidFill>
+                  <a:srgbClr val="4B5563"/>
+                </a:solidFill>
+                <a:latin typeface="Inter" pitchFamily="34" charset="0"/>
+                <a:ea typeface="Inter" pitchFamily="34" charset="-122"/>
+                <a:cs typeface="Inter" pitchFamily="34" charset="-120"/>
+              </a:rPr>
+              <a:t>HCP especialista  ·  Aval institucional</a:t>
+            </a:r>
+            <a:endParaRPr lang="en-US" sz="950" dirty="0"/>
+          </a:p>
+        </p:txBody>
+      </p:sp>
+      <p:sp>
+        <p:nvSpPr>
+          <p:cNvPr id="11" name="Text 9"/>
+          <p:cNvSpPr/>
+          <p:nvPr/>
+        </p:nvSpPr>
+        <p:spPr>
+          <a:xfrm>
+            <a:off x="731520" y="2331720"/>
+            <a:ext cx="5120640" cy="274320"/>
+          </a:xfrm>
+          <a:prstGeom prst="rect">
+            <a:avLst/>
+          </a:prstGeom>
+          <a:noFill/>
+          <a:ln/>
+        </p:spPr>
+        <p:txBody>
+          <a:bodyPr wrap="square" rtlCol="0" anchor="ctr"/>
+          <a:lstStyle/>
+          <a:p>
+            <a:pPr indent="0" marL="0">
+              <a:buNone/>
+            </a:pPr>
+            <a:r>
+              <a:rPr lang="en-US" sz="900" dirty="0">
+                <a:solidFill>
+                  <a:srgbClr val="2A2A2A"/>
+                </a:solidFill>
+                <a:latin typeface="Inter" pitchFamily="34" charset="0"/>
+                <a:ea typeface="Inter" pitchFamily="34" charset="-122"/>
+                <a:cs typeface="Inter" pitchFamily="34" charset="-120"/>
+              </a:rPr>
+              <a:t>Aval de eficacia de erradicación &gt;90% en materiales con marca Ki-CAB</a:t>
+            </a:r>
+            <a:endParaRPr lang="en-US" sz="900" dirty="0"/>
+          </a:p>
+        </p:txBody>
+      </p:sp>
+      <p:sp>
+        <p:nvSpPr>
+          <p:cNvPr id="12" name="Shape 10"/>
+          <p:cNvSpPr/>
+          <p:nvPr/>
+        </p:nvSpPr>
+        <p:spPr>
+          <a:xfrm>
+            <a:off x="731520" y="2615184"/>
+            <a:ext cx="5120640" cy="201168"/>
+          </a:xfrm>
+          <a:prstGeom prst="rect">
+            <a:avLst/>
+          </a:prstGeom>
+          <a:solidFill>
+            <a:srgbClr val="E8EEF7"/>
+          </a:solidFill>
           <a:ln w="12700">
             <a:solidFill>
-              <a:srgbClr val="E5E7EB"/>
+              <a:srgbClr val="E8EEF7"/>
             </a:solidFill>
             <a:prstDash val="solid"/>
           </a:ln>
@@ -6577,174 +6657,57 @@
       </p:sp>
       <p:sp>
         <p:nvSpPr>
-          <p:cNvPr id="11" name="Text 9"/>
-          <p:cNvSpPr/>
-          <p:nvPr/>
-        </p:nvSpPr>
-        <p:spPr>
-          <a:xfrm>
-            <a:off x="731520" y="3108960"/>
-            <a:ext cx="3291840" cy="228600"/>
-          </a:xfrm>
-          <a:prstGeom prst="rect">
-            <a:avLst/>
-          </a:prstGeom>
-          <a:noFill/>
-          <a:ln/>
-        </p:spPr>
-        <p:txBody>
-          <a:bodyPr wrap="square" rtlCol="0" anchor="ctr"/>
-          <a:lstStyle/>
-          <a:p>
-            <a:pPr indent="0" marL="0">
-              <a:buNone/>
-            </a:pPr>
-            <a:r>
-              <a:rPr lang="en-US" sz="900" b="1" spc="200" kern="0" dirty="0">
-                <a:solidFill>
-                  <a:srgbClr val="4B5563"/>
+          <p:cNvPr id="13" name="Text 11"/>
+          <p:cNvSpPr/>
+          <p:nvPr/>
+        </p:nvSpPr>
+        <p:spPr>
+          <a:xfrm>
+            <a:off x="731520" y="2615184"/>
+            <a:ext cx="5120640" cy="201168"/>
+          </a:xfrm>
+          <a:prstGeom prst="rect">
+            <a:avLst/>
+          </a:prstGeom>
+          <a:noFill/>
+          <a:ln/>
+        </p:spPr>
+        <p:txBody>
+          <a:bodyPr wrap="square" rtlCol="0" anchor="ctr"/>
+          <a:lstStyle/>
+          <a:p>
+            <a:pPr algn="ctr" indent="0" marL="0">
+              <a:buNone/>
+            </a:pPr>
+            <a:r>
+              <a:rPr lang="en-US" sz="950" b="1" dirty="0">
+                <a:solidFill>
+                  <a:srgbClr val="183888"/>
                 </a:solidFill>
                 <a:latin typeface="Montserrat" pitchFamily="34" charset="0"/>
                 <a:ea typeface="Montserrat" pitchFamily="34" charset="-122"/>
                 <a:cs typeface="Montserrat" pitchFamily="34" charset="-120"/>
               </a:rPr>
-              <a:t>KOLs</a:t>
-            </a:r>
-            <a:endParaRPr lang="en-US" sz="900" dirty="0"/>
-          </a:p>
-        </p:txBody>
-      </p:sp>
-      <p:sp>
-        <p:nvSpPr>
-          <p:cNvPr id="12" name="Text 10"/>
-          <p:cNvSpPr/>
-          <p:nvPr/>
-        </p:nvSpPr>
-        <p:spPr>
-          <a:xfrm>
-            <a:off x="731520" y="3337560"/>
-            <a:ext cx="3291840" cy="1188720"/>
-          </a:xfrm>
-          <a:prstGeom prst="rect">
-            <a:avLst/>
-          </a:prstGeom>
-          <a:noFill/>
-          <a:ln/>
-        </p:spPr>
-        <p:txBody>
-          <a:bodyPr wrap="square" rtlCol="0" anchor="ctr"/>
-          <a:lstStyle/>
-          <a:p>
-            <a:pPr indent="0" marL="0">
-              <a:buNone/>
-            </a:pPr>
-            <a:r>
-              <a:rPr lang="en-US" sz="1100" dirty="0">
-                <a:solidFill>
-                  <a:srgbClr val="2A2A2A"/>
-                </a:solidFill>
-                <a:latin typeface="Inter" pitchFamily="34" charset="0"/>
-                <a:ea typeface="Inter" pitchFamily="34" charset="-122"/>
-                <a:cs typeface="Inter" pitchFamily="34" charset="-120"/>
-              </a:rPr>
-              <a:t>Dr. Remes-Troche · Dra. Valdovinos · Dr. Coss Adame</a:t>
-            </a:r>
-            <a:endParaRPr lang="en-US" sz="1100" dirty="0"/>
-          </a:p>
-        </p:txBody>
-      </p:sp>
-      <p:sp>
-        <p:nvSpPr>
-          <p:cNvPr id="13" name="Text 11"/>
-          <p:cNvSpPr/>
-          <p:nvPr/>
-        </p:nvSpPr>
-        <p:spPr>
-          <a:xfrm>
-            <a:off x="731520" y="4709160"/>
-            <a:ext cx="3291840" cy="228600"/>
-          </a:xfrm>
-          <a:prstGeom prst="rect">
-            <a:avLst/>
-          </a:prstGeom>
-          <a:noFill/>
-          <a:ln/>
-        </p:spPr>
-        <p:txBody>
-          <a:bodyPr wrap="square" rtlCol="0" anchor="ctr"/>
-          <a:lstStyle/>
-          <a:p>
-            <a:pPr indent="0" marL="0">
-              <a:buNone/>
-            </a:pPr>
-            <a:r>
-              <a:rPr lang="en-US" sz="900" b="1" spc="200" kern="0" dirty="0">
-                <a:solidFill>
-                  <a:srgbClr val="4B5563"/>
-                </a:solidFill>
-                <a:latin typeface="Montserrat" pitchFamily="34" charset="0"/>
-                <a:ea typeface="Montserrat" pitchFamily="34" charset="-122"/>
-                <a:cs typeface="Montserrat" pitchFamily="34" charset="-120"/>
-              </a:rPr>
-              <a:t>Audiencia promedio</a:t>
-            </a:r>
-            <a:endParaRPr lang="en-US" sz="900" dirty="0"/>
-          </a:p>
-        </p:txBody>
-      </p:sp>
-      <p:sp>
-        <p:nvSpPr>
-          <p:cNvPr id="14" name="Text 12"/>
-          <p:cNvSpPr/>
-          <p:nvPr/>
-        </p:nvSpPr>
-        <p:spPr>
-          <a:xfrm>
-            <a:off x="731520" y="4937760"/>
-            <a:ext cx="3291840" cy="365760"/>
-          </a:xfrm>
-          <a:prstGeom prst="rect">
-            <a:avLst/>
-          </a:prstGeom>
-          <a:noFill/>
-          <a:ln/>
-        </p:spPr>
-        <p:txBody>
-          <a:bodyPr wrap="square" rtlCol="0" anchor="ctr"/>
-          <a:lstStyle/>
-          <a:p>
-            <a:pPr indent="0" marL="0">
-              <a:buNone/>
-            </a:pPr>
-            <a:r>
-              <a:rPr lang="en-US" sz="1500" b="1" dirty="0">
-                <a:solidFill>
-                  <a:srgbClr val="183888"/>
-                </a:solidFill>
-                <a:latin typeface="Montserrat" pitchFamily="34" charset="0"/>
-                <a:ea typeface="Montserrat" pitchFamily="34" charset="-122"/>
-                <a:cs typeface="Montserrat" pitchFamily="34" charset="-120"/>
-              </a:rPr>
-              <a:t>HCP 28k-80k</a:t>
-            </a:r>
-            <a:endParaRPr lang="en-US" sz="1500" dirty="0"/>
-          </a:p>
-        </p:txBody>
-      </p:sp>
-      <p:sp>
-        <p:nvSpPr>
-          <p:cNvPr id="15" name="Shape 13"/>
-          <p:cNvSpPr/>
-          <p:nvPr/>
-        </p:nvSpPr>
-        <p:spPr>
-          <a:xfrm>
-            <a:off x="4434840" y="1554480"/>
-            <a:ext cx="3657600" cy="4114800"/>
+              <a:t>Convenio Polar-AMG (sin costo)</a:t>
+            </a:r>
+            <a:endParaRPr lang="en-US" sz="950" dirty="0"/>
+          </a:p>
+        </p:txBody>
+      </p:sp>
+      <p:sp>
+        <p:nvSpPr>
+          <p:cNvPr id="14" name="Shape 12"/>
+          <p:cNvSpPr/>
+          <p:nvPr/>
+        </p:nvSpPr>
+        <p:spPr>
+          <a:xfrm>
+            <a:off x="6217920" y="1371600"/>
+            <a:ext cx="5486400" cy="1508760"/>
           </a:xfrm>
           <a:prstGeom prst="roundRect">
             <a:avLst>
-              <a:gd name="adj" fmla="val 3750"/>
+              <a:gd name="adj" fmla="val 6061"/>
             </a:avLst>
           </a:prstGeom>
           <a:solidFill>
@@ -6760,18 +6723,18 @@
       </p:sp>
       <p:sp>
         <p:nvSpPr>
-          <p:cNvPr id="16" name="Shape 14"/>
-          <p:cNvSpPr/>
-          <p:nvPr/>
-        </p:nvSpPr>
-        <p:spPr>
-          <a:xfrm>
-            <a:off x="4617720" y="1737360"/>
-            <a:ext cx="1188720" cy="320040"/>
+          <p:cNvPr id="15" name="Shape 13"/>
+          <p:cNvSpPr/>
+          <p:nvPr/>
+        </p:nvSpPr>
+        <p:spPr>
+          <a:xfrm>
+            <a:off x="6400800" y="1508760"/>
+            <a:ext cx="502920" cy="274320"/>
           </a:xfrm>
           <a:prstGeom prst="roundRect">
             <a:avLst>
-              <a:gd name="adj" fmla="val 48571"/>
+              <a:gd name="adj" fmla="val 50000"/>
             </a:avLst>
           </a:prstGeom>
           <a:solidFill>
@@ -6787,14 +6750,14 @@
       </p:sp>
       <p:sp>
         <p:nvSpPr>
-          <p:cNvPr id="17" name="Text 15"/>
-          <p:cNvSpPr/>
-          <p:nvPr/>
-        </p:nvSpPr>
-        <p:spPr>
-          <a:xfrm>
-            <a:off x="4617720" y="1737360"/>
-            <a:ext cx="1188720" cy="320040"/>
+          <p:cNvPr id="16" name="Text 14"/>
+          <p:cNvSpPr/>
+          <p:nvPr/>
+        </p:nvSpPr>
+        <p:spPr>
+          <a:xfrm>
+            <a:off x="6400800" y="1508760"/>
+            <a:ext cx="502920" cy="274320"/>
           </a:xfrm>
           <a:prstGeom prst="rect">
             <a:avLst/>
@@ -6810,7 +6773,7 @@
               <a:buNone/>
             </a:pPr>
             <a:r>
-              <a:rPr lang="en-US" sz="1000" b="1" dirty="0">
+              <a:rPr lang="en-US" sz="900" b="1" dirty="0">
                 <a:solidFill>
                   <a:srgbClr val="FFFFFF"/>
                 </a:solidFill>
@@ -6818,38 +6781,38 @@
                 <a:ea typeface="Montserrat" pitchFamily="34" charset="-122"/>
                 <a:cs typeface="Montserrat" pitchFamily="34" charset="-120"/>
               </a:rPr>
-              <a:t>Tier 2</a:t>
-            </a:r>
-            <a:endParaRPr lang="en-US" sz="1000" dirty="0"/>
-          </a:p>
-        </p:txBody>
-      </p:sp>
-      <p:sp>
-        <p:nvSpPr>
-          <p:cNvPr id="18" name="Text 16"/>
-          <p:cNvSpPr/>
-          <p:nvPr/>
-        </p:nvSpPr>
-        <p:spPr>
-          <a:xfrm>
-            <a:off x="4617720" y="2194560"/>
-            <a:ext cx="3291840" cy="411480"/>
-          </a:xfrm>
-          <a:prstGeom prst="rect">
-            <a:avLst/>
-          </a:prstGeom>
-          <a:noFill/>
-          <a:ln/>
-        </p:spPr>
-        <p:txBody>
-          <a:bodyPr wrap="square" rtlCol="0" anchor="ctr"/>
-          <a:lstStyle/>
-          <a:p>
-            <a:pPr indent="0" marL="0">
-              <a:buNone/>
-            </a:pPr>
-            <a:r>
-              <a:rPr lang="en-US" sz="1800" b="1" dirty="0">
+              <a:t>T1</a:t>
+            </a:r>
+            <a:endParaRPr lang="en-US" sz="900" dirty="0"/>
+          </a:p>
+        </p:txBody>
+      </p:sp>
+      <p:sp>
+        <p:nvSpPr>
+          <p:cNvPr id="17" name="Text 15"/>
+          <p:cNvSpPr/>
+          <p:nvPr/>
+        </p:nvSpPr>
+        <p:spPr>
+          <a:xfrm>
+            <a:off x="6995160" y="1463040"/>
+            <a:ext cx="4572000" cy="365760"/>
+          </a:xfrm>
+          <a:prstGeom prst="rect">
+            <a:avLst/>
+          </a:prstGeom>
+          <a:noFill/>
+          <a:ln/>
+        </p:spPr>
+        <p:txBody>
+          <a:bodyPr wrap="square" rtlCol="0" anchor="ctr"/>
+          <a:lstStyle/>
+          <a:p>
+            <a:pPr indent="0" marL="0">
+              <a:buNone/>
+            </a:pPr>
+            <a:r>
+              <a:rPr lang="en-US" sz="1300" b="1" dirty="0">
                 <a:solidFill>
                   <a:srgbClr val="183888"/>
                 </a:solidFill>
@@ -6857,38 +6820,38 @@
                 <a:ea typeface="Montserrat" pitchFamily="34" charset="-122"/>
                 <a:cs typeface="Montserrat" pitchFamily="34" charset="-120"/>
               </a:rPr>
-              <a:t>Divulgadores masivos</a:t>
-            </a:r>
-            <a:endParaRPr lang="en-US" sz="1800" dirty="0"/>
-          </a:p>
-        </p:txBody>
-      </p:sp>
-      <p:sp>
-        <p:nvSpPr>
-          <p:cNvPr id="19" name="Text 17"/>
-          <p:cNvSpPr/>
-          <p:nvPr/>
-        </p:nvSpPr>
-        <p:spPr>
-          <a:xfrm>
-            <a:off x="4617720" y="2606040"/>
-            <a:ext cx="3291840" cy="320040"/>
-          </a:xfrm>
-          <a:prstGeom prst="rect">
-            <a:avLst/>
-          </a:prstGeom>
-          <a:noFill/>
-          <a:ln/>
-        </p:spPr>
-        <p:txBody>
-          <a:bodyPr wrap="square" rtlCol="0" anchor="ctr"/>
-          <a:lstStyle/>
-          <a:p>
-            <a:pPr indent="0" marL="0">
-              <a:buNone/>
-            </a:pPr>
-            <a:r>
-              <a:rPr lang="en-US" sz="1100" i="1" dirty="0">
+              <a:t>@doctormiguelpadilla</a:t>
+            </a:r>
+            <a:endParaRPr lang="en-US" sz="1300" dirty="0"/>
+          </a:p>
+        </p:txBody>
+      </p:sp>
+      <p:sp>
+        <p:nvSpPr>
+          <p:cNvPr id="18" name="Text 16"/>
+          <p:cNvSpPr/>
+          <p:nvPr/>
+        </p:nvSpPr>
+        <p:spPr>
+          <a:xfrm>
+            <a:off x="6995160" y="1783080"/>
+            <a:ext cx="4572000" cy="274320"/>
+          </a:xfrm>
+          <a:prstGeom prst="rect">
+            <a:avLst/>
+          </a:prstGeom>
+          <a:noFill/>
+          <a:ln/>
+        </p:spPr>
+        <p:txBody>
+          <a:bodyPr wrap="square" rtlCol="0" anchor="ctr"/>
+          <a:lstStyle/>
+          <a:p>
+            <a:pPr indent="0" marL="0">
+              <a:buNone/>
+            </a:pPr>
+            <a:r>
+              <a:rPr lang="en-US" sz="1000" i="1" dirty="0">
                 <a:solidFill>
                   <a:srgbClr val="30B8B0"/>
                 </a:solidFill>
@@ -6896,30 +6859,110 @@
                 <a:ea typeface="Inter" pitchFamily="34" charset="-122"/>
                 <a:cs typeface="Inter" pitchFamily="34" charset="-120"/>
               </a:rPr>
-              <a:t>Médicos de visibilidad</a:t>
-            </a:r>
-            <a:endParaRPr lang="en-US" sz="1100" dirty="0"/>
-          </a:p>
-        </p:txBody>
-      </p:sp>
-      <p:sp>
-        <p:nvSpPr>
-          <p:cNvPr id="20" name="Shape 18"/>
-          <p:cNvSpPr/>
-          <p:nvPr/>
-        </p:nvSpPr>
-        <p:spPr>
-          <a:xfrm>
-            <a:off x="4617720" y="3017520"/>
-            <a:ext cx="3291840" cy="0"/>
-          </a:xfrm>
-          <a:prstGeom prst="line">
-            <a:avLst/>
-          </a:prstGeom>
-          <a:noFill/>
+              <a:t>Tier 1 · Médico familiar</a:t>
+            </a:r>
+            <a:endParaRPr lang="en-US" sz="1000" dirty="0"/>
+          </a:p>
+        </p:txBody>
+      </p:sp>
+      <p:sp>
+        <p:nvSpPr>
+          <p:cNvPr id="19" name="Text 17"/>
+          <p:cNvSpPr/>
+          <p:nvPr/>
+        </p:nvSpPr>
+        <p:spPr>
+          <a:xfrm>
+            <a:off x="6400800" y="2103120"/>
+            <a:ext cx="5120640" cy="228600"/>
+          </a:xfrm>
+          <a:prstGeom prst="rect">
+            <a:avLst/>
+          </a:prstGeom>
+          <a:noFill/>
+          <a:ln/>
+        </p:spPr>
+        <p:txBody>
+          <a:bodyPr wrap="square" rtlCol="0" anchor="ctr"/>
+          <a:lstStyle/>
+          <a:p>
+            <a:pPr indent="0" marL="0">
+              <a:buNone/>
+            </a:pPr>
+            <a:r>
+              <a:rPr lang="en-US" sz="950" dirty="0">
+                <a:solidFill>
+                  <a:srgbClr val="4B5563"/>
+                </a:solidFill>
+                <a:latin typeface="Inter" pitchFamily="34" charset="0"/>
+                <a:ea typeface="Inter" pitchFamily="34" charset="-122"/>
+                <a:cs typeface="Inter" pitchFamily="34" charset="-120"/>
+              </a:rPr>
+              <a:t>Pacientes y cuidadores  ·  100K+ seguidores</a:t>
+            </a:r>
+            <a:endParaRPr lang="en-US" sz="950" dirty="0"/>
+          </a:p>
+        </p:txBody>
+      </p:sp>
+      <p:sp>
+        <p:nvSpPr>
+          <p:cNvPr id="20" name="Text 18"/>
+          <p:cNvSpPr/>
+          <p:nvPr/>
+        </p:nvSpPr>
+        <p:spPr>
+          <a:xfrm>
+            <a:off x="6400800" y="2331720"/>
+            <a:ext cx="5120640" cy="274320"/>
+          </a:xfrm>
+          <a:prstGeom prst="rect">
+            <a:avLst/>
+          </a:prstGeom>
+          <a:noFill/>
+          <a:ln/>
+        </p:spPr>
+        <p:txBody>
+          <a:bodyPr wrap="square" rtlCol="0" anchor="ctr"/>
+          <a:lstStyle/>
+          <a:p>
+            <a:pPr indent="0" marL="0">
+              <a:buNone/>
+            </a:pPr>
+            <a:r>
+              <a:rPr lang="en-US" sz="900" dirty="0">
+                <a:solidFill>
+                  <a:srgbClr val="2A2A2A"/>
+                </a:solidFill>
+                <a:latin typeface="Inter" pitchFamily="34" charset="0"/>
+                <a:ea typeface="Inter" pitchFamily="34" charset="-122"/>
+                <a:cs typeface="Inter" pitchFamily="34" charset="-120"/>
+              </a:rPr>
+              <a:t>2 Reels + 3 Stories/mes · Eje "Por qué la gastritis recurrente merece segunda opinión"</a:t>
+            </a:r>
+            <a:endParaRPr lang="en-US" sz="900" dirty="0"/>
+          </a:p>
+        </p:txBody>
+      </p:sp>
+      <p:sp>
+        <p:nvSpPr>
+          <p:cNvPr id="21" name="Shape 19"/>
+          <p:cNvSpPr/>
+          <p:nvPr/>
+        </p:nvSpPr>
+        <p:spPr>
+          <a:xfrm>
+            <a:off x="6400800" y="2615184"/>
+            <a:ext cx="5120640" cy="201168"/>
+          </a:xfrm>
+          <a:prstGeom prst="rect">
+            <a:avLst/>
+          </a:prstGeom>
+          <a:solidFill>
+            <a:srgbClr val="F0FAFA"/>
+          </a:solidFill>
           <a:ln w="12700">
             <a:solidFill>
-              <a:srgbClr val="E5E7EB"/>
+              <a:srgbClr val="F0FAFA"/>
             </a:solidFill>
             <a:prstDash val="solid"/>
           </a:ln>
@@ -6927,38 +6970,131 @@
       </p:sp>
       <p:sp>
         <p:nvSpPr>
-          <p:cNvPr id="21" name="Text 19"/>
-          <p:cNvSpPr/>
-          <p:nvPr/>
-        </p:nvSpPr>
-        <p:spPr>
-          <a:xfrm>
-            <a:off x="4617720" y="3108960"/>
-            <a:ext cx="3291840" cy="228600"/>
-          </a:xfrm>
-          <a:prstGeom prst="rect">
-            <a:avLst/>
-          </a:prstGeom>
-          <a:noFill/>
-          <a:ln/>
-        </p:spPr>
-        <p:txBody>
-          <a:bodyPr wrap="square" rtlCol="0" anchor="ctr"/>
-          <a:lstStyle/>
-          <a:p>
-            <a:pPr indent="0" marL="0">
-              <a:buNone/>
-            </a:pPr>
-            <a:r>
-              <a:rPr lang="en-US" sz="900" b="1" spc="200" kern="0" dirty="0">
-                <a:solidFill>
-                  <a:srgbClr val="4B5563"/>
+          <p:cNvPr id="22" name="Text 20"/>
+          <p:cNvSpPr/>
+          <p:nvPr/>
+        </p:nvSpPr>
+        <p:spPr>
+          <a:xfrm>
+            <a:off x="6400800" y="2615184"/>
+            <a:ext cx="5120640" cy="201168"/>
+          </a:xfrm>
+          <a:prstGeom prst="rect">
+            <a:avLst/>
+          </a:prstGeom>
+          <a:noFill/>
+          <a:ln/>
+        </p:spPr>
+        <p:txBody>
+          <a:bodyPr wrap="square" rtlCol="0" anchor="ctr"/>
+          <a:lstStyle/>
+          <a:p>
+            <a:pPr algn="ctr" indent="0" marL="0">
+              <a:buNone/>
+            </a:pPr>
+            <a:r>
+              <a:rPr lang="en-US" sz="950" b="1" dirty="0">
+                <a:solidFill>
+                  <a:srgbClr val="30B8B0"/>
                 </a:solidFill>
                 <a:latin typeface="Montserrat" pitchFamily="34" charset="0"/>
                 <a:ea typeface="Montserrat" pitchFamily="34" charset="-122"/>
                 <a:cs typeface="Montserrat" pitchFamily="34" charset="-120"/>
               </a:rPr>
-              <a:t>KOLs</a:t>
+              <a:t>$25,000 – $40,000 MXN / mes</a:t>
+            </a:r>
+            <a:endParaRPr lang="en-US" sz="950" dirty="0"/>
+          </a:p>
+        </p:txBody>
+      </p:sp>
+      <p:sp>
+        <p:nvSpPr>
+          <p:cNvPr id="23" name="Shape 21"/>
+          <p:cNvSpPr/>
+          <p:nvPr/>
+        </p:nvSpPr>
+        <p:spPr>
+          <a:xfrm>
+            <a:off x="548640" y="3017520"/>
+            <a:ext cx="5486400" cy="1508760"/>
+          </a:xfrm>
+          <a:prstGeom prst="roundRect">
+            <a:avLst>
+              <a:gd name="adj" fmla="val 6061"/>
+            </a:avLst>
+          </a:prstGeom>
+          <a:solidFill>
+            <a:srgbClr val="FFFFFF"/>
+          </a:solidFill>
+          <a:ln w="25400">
+            <a:solidFill>
+              <a:srgbClr val="30B8B0"/>
+            </a:solidFill>
+            <a:prstDash val="solid"/>
+          </a:ln>
+        </p:spPr>
+      </p:sp>
+      <p:sp>
+        <p:nvSpPr>
+          <p:cNvPr id="24" name="Shape 22"/>
+          <p:cNvSpPr/>
+          <p:nvPr/>
+        </p:nvSpPr>
+        <p:spPr>
+          <a:xfrm>
+            <a:off x="731520" y="3154680"/>
+            <a:ext cx="502920" cy="274320"/>
+          </a:xfrm>
+          <a:prstGeom prst="roundRect">
+            <a:avLst>
+              <a:gd name="adj" fmla="val 50000"/>
+            </a:avLst>
+          </a:prstGeom>
+          <a:solidFill>
+            <a:srgbClr val="30B8B0"/>
+          </a:solidFill>
+          <a:ln w="12700">
+            <a:solidFill>
+              <a:srgbClr val="30B8B0"/>
+            </a:solidFill>
+            <a:prstDash val="solid"/>
+          </a:ln>
+        </p:spPr>
+      </p:sp>
+      <p:sp>
+        <p:nvSpPr>
+          <p:cNvPr id="25" name="Text 23"/>
+          <p:cNvSpPr/>
+          <p:nvPr/>
+        </p:nvSpPr>
+        <p:spPr>
+          <a:xfrm>
+            <a:off x="731520" y="3154680"/>
+            <a:ext cx="502920" cy="274320"/>
+          </a:xfrm>
+          <a:prstGeom prst="rect">
+            <a:avLst/>
+          </a:prstGeom>
+          <a:noFill/>
+          <a:ln/>
+        </p:spPr>
+        <p:txBody>
+          <a:bodyPr wrap="square" rtlCol="0" anchor="ctr"/>
+          <a:lstStyle/>
+          <a:p>
+            <a:pPr algn="ctr" indent="0" marL="0">
+              <a:buNone/>
+            </a:pPr>
+            <a:r>
+              <a:rPr lang="en-US" sz="900" b="1" dirty="0">
+                <a:solidFill>
+                  <a:srgbClr val="FFFFFF"/>
+                </a:solidFill>
+                <a:latin typeface="Montserrat" pitchFamily="34" charset="0"/>
+                <a:ea typeface="Montserrat" pitchFamily="34" charset="-122"/>
+                <a:cs typeface="Montserrat" pitchFamily="34" charset="-120"/>
+              </a:rPr>
+              <a:t>T1</a:t>
             </a:r>
             <a:endParaRPr lang="en-US" sz="900" dirty="0"/>
           </a:p>
@@ -6966,152 +7102,238 @@
       </p:sp>
       <p:sp>
         <p:nvSpPr>
-          <p:cNvPr id="22" name="Text 20"/>
-          <p:cNvSpPr/>
-          <p:nvPr/>
-        </p:nvSpPr>
-        <p:spPr>
-          <a:xfrm>
-            <a:off x="4617720" y="3337560"/>
-            <a:ext cx="3291840" cy="1188720"/>
-          </a:xfrm>
-          <a:prstGeom prst="rect">
-            <a:avLst/>
-          </a:prstGeom>
-          <a:noFill/>
-          <a:ln/>
-        </p:spPr>
-        <p:txBody>
-          <a:bodyPr wrap="square" rtlCol="0" anchor="ctr"/>
-          <a:lstStyle/>
-          <a:p>
-            <a:pPr indent="0" marL="0">
-              <a:buNone/>
-            </a:pPr>
-            <a:r>
-              <a:rPr lang="en-US" sz="1100" dirty="0">
-                <a:solidFill>
-                  <a:srgbClr val="2A2A2A"/>
+          <p:cNvPr id="26" name="Text 24"/>
+          <p:cNvSpPr/>
+          <p:nvPr/>
+        </p:nvSpPr>
+        <p:spPr>
+          <a:xfrm>
+            <a:off x="1325880" y="3108960"/>
+            <a:ext cx="4572000" cy="365760"/>
+          </a:xfrm>
+          <a:prstGeom prst="rect">
+            <a:avLst/>
+          </a:prstGeom>
+          <a:noFill/>
+          <a:ln/>
+        </p:spPr>
+        <p:txBody>
+          <a:bodyPr wrap="square" rtlCol="0" anchor="ctr"/>
+          <a:lstStyle/>
+          <a:p>
+            <a:pPr indent="0" marL="0">
+              <a:buNone/>
+            </a:pPr>
+            <a:r>
+              <a:rPr lang="en-US" sz="1300" b="1" dirty="0">
+                <a:solidFill>
+                  <a:srgbClr val="183888"/>
+                </a:solidFill>
+                <a:latin typeface="Montserrat" pitchFamily="34" charset="0"/>
+                <a:ea typeface="Montserrat" pitchFamily="34" charset="-122"/>
+                <a:cs typeface="Montserrat" pitchFamily="34" charset="-120"/>
+              </a:rPr>
+              <a:t>@pologuerrero.med</a:t>
+            </a:r>
+            <a:endParaRPr lang="en-US" sz="1300" dirty="0"/>
+          </a:p>
+        </p:txBody>
+      </p:sp>
+      <p:sp>
+        <p:nvSpPr>
+          <p:cNvPr id="27" name="Text 25"/>
+          <p:cNvSpPr/>
+          <p:nvPr/>
+        </p:nvSpPr>
+        <p:spPr>
+          <a:xfrm>
+            <a:off x="1325880" y="3429000"/>
+            <a:ext cx="4572000" cy="274320"/>
+          </a:xfrm>
+          <a:prstGeom prst="rect">
+            <a:avLst/>
+          </a:prstGeom>
+          <a:noFill/>
+          <a:ln/>
+        </p:spPr>
+        <p:txBody>
+          <a:bodyPr wrap="square" rtlCol="0" anchor="ctr"/>
+          <a:lstStyle/>
+          <a:p>
+            <a:pPr indent="0" marL="0">
+              <a:buNone/>
+            </a:pPr>
+            <a:r>
+              <a:rPr lang="en-US" sz="1000" i="1" dirty="0">
+                <a:solidFill>
+                  <a:srgbClr val="30B8B0"/>
                 </a:solidFill>
                 <a:latin typeface="Inter" pitchFamily="34" charset="0"/>
                 <a:ea typeface="Inter" pitchFamily="34" charset="-122"/>
                 <a:cs typeface="Inter" pitchFamily="34" charset="-120"/>
               </a:rPr>
-              <a:t>Figura tipo Dr. Vic · Dra. Isa Zapata</a:t>
-            </a:r>
-            <a:endParaRPr lang="en-US" sz="1100" dirty="0"/>
-          </a:p>
-          <a:p>
-            <a:pPr indent="0" marL="0">
-              <a:buNone/>
-            </a:pPr>
-            <a:r>
-              <a:rPr lang="en-US" sz="1100" dirty="0">
-                <a:solidFill>
-                  <a:srgbClr val="2A2A2A"/>
+              <a:t>Tier 1 · Médico humor y trend</a:t>
+            </a:r>
+            <a:endParaRPr lang="en-US" sz="1000" dirty="0"/>
+          </a:p>
+        </p:txBody>
+      </p:sp>
+      <p:sp>
+        <p:nvSpPr>
+          <p:cNvPr id="28" name="Text 26"/>
+          <p:cNvSpPr/>
+          <p:nvPr/>
+        </p:nvSpPr>
+        <p:spPr>
+          <a:xfrm>
+            <a:off x="731520" y="3749040"/>
+            <a:ext cx="5120640" cy="228600"/>
+          </a:xfrm>
+          <a:prstGeom prst="rect">
+            <a:avLst/>
+          </a:prstGeom>
+          <a:noFill/>
+          <a:ln/>
+        </p:spPr>
+        <p:txBody>
+          <a:bodyPr wrap="square" rtlCol="0" anchor="ctr"/>
+          <a:lstStyle/>
+          <a:p>
+            <a:pPr indent="0" marL="0">
+              <a:buNone/>
+            </a:pPr>
+            <a:r>
+              <a:rPr lang="en-US" sz="950" dirty="0">
+                <a:solidFill>
+                  <a:srgbClr val="4B5563"/>
                 </a:solidFill>
                 <a:latin typeface="Inter" pitchFamily="34" charset="0"/>
                 <a:ea typeface="Inter" pitchFamily="34" charset="-122"/>
                 <a:cs typeface="Inter" pitchFamily="34" charset="-120"/>
               </a:rPr>
-              <a:t>(en reclutamiento)</a:t>
-            </a:r>
-            <a:endParaRPr lang="en-US" sz="1100" dirty="0"/>
-          </a:p>
-        </p:txBody>
-      </p:sp>
-      <p:sp>
-        <p:nvSpPr>
-          <p:cNvPr id="23" name="Text 21"/>
-          <p:cNvSpPr/>
-          <p:nvPr/>
-        </p:nvSpPr>
-        <p:spPr>
-          <a:xfrm>
-            <a:off x="4617720" y="4709160"/>
-            <a:ext cx="3291840" cy="228600"/>
-          </a:xfrm>
-          <a:prstGeom prst="rect">
-            <a:avLst/>
-          </a:prstGeom>
-          <a:noFill/>
-          <a:ln/>
-        </p:spPr>
-        <p:txBody>
-          <a:bodyPr wrap="square" rtlCol="0" anchor="ctr"/>
-          <a:lstStyle/>
-          <a:p>
-            <a:pPr indent="0" marL="0">
-              <a:buNone/>
-            </a:pPr>
-            <a:r>
-              <a:rPr lang="en-US" sz="900" b="1" spc="200" kern="0" dirty="0">
-                <a:solidFill>
-                  <a:srgbClr val="4B5563"/>
+              <a:t>Adultos 25-40 preventivos  ·  80K+ seguidores</a:t>
+            </a:r>
+            <a:endParaRPr lang="en-US" sz="950" dirty="0"/>
+          </a:p>
+        </p:txBody>
+      </p:sp>
+      <p:sp>
+        <p:nvSpPr>
+          <p:cNvPr id="29" name="Text 27"/>
+          <p:cNvSpPr/>
+          <p:nvPr/>
+        </p:nvSpPr>
+        <p:spPr>
+          <a:xfrm>
+            <a:off x="731520" y="3977640"/>
+            <a:ext cx="5120640" cy="274320"/>
+          </a:xfrm>
+          <a:prstGeom prst="rect">
+            <a:avLst/>
+          </a:prstGeom>
+          <a:noFill/>
+          <a:ln/>
+        </p:spPr>
+        <p:txBody>
+          <a:bodyPr wrap="square" rtlCol="0" anchor="ctr"/>
+          <a:lstStyle/>
+          <a:p>
+            <a:pPr indent="0" marL="0">
+              <a:buNone/>
+            </a:pPr>
+            <a:r>
+              <a:rPr lang="en-US" sz="900" dirty="0">
+                <a:solidFill>
+                  <a:srgbClr val="2A2A2A"/>
+                </a:solidFill>
+                <a:latin typeface="Inter" pitchFamily="34" charset="0"/>
+                <a:ea typeface="Inter" pitchFamily="34" charset="-122"/>
+                <a:cs typeface="Inter" pitchFamily="34" charset="-120"/>
+              </a:rPr>
+              <a:t>2 TikToks + 2 Reels/mes · Gancho "7 de cada 10 mexicanos la tienen"</a:t>
+            </a:r>
+            <a:endParaRPr lang="en-US" sz="900" dirty="0"/>
+          </a:p>
+        </p:txBody>
+      </p:sp>
+      <p:sp>
+        <p:nvSpPr>
+          <p:cNvPr id="30" name="Shape 28"/>
+          <p:cNvSpPr/>
+          <p:nvPr/>
+        </p:nvSpPr>
+        <p:spPr>
+          <a:xfrm>
+            <a:off x="731520" y="4261104"/>
+            <a:ext cx="5120640" cy="201168"/>
+          </a:xfrm>
+          <a:prstGeom prst="rect">
+            <a:avLst/>
+          </a:prstGeom>
+          <a:solidFill>
+            <a:srgbClr val="F0FAFA"/>
+          </a:solidFill>
+          <a:ln w="12700">
+            <a:solidFill>
+              <a:srgbClr val="F0FAFA"/>
+            </a:solidFill>
+            <a:prstDash val="solid"/>
+          </a:ln>
+        </p:spPr>
+      </p:sp>
+      <p:sp>
+        <p:nvSpPr>
+          <p:cNvPr id="31" name="Text 29"/>
+          <p:cNvSpPr/>
+          <p:nvPr/>
+        </p:nvSpPr>
+        <p:spPr>
+          <a:xfrm>
+            <a:off x="731520" y="4261104"/>
+            <a:ext cx="5120640" cy="201168"/>
+          </a:xfrm>
+          <a:prstGeom prst="rect">
+            <a:avLst/>
+          </a:prstGeom>
+          <a:noFill/>
+          <a:ln/>
+        </p:spPr>
+        <p:txBody>
+          <a:bodyPr wrap="square" rtlCol="0" anchor="ctr"/>
+          <a:lstStyle/>
+          <a:p>
+            <a:pPr algn="ctr" indent="0" marL="0">
+              <a:buNone/>
+            </a:pPr>
+            <a:r>
+              <a:rPr lang="en-US" sz="950" b="1" dirty="0">
+                <a:solidFill>
+                  <a:srgbClr val="30B8B0"/>
                 </a:solidFill>
                 <a:latin typeface="Montserrat" pitchFamily="34" charset="0"/>
                 <a:ea typeface="Montserrat" pitchFamily="34" charset="-122"/>
                 <a:cs typeface="Montserrat" pitchFamily="34" charset="-120"/>
               </a:rPr>
-              <a:t>Audiencia promedio</a:t>
-            </a:r>
-            <a:endParaRPr lang="en-US" sz="900" dirty="0"/>
-          </a:p>
-        </p:txBody>
-      </p:sp>
-      <p:sp>
-        <p:nvSpPr>
-          <p:cNvPr id="24" name="Text 22"/>
-          <p:cNvSpPr/>
-          <p:nvPr/>
-        </p:nvSpPr>
-        <p:spPr>
-          <a:xfrm>
-            <a:off x="4617720" y="4937760"/>
-            <a:ext cx="3291840" cy="365760"/>
-          </a:xfrm>
-          <a:prstGeom prst="rect">
-            <a:avLst/>
-          </a:prstGeom>
-          <a:noFill/>
-          <a:ln/>
-        </p:spPr>
-        <p:txBody>
-          <a:bodyPr wrap="square" rtlCol="0" anchor="ctr"/>
-          <a:lstStyle/>
-          <a:p>
-            <a:pPr indent="0" marL="0">
-              <a:buNone/>
-            </a:pPr>
-            <a:r>
-              <a:rPr lang="en-US" sz="1500" b="1" dirty="0">
-                <a:solidFill>
-                  <a:srgbClr val="30B8B0"/>
-                </a:solidFill>
-                <a:latin typeface="Montserrat" pitchFamily="34" charset="0"/>
-                <a:ea typeface="Montserrat" pitchFamily="34" charset="-122"/>
-                <a:cs typeface="Montserrat" pitchFamily="34" charset="-120"/>
-              </a:rPr>
-              <a:t>Paciente 50-200k</a:t>
-            </a:r>
-            <a:endParaRPr lang="en-US" sz="1500" dirty="0"/>
-          </a:p>
-        </p:txBody>
-      </p:sp>
-      <p:sp>
-        <p:nvSpPr>
-          <p:cNvPr id="25" name="Shape 23"/>
-          <p:cNvSpPr/>
-          <p:nvPr/>
-        </p:nvSpPr>
-        <p:spPr>
-          <a:xfrm>
-            <a:off x="8321040" y="1554480"/>
-            <a:ext cx="3657600" cy="4114800"/>
+              <a:t>$20,000 – $35,000 MXN / mes</a:t>
+            </a:r>
+            <a:endParaRPr lang="en-US" sz="950" dirty="0"/>
+          </a:p>
+        </p:txBody>
+      </p:sp>
+      <p:sp>
+        <p:nvSpPr>
+          <p:cNvPr id="32" name="Shape 30"/>
+          <p:cNvSpPr/>
+          <p:nvPr/>
+        </p:nvSpPr>
+        <p:spPr>
+          <a:xfrm>
+            <a:off x="6217920" y="3017520"/>
+            <a:ext cx="5486400" cy="1508760"/>
           </a:xfrm>
           <a:prstGeom prst="roundRect">
             <a:avLst>
-              <a:gd name="adj" fmla="val 3750"/>
+              <a:gd name="adj" fmla="val 6061"/>
             </a:avLst>
           </a:prstGeom>
           <a:solidFill>
@@ -7127,18 +7349,18 @@
       </p:sp>
       <p:sp>
         <p:nvSpPr>
-          <p:cNvPr id="26" name="Shape 24"/>
-          <p:cNvSpPr/>
-          <p:nvPr/>
-        </p:nvSpPr>
-        <p:spPr>
-          <a:xfrm>
-            <a:off x="8503920" y="1737360"/>
-            <a:ext cx="1188720" cy="320040"/>
+          <p:cNvPr id="33" name="Shape 31"/>
+          <p:cNvSpPr/>
+          <p:nvPr/>
+        </p:nvSpPr>
+        <p:spPr>
+          <a:xfrm>
+            <a:off x="6400800" y="3154680"/>
+            <a:ext cx="502920" cy="274320"/>
           </a:xfrm>
           <a:prstGeom prst="roundRect">
             <a:avLst>
-              <a:gd name="adj" fmla="val 48571"/>
+              <a:gd name="adj" fmla="val 50000"/>
             </a:avLst>
           </a:prstGeom>
           <a:solidFill>
@@ -7154,14 +7376,14 @@
       </p:sp>
       <p:sp>
         <p:nvSpPr>
-          <p:cNvPr id="27" name="Text 25"/>
-          <p:cNvSpPr/>
-          <p:nvPr/>
-        </p:nvSpPr>
-        <p:spPr>
-          <a:xfrm>
-            <a:off x="8503920" y="1737360"/>
-            <a:ext cx="1188720" cy="320040"/>
+          <p:cNvPr id="34" name="Text 32"/>
+          <p:cNvSpPr/>
+          <p:nvPr/>
+        </p:nvSpPr>
+        <p:spPr>
+          <a:xfrm>
+            <a:off x="6400800" y="3154680"/>
+            <a:ext cx="502920" cy="274320"/>
           </a:xfrm>
           <a:prstGeom prst="rect">
             <a:avLst/>
@@ -7177,7 +7399,7 @@
               <a:buNone/>
             </a:pPr>
             <a:r>
-              <a:rPr lang="en-US" sz="1000" b="1" dirty="0">
+              <a:rPr lang="en-US" sz="900" b="1" dirty="0">
                 <a:solidFill>
                   <a:srgbClr val="FFFFFF"/>
                 </a:solidFill>
@@ -7185,38 +7407,38 @@
                 <a:ea typeface="Montserrat" pitchFamily="34" charset="-122"/>
                 <a:cs typeface="Montserrat" pitchFamily="34" charset="-120"/>
               </a:rPr>
-              <a:t>Tier 3</a:t>
-            </a:r>
-            <a:endParaRPr lang="en-US" sz="1000" dirty="0"/>
-          </a:p>
-        </p:txBody>
-      </p:sp>
-      <p:sp>
-        <p:nvSpPr>
-          <p:cNvPr id="28" name="Text 26"/>
-          <p:cNvSpPr/>
-          <p:nvPr/>
-        </p:nvSpPr>
-        <p:spPr>
-          <a:xfrm>
-            <a:off x="8503920" y="2194560"/>
-            <a:ext cx="3291840" cy="411480"/>
-          </a:xfrm>
-          <a:prstGeom prst="rect">
-            <a:avLst/>
-          </a:prstGeom>
-          <a:noFill/>
-          <a:ln/>
-        </p:spPr>
-        <p:txBody>
-          <a:bodyPr wrap="square" rtlCol="0" anchor="ctr"/>
-          <a:lstStyle/>
-          <a:p>
-            <a:pPr indent="0" marL="0">
-              <a:buNone/>
-            </a:pPr>
-            <a:r>
-              <a:rPr lang="en-US" sz="1800" b="1" dirty="0">
+              <a:t>T2</a:t>
+            </a:r>
+            <a:endParaRPr lang="en-US" sz="900" dirty="0"/>
+          </a:p>
+        </p:txBody>
+      </p:sp>
+      <p:sp>
+        <p:nvSpPr>
+          <p:cNvPr id="35" name="Text 33"/>
+          <p:cNvSpPr/>
+          <p:nvPr/>
+        </p:nvSpPr>
+        <p:spPr>
+          <a:xfrm>
+            <a:off x="6995160" y="3108960"/>
+            <a:ext cx="4572000" cy="365760"/>
+          </a:xfrm>
+          <a:prstGeom prst="rect">
+            <a:avLst/>
+          </a:prstGeom>
+          <a:noFill/>
+          <a:ln/>
+        </p:spPr>
+        <p:txBody>
+          <a:bodyPr wrap="square" rtlCol="0" anchor="ctr"/>
+          <a:lstStyle/>
+          <a:p>
+            <a:pPr indent="0" marL="0">
+              <a:buNone/>
+            </a:pPr>
+            <a:r>
+              <a:rPr lang="en-US" sz="1300" b="1" dirty="0">
                 <a:solidFill>
                   <a:srgbClr val="183888"/>
                 </a:solidFill>
@@ -7224,38 +7446,38 @@
                 <a:ea typeface="Montserrat" pitchFamily="34" charset="-122"/>
                 <a:cs typeface="Montserrat" pitchFamily="34" charset="-120"/>
               </a:rPr>
-              <a:t>Atención primaria</a:t>
-            </a:r>
-            <a:endParaRPr lang="en-US" sz="1800" dirty="0"/>
-          </a:p>
-        </p:txBody>
-      </p:sp>
-      <p:sp>
-        <p:nvSpPr>
-          <p:cNvPr id="29" name="Text 27"/>
-          <p:cNvSpPr/>
-          <p:nvPr/>
-        </p:nvSpPr>
-        <p:spPr>
-          <a:xfrm>
-            <a:off x="8503920" y="2606040"/>
-            <a:ext cx="3291840" cy="320040"/>
-          </a:xfrm>
-          <a:prstGeom prst="rect">
-            <a:avLst/>
-          </a:prstGeom>
-          <a:noFill/>
-          <a:ln/>
-        </p:spPr>
-        <p:txBody>
-          <a:bodyPr wrap="square" rtlCol="0" anchor="ctr"/>
-          <a:lstStyle/>
-          <a:p>
-            <a:pPr indent="0" marL="0">
-              <a:buNone/>
-            </a:pPr>
-            <a:r>
-              <a:rPr lang="en-US" sz="1100" i="1" dirty="0">
+              <a:t>@drasuarezgastro</a:t>
+            </a:r>
+            <a:endParaRPr lang="en-US" sz="1300" dirty="0"/>
+          </a:p>
+        </p:txBody>
+      </p:sp>
+      <p:sp>
+        <p:nvSpPr>
+          <p:cNvPr id="36" name="Text 34"/>
+          <p:cNvSpPr/>
+          <p:nvPr/>
+        </p:nvSpPr>
+        <p:spPr>
+          <a:xfrm>
+            <a:off x="6995160" y="3429000"/>
+            <a:ext cx="4572000" cy="274320"/>
+          </a:xfrm>
+          <a:prstGeom prst="rect">
+            <a:avLst/>
+          </a:prstGeom>
+          <a:noFill/>
+          <a:ln/>
+        </p:spPr>
+        <p:txBody>
+          <a:bodyPr wrap="square" rtlCol="0" anchor="ctr"/>
+          <a:lstStyle/>
+          <a:p>
+            <a:pPr indent="0" marL="0">
+              <a:buNone/>
+            </a:pPr>
+            <a:r>
+              <a:rPr lang="en-US" sz="1000" i="1" dirty="0">
                 <a:solidFill>
                   <a:srgbClr val="887028"/>
                 </a:solidFill>
@@ -7263,30 +7485,110 @@
                 <a:ea typeface="Inter" pitchFamily="34" charset="-122"/>
                 <a:cs typeface="Inter" pitchFamily="34" charset="-120"/>
               </a:rPr>
-              <a:t>Primer contacto</a:t>
-            </a:r>
-            <a:endParaRPr lang="en-US" sz="1100" dirty="0"/>
-          </a:p>
-        </p:txBody>
-      </p:sp>
-      <p:sp>
-        <p:nvSpPr>
-          <p:cNvPr id="30" name="Shape 28"/>
-          <p:cNvSpPr/>
-          <p:nvPr/>
-        </p:nvSpPr>
-        <p:spPr>
-          <a:xfrm>
-            <a:off x="8503920" y="3017520"/>
-            <a:ext cx="3291840" cy="0"/>
-          </a:xfrm>
-          <a:prstGeom prst="line">
-            <a:avLst/>
-          </a:prstGeom>
-          <a:noFill/>
+              <a:t>Tier 2 · Gastroenteróloga</a:t>
+            </a:r>
+            <a:endParaRPr lang="en-US" sz="1000" dirty="0"/>
+          </a:p>
+        </p:txBody>
+      </p:sp>
+      <p:sp>
+        <p:nvSpPr>
+          <p:cNvPr id="37" name="Text 35"/>
+          <p:cNvSpPr/>
+          <p:nvPr/>
+        </p:nvSpPr>
+        <p:spPr>
+          <a:xfrm>
+            <a:off x="6400800" y="3749040"/>
+            <a:ext cx="5120640" cy="228600"/>
+          </a:xfrm>
+          <a:prstGeom prst="rect">
+            <a:avLst/>
+          </a:prstGeom>
+          <a:noFill/>
+          <a:ln/>
+        </p:spPr>
+        <p:txBody>
+          <a:bodyPr wrap="square" rtlCol="0" anchor="ctr"/>
+          <a:lstStyle/>
+          <a:p>
+            <a:pPr indent="0" marL="0">
+              <a:buNone/>
+            </a:pPr>
+            <a:r>
+              <a:rPr lang="en-US" sz="950" dirty="0">
+                <a:solidFill>
+                  <a:srgbClr val="4B5563"/>
+                </a:solidFill>
+                <a:latin typeface="Inter" pitchFamily="34" charset="0"/>
+                <a:ea typeface="Inter" pitchFamily="34" charset="-122"/>
+                <a:cs typeface="Inter" pitchFamily="34" charset="-120"/>
+              </a:rPr>
+              <a:t>Pacientes GI + médicos generales  ·  30K – 60K seguidores</a:t>
+            </a:r>
+            <a:endParaRPr lang="en-US" sz="950" dirty="0"/>
+          </a:p>
+        </p:txBody>
+      </p:sp>
+      <p:sp>
+        <p:nvSpPr>
+          <p:cNvPr id="38" name="Text 36"/>
+          <p:cNvSpPr/>
+          <p:nvPr/>
+        </p:nvSpPr>
+        <p:spPr>
+          <a:xfrm>
+            <a:off x="6400800" y="3977640"/>
+            <a:ext cx="5120640" cy="274320"/>
+          </a:xfrm>
+          <a:prstGeom prst="rect">
+            <a:avLst/>
+          </a:prstGeom>
+          <a:noFill/>
+          <a:ln/>
+        </p:spPr>
+        <p:txBody>
+          <a:bodyPr wrap="square" rtlCol="0" anchor="ctr"/>
+          <a:lstStyle/>
+          <a:p>
+            <a:pPr indent="0" marL="0">
+              <a:buNone/>
+            </a:pPr>
+            <a:r>
+              <a:rPr lang="en-US" sz="900" dirty="0">
+                <a:solidFill>
+                  <a:srgbClr val="2A2A2A"/>
+                </a:solidFill>
+                <a:latin typeface="Inter" pitchFamily="34" charset="0"/>
+                <a:ea typeface="Inter" pitchFamily="34" charset="-122"/>
+                <a:cs typeface="Inter" pitchFamily="34" charset="-120"/>
+              </a:rPr>
+              <a:t>2 posts/mes (carrusel + Reel) · Eje "Lo que tu gastro quiere que sepas"</a:t>
+            </a:r>
+            <a:endParaRPr lang="en-US" sz="900" dirty="0"/>
+          </a:p>
+        </p:txBody>
+      </p:sp>
+      <p:sp>
+        <p:nvSpPr>
+          <p:cNvPr id="39" name="Shape 37"/>
+          <p:cNvSpPr/>
+          <p:nvPr/>
+        </p:nvSpPr>
+        <p:spPr>
+          <a:xfrm>
+            <a:off x="6400800" y="4261104"/>
+            <a:ext cx="5120640" cy="201168"/>
+          </a:xfrm>
+          <a:prstGeom prst="rect">
+            <a:avLst/>
+          </a:prstGeom>
+          <a:solidFill>
+            <a:srgbClr val="F0FAFA"/>
+          </a:solidFill>
           <a:ln w="12700">
             <a:solidFill>
-              <a:srgbClr val="E5E7EB"/>
+              <a:srgbClr val="F0FAFA"/>
             </a:solidFill>
             <a:prstDash val="solid"/>
           </a:ln>
@@ -7294,38 +7596,131 @@
       </p:sp>
       <p:sp>
         <p:nvSpPr>
-          <p:cNvPr id="31" name="Text 29"/>
-          <p:cNvSpPr/>
-          <p:nvPr/>
-        </p:nvSpPr>
-        <p:spPr>
-          <a:xfrm>
-            <a:off x="8503920" y="3108960"/>
-            <a:ext cx="3291840" cy="228600"/>
-          </a:xfrm>
-          <a:prstGeom prst="rect">
-            <a:avLst/>
-          </a:prstGeom>
-          <a:noFill/>
-          <a:ln/>
-        </p:spPr>
-        <p:txBody>
-          <a:bodyPr wrap="square" rtlCol="0" anchor="ctr"/>
-          <a:lstStyle/>
-          <a:p>
-            <a:pPr indent="0" marL="0">
-              <a:buNone/>
-            </a:pPr>
-            <a:r>
-              <a:rPr lang="en-US" sz="900" b="1" spc="200" kern="0" dirty="0">
-                <a:solidFill>
-                  <a:srgbClr val="4B5563"/>
+          <p:cNvPr id="40" name="Text 38"/>
+          <p:cNvSpPr/>
+          <p:nvPr/>
+        </p:nvSpPr>
+        <p:spPr>
+          <a:xfrm>
+            <a:off x="6400800" y="4261104"/>
+            <a:ext cx="5120640" cy="201168"/>
+          </a:xfrm>
+          <a:prstGeom prst="rect">
+            <a:avLst/>
+          </a:prstGeom>
+          <a:noFill/>
+          <a:ln/>
+        </p:spPr>
+        <p:txBody>
+          <a:bodyPr wrap="square" rtlCol="0" anchor="ctr"/>
+          <a:lstStyle/>
+          <a:p>
+            <a:pPr algn="ctr" indent="0" marL="0">
+              <a:buNone/>
+            </a:pPr>
+            <a:r>
+              <a:rPr lang="en-US" sz="950" b="1" dirty="0">
+                <a:solidFill>
+                  <a:srgbClr val="887028"/>
                 </a:solidFill>
                 <a:latin typeface="Montserrat" pitchFamily="34" charset="0"/>
                 <a:ea typeface="Montserrat" pitchFamily="34" charset="-122"/>
                 <a:cs typeface="Montserrat" pitchFamily="34" charset="-120"/>
               </a:rPr>
-              <a:t>KOLs</a:t>
+              <a:t>$10,000 – $18,000 MXN / mes</a:t>
+            </a:r>
+            <a:endParaRPr lang="en-US" sz="950" dirty="0"/>
+          </a:p>
+        </p:txBody>
+      </p:sp>
+      <p:sp>
+        <p:nvSpPr>
+          <p:cNvPr id="41" name="Shape 39"/>
+          <p:cNvSpPr/>
+          <p:nvPr/>
+        </p:nvSpPr>
+        <p:spPr>
+          <a:xfrm>
+            <a:off x="548640" y="4663440"/>
+            <a:ext cx="5486400" cy="1508760"/>
+          </a:xfrm>
+          <a:prstGeom prst="roundRect">
+            <a:avLst>
+              <a:gd name="adj" fmla="val 6061"/>
+            </a:avLst>
+          </a:prstGeom>
+          <a:solidFill>
+            <a:srgbClr val="FFFFFF"/>
+          </a:solidFill>
+          <a:ln w="25400">
+            <a:solidFill>
+              <a:srgbClr val="887028"/>
+            </a:solidFill>
+            <a:prstDash val="solid"/>
+          </a:ln>
+        </p:spPr>
+      </p:sp>
+      <p:sp>
+        <p:nvSpPr>
+          <p:cNvPr id="42" name="Shape 40"/>
+          <p:cNvSpPr/>
+          <p:nvPr/>
+        </p:nvSpPr>
+        <p:spPr>
+          <a:xfrm>
+            <a:off x="731520" y="4800600"/>
+            <a:ext cx="502920" cy="274320"/>
+          </a:xfrm>
+          <a:prstGeom prst="roundRect">
+            <a:avLst>
+              <a:gd name="adj" fmla="val 50000"/>
+            </a:avLst>
+          </a:prstGeom>
+          <a:solidFill>
+            <a:srgbClr val="887028"/>
+          </a:solidFill>
+          <a:ln w="12700">
+            <a:solidFill>
+              <a:srgbClr val="887028"/>
+            </a:solidFill>
+            <a:prstDash val="solid"/>
+          </a:ln>
+        </p:spPr>
+      </p:sp>
+      <p:sp>
+        <p:nvSpPr>
+          <p:cNvPr id="43" name="Text 41"/>
+          <p:cNvSpPr/>
+          <p:nvPr/>
+        </p:nvSpPr>
+        <p:spPr>
+          <a:xfrm>
+            <a:off x="731520" y="4800600"/>
+            <a:ext cx="502920" cy="274320"/>
+          </a:xfrm>
+          <a:prstGeom prst="rect">
+            <a:avLst/>
+          </a:prstGeom>
+          <a:noFill/>
+          <a:ln/>
+        </p:spPr>
+        <p:txBody>
+          <a:bodyPr wrap="square" rtlCol="0" anchor="ctr"/>
+          <a:lstStyle/>
+          <a:p>
+            <a:pPr algn="ctr" indent="0" marL="0">
+              <a:buNone/>
+            </a:pPr>
+            <a:r>
+              <a:rPr lang="en-US" sz="900" b="1" dirty="0">
+                <a:solidFill>
+                  <a:srgbClr val="FFFFFF"/>
+                </a:solidFill>
+                <a:latin typeface="Montserrat" pitchFamily="34" charset="0"/>
+                <a:ea typeface="Montserrat" pitchFamily="34" charset="-122"/>
+                <a:cs typeface="Montserrat" pitchFamily="34" charset="-120"/>
+              </a:rPr>
+              <a:t>T3</a:t>
             </a:r>
             <a:endParaRPr lang="en-US" sz="900" dirty="0"/>
           </a:p>
@@ -7333,210 +7728,636 @@
       </p:sp>
       <p:sp>
         <p:nvSpPr>
-          <p:cNvPr id="32" name="Text 30"/>
-          <p:cNvSpPr/>
-          <p:nvPr/>
-        </p:nvSpPr>
-        <p:spPr>
-          <a:xfrm>
-            <a:off x="8503920" y="3337560"/>
-            <a:ext cx="3291840" cy="1188720"/>
-          </a:xfrm>
-          <a:prstGeom prst="rect">
-            <a:avLst/>
-          </a:prstGeom>
-          <a:noFill/>
-          <a:ln/>
-        </p:spPr>
-        <p:txBody>
-          <a:bodyPr wrap="square" rtlCol="0" anchor="ctr"/>
-          <a:lstStyle/>
-          <a:p>
-            <a:pPr indent="0" marL="0">
-              <a:buNone/>
-            </a:pPr>
-            <a:r>
-              <a:rPr lang="en-US" sz="1100" dirty="0">
-                <a:solidFill>
-                  <a:srgbClr val="2A2A2A"/>
+          <p:cNvPr id="44" name="Text 42"/>
+          <p:cNvSpPr/>
+          <p:nvPr/>
+        </p:nvSpPr>
+        <p:spPr>
+          <a:xfrm>
+            <a:off x="1325880" y="4754880"/>
+            <a:ext cx="4572000" cy="365760"/>
+          </a:xfrm>
+          <a:prstGeom prst="rect">
+            <a:avLst/>
+          </a:prstGeom>
+          <a:noFill/>
+          <a:ln/>
+        </p:spPr>
+        <p:txBody>
+          <a:bodyPr wrap="square" rtlCol="0" anchor="ctr"/>
+          <a:lstStyle/>
+          <a:p>
+            <a:pPr indent="0" marL="0">
+              <a:buNone/>
+            </a:pPr>
+            <a:r>
+              <a:rPr lang="en-US" sz="1300" b="1" dirty="0">
+                <a:solidFill>
+                  <a:srgbClr val="183888"/>
+                </a:solidFill>
+                <a:latin typeface="Montserrat" pitchFamily="34" charset="0"/>
+                <a:ea typeface="Montserrat" pitchFamily="34" charset="-122"/>
+                <a:cs typeface="Montserrat" pitchFamily="34" charset="-120"/>
+              </a:rPr>
+              <a:t>@doclaurasalazar</a:t>
+            </a:r>
+            <a:endParaRPr lang="en-US" sz="1300" dirty="0"/>
+          </a:p>
+        </p:txBody>
+      </p:sp>
+      <p:sp>
+        <p:nvSpPr>
+          <p:cNvPr id="45" name="Text 43"/>
+          <p:cNvSpPr/>
+          <p:nvPr/>
+        </p:nvSpPr>
+        <p:spPr>
+          <a:xfrm>
+            <a:off x="1325880" y="5074920"/>
+            <a:ext cx="4572000" cy="274320"/>
+          </a:xfrm>
+          <a:prstGeom prst="rect">
+            <a:avLst/>
+          </a:prstGeom>
+          <a:noFill/>
+          <a:ln/>
+        </p:spPr>
+        <p:txBody>
+          <a:bodyPr wrap="square" rtlCol="0" anchor="ctr"/>
+          <a:lstStyle/>
+          <a:p>
+            <a:pPr indent="0" marL="0">
+              <a:buNone/>
+            </a:pPr>
+            <a:r>
+              <a:rPr lang="en-US" sz="1000" i="1" dirty="0">
+                <a:solidFill>
+                  <a:srgbClr val="887028"/>
                 </a:solidFill>
                 <a:latin typeface="Inter" pitchFamily="34" charset="0"/>
                 <a:ea typeface="Inter" pitchFamily="34" charset="-122"/>
                 <a:cs typeface="Inter" pitchFamily="34" charset="-120"/>
               </a:rPr>
-              <a:t>Enfermeras divulgadoras + médicos de primer contacto</a:t>
-            </a:r>
-            <a:endParaRPr lang="en-US" sz="1100" dirty="0"/>
-          </a:p>
-          <a:p>
-            <a:pPr indent="0" marL="0">
-              <a:buNone/>
-            </a:pPr>
-            <a:r>
-              <a:rPr lang="en-US" sz="1100" dirty="0">
-                <a:solidFill>
-                  <a:srgbClr val="2A2A2A"/>
+              <a:t>Tier 3 · Salud preventiva</a:t>
+            </a:r>
+            <a:endParaRPr lang="en-US" sz="1000" dirty="0"/>
+          </a:p>
+        </p:txBody>
+      </p:sp>
+      <p:sp>
+        <p:nvSpPr>
+          <p:cNvPr id="46" name="Text 44"/>
+          <p:cNvSpPr/>
+          <p:nvPr/>
+        </p:nvSpPr>
+        <p:spPr>
+          <a:xfrm>
+            <a:off x="731520" y="5394960"/>
+            <a:ext cx="5120640" cy="228600"/>
+          </a:xfrm>
+          <a:prstGeom prst="rect">
+            <a:avLst/>
+          </a:prstGeom>
+          <a:noFill/>
+          <a:ln/>
+        </p:spPr>
+        <p:txBody>
+          <a:bodyPr wrap="square" rtlCol="0" anchor="ctr"/>
+          <a:lstStyle/>
+          <a:p>
+            <a:pPr indent="0" marL="0">
+              <a:buNone/>
+            </a:pPr>
+            <a:r>
+              <a:rPr lang="en-US" sz="950" dirty="0">
+                <a:solidFill>
+                  <a:srgbClr val="4B5563"/>
                 </a:solidFill>
                 <a:latin typeface="Inter" pitchFamily="34" charset="0"/>
                 <a:ea typeface="Inter" pitchFamily="34" charset="-122"/>
                 <a:cs typeface="Inter" pitchFamily="34" charset="-120"/>
               </a:rPr>
-              <a:t>(en reclutamiento)</a:t>
-            </a:r>
-            <a:endParaRPr lang="en-US" sz="1100" dirty="0"/>
-          </a:p>
-        </p:txBody>
-      </p:sp>
-      <p:sp>
-        <p:nvSpPr>
-          <p:cNvPr id="33" name="Text 31"/>
-          <p:cNvSpPr/>
-          <p:nvPr/>
-        </p:nvSpPr>
-        <p:spPr>
-          <a:xfrm>
-            <a:off x="8503920" y="4709160"/>
-            <a:ext cx="3291840" cy="228600"/>
-          </a:xfrm>
-          <a:prstGeom prst="rect">
-            <a:avLst/>
-          </a:prstGeom>
-          <a:noFill/>
-          <a:ln/>
-        </p:spPr>
-        <p:txBody>
-          <a:bodyPr wrap="square" rtlCol="0" anchor="ctr"/>
-          <a:lstStyle/>
-          <a:p>
-            <a:pPr indent="0" marL="0">
-              <a:buNone/>
-            </a:pPr>
-            <a:r>
-              <a:rPr lang="en-US" sz="900" b="1" spc="200" kern="0" dirty="0">
-                <a:solidFill>
-                  <a:srgbClr val="4B5563"/>
+              <a:t>Mujeres 30-50, salud familiar  ·  15K – 30K seguidores</a:t>
+            </a:r>
+            <a:endParaRPr lang="en-US" sz="950" dirty="0"/>
+          </a:p>
+        </p:txBody>
+      </p:sp>
+      <p:sp>
+        <p:nvSpPr>
+          <p:cNvPr id="47" name="Text 45"/>
+          <p:cNvSpPr/>
+          <p:nvPr/>
+        </p:nvSpPr>
+        <p:spPr>
+          <a:xfrm>
+            <a:off x="731520" y="5623560"/>
+            <a:ext cx="5120640" cy="274320"/>
+          </a:xfrm>
+          <a:prstGeom prst="rect">
+            <a:avLst/>
+          </a:prstGeom>
+          <a:noFill/>
+          <a:ln/>
+        </p:spPr>
+        <p:txBody>
+          <a:bodyPr wrap="square" rtlCol="0" anchor="ctr"/>
+          <a:lstStyle/>
+          <a:p>
+            <a:pPr indent="0" marL="0">
+              <a:buNone/>
+            </a:pPr>
+            <a:r>
+              <a:rPr lang="en-US" sz="900" dirty="0">
+                <a:solidFill>
+                  <a:srgbClr val="2A2A2A"/>
+                </a:solidFill>
+                <a:latin typeface="Inter" pitchFamily="34" charset="0"/>
+                <a:ea typeface="Inter" pitchFamily="34" charset="-122"/>
+                <a:cs typeface="Inter" pitchFamily="34" charset="-120"/>
+              </a:rPr>
+              <a:t>3 Stories + 1 Reel/mes · Eje "La bacteria que pasa de mamá a hijos"</a:t>
+            </a:r>
+            <a:endParaRPr lang="en-US" sz="900" dirty="0"/>
+          </a:p>
+        </p:txBody>
+      </p:sp>
+      <p:sp>
+        <p:nvSpPr>
+          <p:cNvPr id="48" name="Shape 46"/>
+          <p:cNvSpPr/>
+          <p:nvPr/>
+        </p:nvSpPr>
+        <p:spPr>
+          <a:xfrm>
+            <a:off x="731520" y="5907024"/>
+            <a:ext cx="5120640" cy="201168"/>
+          </a:xfrm>
+          <a:prstGeom prst="rect">
+            <a:avLst/>
+          </a:prstGeom>
+          <a:solidFill>
+            <a:srgbClr val="F0FAFA"/>
+          </a:solidFill>
+          <a:ln w="12700">
+            <a:solidFill>
+              <a:srgbClr val="F0FAFA"/>
+            </a:solidFill>
+            <a:prstDash val="solid"/>
+          </a:ln>
+        </p:spPr>
+      </p:sp>
+      <p:sp>
+        <p:nvSpPr>
+          <p:cNvPr id="49" name="Text 47"/>
+          <p:cNvSpPr/>
+          <p:nvPr/>
+        </p:nvSpPr>
+        <p:spPr>
+          <a:xfrm>
+            <a:off x="731520" y="5907024"/>
+            <a:ext cx="5120640" cy="201168"/>
+          </a:xfrm>
+          <a:prstGeom prst="rect">
+            <a:avLst/>
+          </a:prstGeom>
+          <a:noFill/>
+          <a:ln/>
+        </p:spPr>
+        <p:txBody>
+          <a:bodyPr wrap="square" rtlCol="0" anchor="ctr"/>
+          <a:lstStyle/>
+          <a:p>
+            <a:pPr algn="ctr" indent="0" marL="0">
+              <a:buNone/>
+            </a:pPr>
+            <a:r>
+              <a:rPr lang="en-US" sz="950" b="1" dirty="0">
+                <a:solidFill>
+                  <a:srgbClr val="887028"/>
                 </a:solidFill>
                 <a:latin typeface="Montserrat" pitchFamily="34" charset="0"/>
                 <a:ea typeface="Montserrat" pitchFamily="34" charset="-122"/>
                 <a:cs typeface="Montserrat" pitchFamily="34" charset="-120"/>
               </a:rPr>
-              <a:t>Audiencia promedio</a:t>
-            </a:r>
-            <a:endParaRPr lang="en-US" sz="900" dirty="0"/>
-          </a:p>
-        </p:txBody>
-      </p:sp>
-      <p:sp>
-        <p:nvSpPr>
-          <p:cNvPr id="34" name="Text 32"/>
-          <p:cNvSpPr/>
-          <p:nvPr/>
-        </p:nvSpPr>
-        <p:spPr>
-          <a:xfrm>
-            <a:off x="8503920" y="4937760"/>
-            <a:ext cx="3291840" cy="365760"/>
-          </a:xfrm>
-          <a:prstGeom prst="rect">
-            <a:avLst/>
-          </a:prstGeom>
-          <a:noFill/>
-          <a:ln/>
-        </p:spPr>
-        <p:txBody>
-          <a:bodyPr wrap="square" rtlCol="0" anchor="ctr"/>
-          <a:lstStyle/>
-          <a:p>
-            <a:pPr indent="0" marL="0">
-              <a:buNone/>
-            </a:pPr>
-            <a:r>
-              <a:rPr lang="en-US" sz="1500" b="1" dirty="0">
-                <a:solidFill>
-                  <a:srgbClr val="887028"/>
+              <a:t>$5,000 – $10,000 MXN / mes</a:t>
+            </a:r>
+            <a:endParaRPr lang="en-US" sz="950" dirty="0"/>
+          </a:p>
+        </p:txBody>
+      </p:sp>
+      <p:sp>
+        <p:nvSpPr>
+          <p:cNvPr id="50" name="Shape 48"/>
+          <p:cNvSpPr/>
+          <p:nvPr/>
+        </p:nvSpPr>
+        <p:spPr>
+          <a:xfrm>
+            <a:off x="6217920" y="4663440"/>
+            <a:ext cx="5486400" cy="1508760"/>
+          </a:xfrm>
+          <a:prstGeom prst="roundRect">
+            <a:avLst>
+              <a:gd name="adj" fmla="val 6061"/>
+            </a:avLst>
+          </a:prstGeom>
+          <a:solidFill>
+            <a:srgbClr val="FFFFFF"/>
+          </a:solidFill>
+          <a:ln w="25400">
+            <a:solidFill>
+              <a:srgbClr val="887028"/>
+            </a:solidFill>
+            <a:prstDash val="solid"/>
+          </a:ln>
+        </p:spPr>
+      </p:sp>
+      <p:sp>
+        <p:nvSpPr>
+          <p:cNvPr id="51" name="Shape 49"/>
+          <p:cNvSpPr/>
+          <p:nvPr/>
+        </p:nvSpPr>
+        <p:spPr>
+          <a:xfrm>
+            <a:off x="6400800" y="4800600"/>
+            <a:ext cx="502920" cy="274320"/>
+          </a:xfrm>
+          <a:prstGeom prst="roundRect">
+            <a:avLst>
+              <a:gd name="adj" fmla="val 50000"/>
+            </a:avLst>
+          </a:prstGeom>
+          <a:solidFill>
+            <a:srgbClr val="887028"/>
+          </a:solidFill>
+          <a:ln w="12700">
+            <a:solidFill>
+              <a:srgbClr val="887028"/>
+            </a:solidFill>
+            <a:prstDash val="solid"/>
+          </a:ln>
+        </p:spPr>
+      </p:sp>
+      <p:sp>
+        <p:nvSpPr>
+          <p:cNvPr id="52" name="Text 50"/>
+          <p:cNvSpPr/>
+          <p:nvPr/>
+        </p:nvSpPr>
+        <p:spPr>
+          <a:xfrm>
+            <a:off x="6400800" y="4800600"/>
+            <a:ext cx="502920" cy="274320"/>
+          </a:xfrm>
+          <a:prstGeom prst="rect">
+            <a:avLst/>
+          </a:prstGeom>
+          <a:noFill/>
+          <a:ln/>
+        </p:spPr>
+        <p:txBody>
+          <a:bodyPr wrap="square" rtlCol="0" anchor="ctr"/>
+          <a:lstStyle/>
+          <a:p>
+            <a:pPr algn="ctr" indent="0" marL="0">
+              <a:buNone/>
+            </a:pPr>
+            <a:r>
+              <a:rPr lang="en-US" sz="900" b="1" dirty="0">
+                <a:solidFill>
+                  <a:srgbClr val="FFFFFF"/>
                 </a:solidFill>
                 <a:latin typeface="Montserrat" pitchFamily="34" charset="0"/>
                 <a:ea typeface="Montserrat" pitchFamily="34" charset="-122"/>
                 <a:cs typeface="Montserrat" pitchFamily="34" charset="-120"/>
               </a:rPr>
-              <a:t>Femenino 30-80k</a:t>
-            </a:r>
-            <a:endParaRPr lang="en-US" sz="1500" dirty="0"/>
-          </a:p>
-        </p:txBody>
-      </p:sp>
-      <p:sp>
-        <p:nvSpPr>
-          <p:cNvPr id="35" name="Text 33"/>
-          <p:cNvSpPr/>
-          <p:nvPr/>
-        </p:nvSpPr>
-        <p:spPr>
-          <a:xfrm>
-            <a:off x="548640" y="5943600"/>
-            <a:ext cx="11064240" cy="457200"/>
-          </a:xfrm>
-          <a:prstGeom prst="rect">
-            <a:avLst/>
-          </a:prstGeom>
-          <a:noFill/>
-          <a:ln/>
-        </p:spPr>
-        <p:txBody>
-          <a:bodyPr wrap="square" rtlCol="0" anchor="ctr"/>
-          <a:lstStyle/>
-          <a:p>
-            <a:pPr algn="ctr" indent="0" marL="0">
-              <a:buNone/>
-            </a:pPr>
-            <a:r>
-              <a:rPr lang="en-US" sz="1300" b="1" i="1" dirty="0">
+              <a:t>T3</a:t>
+            </a:r>
+            <a:endParaRPr lang="en-US" sz="900" dirty="0"/>
+          </a:p>
+        </p:txBody>
+      </p:sp>
+      <p:sp>
+        <p:nvSpPr>
+          <p:cNvPr id="53" name="Text 51"/>
+          <p:cNvSpPr/>
+          <p:nvPr/>
+        </p:nvSpPr>
+        <p:spPr>
+          <a:xfrm>
+            <a:off x="6995160" y="4754880"/>
+            <a:ext cx="4572000" cy="365760"/>
+          </a:xfrm>
+          <a:prstGeom prst="rect">
+            <a:avLst/>
+          </a:prstGeom>
+          <a:noFill/>
+          <a:ln/>
+        </p:spPr>
+        <p:txBody>
+          <a:bodyPr wrap="square" rtlCol="0" anchor="ctr"/>
+          <a:lstStyle/>
+          <a:p>
+            <a:pPr indent="0" marL="0">
+              <a:buNone/>
+            </a:pPr>
+            <a:r>
+              <a:rPr lang="en-US" sz="1300" b="1" dirty="0">
                 <a:solidFill>
                   <a:srgbClr val="183888"/>
+                </a:solidFill>
+                <a:latin typeface="Montserrat" pitchFamily="34" charset="0"/>
+                <a:ea typeface="Montserrat" pitchFamily="34" charset="-122"/>
+                <a:cs typeface="Montserrat" pitchFamily="34" charset="-120"/>
+              </a:rPr>
+              <a:t>@doctorvic</a:t>
+            </a:r>
+            <a:endParaRPr lang="en-US" sz="1300" dirty="0"/>
+          </a:p>
+        </p:txBody>
+      </p:sp>
+      <p:sp>
+        <p:nvSpPr>
+          <p:cNvPr id="54" name="Text 52"/>
+          <p:cNvSpPr/>
+          <p:nvPr/>
+        </p:nvSpPr>
+        <p:spPr>
+          <a:xfrm>
+            <a:off x="6995160" y="5074920"/>
+            <a:ext cx="4572000" cy="274320"/>
+          </a:xfrm>
+          <a:prstGeom prst="rect">
+            <a:avLst/>
+          </a:prstGeom>
+          <a:noFill/>
+          <a:ln/>
+        </p:spPr>
+        <p:txBody>
+          <a:bodyPr wrap="square" rtlCol="0" anchor="ctr"/>
+          <a:lstStyle/>
+          <a:p>
+            <a:pPr indent="0" marL="0">
+              <a:buNone/>
+            </a:pPr>
+            <a:r>
+              <a:rPr lang="en-US" sz="1000" i="1" dirty="0">
+                <a:solidFill>
+                  <a:srgbClr val="887028"/>
                 </a:solidFill>
                 <a:latin typeface="Inter" pitchFamily="34" charset="0"/>
                 <a:ea typeface="Inter" pitchFamily="34" charset="-122"/>
                 <a:cs typeface="Inter" pitchFamily="34" charset="-120"/>
               </a:rPr>
-              <a:t>1 post de cuenta institucional = 1× alcance. 1 post del mismo KOL = 4× alcance + trust premium imposible de comprar.</a:t>
-            </a:r>
-            <a:endParaRPr lang="en-US" sz="1300" dirty="0"/>
-          </a:p>
-        </p:txBody>
-      </p:sp>
-      <p:sp>
-        <p:nvSpPr>
-          <p:cNvPr id="36" name="Text 34"/>
-          <p:cNvSpPr/>
-          <p:nvPr/>
-        </p:nvSpPr>
-        <p:spPr>
-          <a:xfrm>
-            <a:off x="548640" y="6446520"/>
-            <a:ext cx="8229600" cy="274320"/>
-          </a:xfrm>
-          <a:prstGeom prst="rect">
-            <a:avLst/>
-          </a:prstGeom>
-          <a:noFill/>
-          <a:ln/>
-        </p:spPr>
-        <p:txBody>
-          <a:bodyPr wrap="square" rtlCol="0" anchor="ctr"/>
-          <a:lstStyle/>
-          <a:p>
-            <a:pPr indent="0" marL="0">
-              <a:buNone/>
-            </a:pPr>
-            <a:r>
-              <a:rPr lang="en-US" sz="900" dirty="0">
-                <a:solidFill>
-                  <a:srgbClr val="9CA3AF"/>
+              <a:t>Tier 3 · Audiencia joven</a:t>
+            </a:r>
+            <a:endParaRPr lang="en-US" sz="1000" dirty="0"/>
+          </a:p>
+        </p:txBody>
+      </p:sp>
+      <p:sp>
+        <p:nvSpPr>
+          <p:cNvPr id="55" name="Text 53"/>
+          <p:cNvSpPr/>
+          <p:nvPr/>
+        </p:nvSpPr>
+        <p:spPr>
+          <a:xfrm>
+            <a:off x="6400800" y="5394960"/>
+            <a:ext cx="5120640" cy="228600"/>
+          </a:xfrm>
+          <a:prstGeom prst="rect">
+            <a:avLst/>
+          </a:prstGeom>
+          <a:noFill/>
+          <a:ln/>
+        </p:spPr>
+        <p:txBody>
+          <a:bodyPr wrap="square" rtlCol="0" anchor="ctr"/>
+          <a:lstStyle/>
+          <a:p>
+            <a:pPr indent="0" marL="0">
+              <a:buNone/>
+            </a:pPr>
+            <a:r>
+              <a:rPr lang="en-US" sz="950" dirty="0">
+                <a:solidFill>
+                  <a:srgbClr val="4B5563"/>
                 </a:solidFill>
                 <a:latin typeface="Inter" pitchFamily="34" charset="0"/>
                 <a:ea typeface="Inter" pitchFamily="34" charset="-122"/>
                 <a:cs typeface="Inter" pitchFamily="34" charset="-120"/>
               </a:rPr>
+              <a:t>Millennials + GenZ  ·  20K – 40K seguidores</a:t>
+            </a:r>
+            <a:endParaRPr lang="en-US" sz="950" dirty="0"/>
+          </a:p>
+        </p:txBody>
+      </p:sp>
+      <p:sp>
+        <p:nvSpPr>
+          <p:cNvPr id="56" name="Text 54"/>
+          <p:cNvSpPr/>
+          <p:nvPr/>
+        </p:nvSpPr>
+        <p:spPr>
+          <a:xfrm>
+            <a:off x="6400800" y="5623560"/>
+            <a:ext cx="5120640" cy="274320"/>
+          </a:xfrm>
+          <a:prstGeom prst="rect">
+            <a:avLst/>
+          </a:prstGeom>
+          <a:noFill/>
+          <a:ln/>
+        </p:spPr>
+        <p:txBody>
+          <a:bodyPr wrap="square" rtlCol="0" anchor="ctr"/>
+          <a:lstStyle/>
+          <a:p>
+            <a:pPr indent="0" marL="0">
+              <a:buNone/>
+            </a:pPr>
+            <a:r>
+              <a:rPr lang="en-US" sz="900" dirty="0">
+                <a:solidFill>
+                  <a:srgbClr val="2A2A2A"/>
+                </a:solidFill>
+                <a:latin typeface="Inter" pitchFamily="34" charset="0"/>
+                <a:ea typeface="Inter" pitchFamily="34" charset="-122"/>
+                <a:cs typeface="Inter" pitchFamily="34" charset="-120"/>
+              </a:rPr>
+              <a:t>2 TikToks/mes · Eje "La prueba de aliento que ni sabías que existe"</a:t>
+            </a:r>
+            <a:endParaRPr lang="en-US" sz="900" dirty="0"/>
+          </a:p>
+        </p:txBody>
+      </p:sp>
+      <p:sp>
+        <p:nvSpPr>
+          <p:cNvPr id="57" name="Shape 55"/>
+          <p:cNvSpPr/>
+          <p:nvPr/>
+        </p:nvSpPr>
+        <p:spPr>
+          <a:xfrm>
+            <a:off x="6400800" y="5907024"/>
+            <a:ext cx="5120640" cy="201168"/>
+          </a:xfrm>
+          <a:prstGeom prst="rect">
+            <a:avLst/>
+          </a:prstGeom>
+          <a:solidFill>
+            <a:srgbClr val="F0FAFA"/>
+          </a:solidFill>
+          <a:ln w="12700">
+            <a:solidFill>
+              <a:srgbClr val="F0FAFA"/>
+            </a:solidFill>
+            <a:prstDash val="solid"/>
+          </a:ln>
+        </p:spPr>
+      </p:sp>
+      <p:sp>
+        <p:nvSpPr>
+          <p:cNvPr id="58" name="Text 56"/>
+          <p:cNvSpPr/>
+          <p:nvPr/>
+        </p:nvSpPr>
+        <p:spPr>
+          <a:xfrm>
+            <a:off x="6400800" y="5907024"/>
+            <a:ext cx="5120640" cy="201168"/>
+          </a:xfrm>
+          <a:prstGeom prst="rect">
+            <a:avLst/>
+          </a:prstGeom>
+          <a:noFill/>
+          <a:ln/>
+        </p:spPr>
+        <p:txBody>
+          <a:bodyPr wrap="square" rtlCol="0" anchor="ctr"/>
+          <a:lstStyle/>
+          <a:p>
+            <a:pPr algn="ctr" indent="0" marL="0">
+              <a:buNone/>
+            </a:pPr>
+            <a:r>
+              <a:rPr lang="en-US" sz="950" b="1" dirty="0">
+                <a:solidFill>
+                  <a:srgbClr val="887028"/>
+                </a:solidFill>
+                <a:latin typeface="Montserrat" pitchFamily="34" charset="0"/>
+                <a:ea typeface="Montserrat" pitchFamily="34" charset="-122"/>
+                <a:cs typeface="Montserrat" pitchFamily="34" charset="-120"/>
+              </a:rPr>
+              <a:t>$5,000 – $8,000 MXN / mes</a:t>
+            </a:r>
+            <a:endParaRPr lang="en-US" sz="950" dirty="0"/>
+          </a:p>
+        </p:txBody>
+      </p:sp>
+      <p:sp>
+        <p:nvSpPr>
+          <p:cNvPr id="59" name="Shape 57"/>
+          <p:cNvSpPr/>
+          <p:nvPr/>
+        </p:nvSpPr>
+        <p:spPr>
+          <a:xfrm>
+            <a:off x="548640" y="6309360"/>
+            <a:ext cx="11064240" cy="274320"/>
+          </a:xfrm>
+          <a:prstGeom prst="roundRect">
+            <a:avLst>
+              <a:gd name="adj" fmla="val 16667"/>
+            </a:avLst>
+          </a:prstGeom>
+          <a:solidFill>
+            <a:srgbClr val="E8D9B0"/>
+          </a:solidFill>
+          <a:ln w="12700">
+            <a:solidFill>
+              <a:srgbClr val="887028"/>
+            </a:solidFill>
+            <a:prstDash val="solid"/>
+          </a:ln>
+        </p:spPr>
+      </p:sp>
+      <p:sp>
+        <p:nvSpPr>
+          <p:cNvPr id="60" name="Text 58"/>
+          <p:cNvSpPr/>
+          <p:nvPr/>
+        </p:nvSpPr>
+        <p:spPr>
+          <a:xfrm>
+            <a:off x="731520" y="6309360"/>
+            <a:ext cx="10789920" cy="274320"/>
+          </a:xfrm>
+          <a:prstGeom prst="rect">
+            <a:avLst/>
+          </a:prstGeom>
+          <a:noFill/>
+          <a:ln/>
+        </p:spPr>
+        <p:txBody>
+          <a:bodyPr wrap="square" rtlCol="0" anchor="ctr"/>
+          <a:lstStyle/>
+          <a:p>
+            <a:pPr indent="0" marL="0">
+              <a:buNone/>
+            </a:pPr>
+            <a:r>
+              <a:rPr lang="en-US" sz="1050" b="1" i="1" dirty="0">
+                <a:solidFill>
+                  <a:srgbClr val="183888"/>
+                </a:solidFill>
+                <a:latin typeface="Inter" pitchFamily="34" charset="0"/>
+                <a:ea typeface="Inter" pitchFamily="34" charset="-122"/>
+                <a:cs typeface="Inter" pitchFamily="34" charset="-120"/>
+              </a:rPr>
+              <a:t>Rango total pool influencers pagados: $65,000 – $111,000 MXN/mes · Los KOLs institucionales AMG (Valdovinos, Coss Adame, Noble) participan sin costo por convenio.</a:t>
+            </a:r>
+            <a:endParaRPr lang="en-US" sz="1050" dirty="0"/>
+          </a:p>
+        </p:txBody>
+      </p:sp>
+      <p:sp>
+        <p:nvSpPr>
+          <p:cNvPr id="61" name="Text 59"/>
+          <p:cNvSpPr/>
+          <p:nvPr/>
+        </p:nvSpPr>
+        <p:spPr>
+          <a:xfrm>
+            <a:off x="548640" y="6446520"/>
+            <a:ext cx="8229600" cy="274320"/>
+          </a:xfrm>
+          <a:prstGeom prst="rect">
+            <a:avLst/>
+          </a:prstGeom>
+          <a:noFill/>
+          <a:ln/>
+        </p:spPr>
+        <p:txBody>
+          <a:bodyPr wrap="square" rtlCol="0" anchor="ctr"/>
+          <a:lstStyle/>
+          <a:p>
+            <a:pPr indent="0" marL="0">
+              <a:buNone/>
+            </a:pPr>
+            <a:r>
+              <a:rPr lang="en-US" sz="900" dirty="0">
+                <a:solidFill>
+                  <a:srgbClr val="9CA3AF"/>
+                </a:solidFill>
+                <a:latin typeface="Inter" pitchFamily="34" charset="0"/>
+                <a:ea typeface="Inter" pitchFamily="34" charset="-122"/>
+                <a:cs typeface="Inter" pitchFamily="34" charset="-120"/>
+              </a:rPr>
               <a:t>Polar Multimedia · Sistema AMG 2026 · Confidencial Carnot/AMG</a:t>
             </a:r>
             <a:endParaRPr lang="en-US" sz="900" dirty="0"/>
@@ -7545,7 +8366,7 @@
       </p:sp>
       <p:sp>
         <p:nvSpPr>
-          <p:cNvPr id="37" name="Text 35"/>
+          <p:cNvPr id="62" name="Text 60"/>
           <p:cNvSpPr/>
           <p:nvPr/>
         </p:nvSpPr>
@@ -10337,7 +11158,7 @@
                 <a:ea typeface="Montserrat" pitchFamily="34" charset="-122"/>
                 <a:cs typeface="Montserrat" pitchFamily="34" charset="-120"/>
               </a:rPr>
-              <a:t>Mes prev. cáncer</a:t>
+              <a:t>Prevención y evidencia</a:t>
             </a:r>
             <a:endParaRPr lang="en-US" sz="1300" dirty="0"/>
           </a:p>
@@ -10376,7 +11197,7 @@
                 <a:ea typeface="Montserrat" pitchFamily="34" charset="-122"/>
                 <a:cs typeface="Montserrat" pitchFamily="34" charset="-120"/>
               </a:rPr>
-              <a:t>46%</a:t>
+              <a:t>&gt;90%</a:t>
             </a:r>
             <a:endParaRPr lang="en-US" sz="1400" dirty="0"/>
           </a:p>
@@ -10415,7 +11236,7 @@
                 <a:ea typeface="Montserrat" pitchFamily="34" charset="-122"/>
                 <a:cs typeface="Montserrat" pitchFamily="34" charset="-120"/>
               </a:rPr>
-              <a:t>reducción</a:t>
+              <a:t>curación</a:t>
             </a:r>
             <a:endParaRPr lang="en-US" sz="1400" dirty="0"/>
           </a:p>
@@ -10545,7 +11366,7 @@
                 <a:ea typeface="Montserrat" pitchFamily="34" charset="-122"/>
                 <a:cs typeface="Montserrat" pitchFamily="34" charset="-120"/>
               </a:rPr>
-              <a:t>Cierre y balance</a:t>
+              <a:t>Cierre y regalo de salud</a:t>
             </a:r>
             <a:endParaRPr lang="en-US" sz="1300" dirty="0"/>
           </a:p>
@@ -10584,7 +11405,7 @@
                 <a:ea typeface="Montserrat" pitchFamily="34" charset="-122"/>
                 <a:cs typeface="Montserrat" pitchFamily="34" charset="-120"/>
               </a:rPr>
-              <a:t>Reporte</a:t>
+              <a:t>Familia</a:t>
             </a:r>
             <a:endParaRPr lang="en-US" sz="1400" dirty="0"/>
           </a:p>
@@ -10623,7 +11444,7 @@
                 <a:ea typeface="Montserrat" pitchFamily="34" charset="-122"/>
                 <a:cs typeface="Montserrat" pitchFamily="34" charset="-120"/>
               </a:rPr>
-              <a:t>anual</a:t>
+              <a:t>Claridad</a:t>
             </a:r>
             <a:endParaRPr lang="en-US" sz="1400" dirty="0"/>
           </a:p>
@@ -10851,7 +11672,7 @@
         <p:spPr>
           <a:xfrm>
             <a:off x="548640" y="1554480"/>
-            <a:ext cx="2011680" cy="502920"/>
+            <a:ext cx="2103120" cy="502920"/>
           </a:xfrm>
           <a:prstGeom prst="rect">
             <a:avLst/>
@@ -10876,7 +11697,7 @@
         <p:spPr>
           <a:xfrm>
             <a:off x="621792" y="1554480"/>
-            <a:ext cx="2011680" cy="502920"/>
+            <a:ext cx="2103120" cy="502920"/>
           </a:xfrm>
           <a:prstGeom prst="rect">
             <a:avLst/>
@@ -10914,8 +11735,8 @@
         </p:nvSpPr>
         <p:spPr>
           <a:xfrm>
-            <a:off x="2560320" y="1554480"/>
-            <a:ext cx="2377440" cy="502920"/>
+            <a:off x="2651760" y="1554480"/>
+            <a:ext cx="2468880" cy="502920"/>
           </a:xfrm>
           <a:prstGeom prst="rect">
             <a:avLst/>
@@ -10939,8 +11760,8 @@
         </p:nvSpPr>
         <p:spPr>
           <a:xfrm>
-            <a:off x="2633472" y="1554480"/>
-            <a:ext cx="2377440" cy="502920"/>
+            <a:off x="2724912" y="1554480"/>
+            <a:ext cx="2468880" cy="502920"/>
           </a:xfrm>
           <a:prstGeom prst="rect">
             <a:avLst/>
@@ -10978,8 +11799,8 @@
         </p:nvSpPr>
         <p:spPr>
           <a:xfrm>
-            <a:off x="4937760" y="1554480"/>
-            <a:ext cx="2194560" cy="502920"/>
+            <a:off x="5120640" y="1554480"/>
+            <a:ext cx="2286000" cy="502920"/>
           </a:xfrm>
           <a:prstGeom prst="rect">
             <a:avLst/>
@@ -11003,8 +11824,8 @@
         </p:nvSpPr>
         <p:spPr>
           <a:xfrm>
-            <a:off x="5010912" y="1554480"/>
-            <a:ext cx="2194560" cy="502920"/>
+            <a:off x="5193792" y="1554480"/>
+            <a:ext cx="2286000" cy="502920"/>
           </a:xfrm>
           <a:prstGeom prst="rect">
             <a:avLst/>
@@ -11042,8 +11863,8 @@
         </p:nvSpPr>
         <p:spPr>
           <a:xfrm>
-            <a:off x="7132320" y="1554480"/>
-            <a:ext cx="2651760" cy="502920"/>
+            <a:off x="7406640" y="1554480"/>
+            <a:ext cx="2743200" cy="502920"/>
           </a:xfrm>
           <a:prstGeom prst="rect">
             <a:avLst/>
@@ -11067,8 +11888,8 @@
         </p:nvSpPr>
         <p:spPr>
           <a:xfrm>
-            <a:off x="7205472" y="1554480"/>
-            <a:ext cx="2651760" cy="502920"/>
+            <a:off x="7479792" y="1554480"/>
+            <a:ext cx="2743200" cy="502920"/>
           </a:xfrm>
           <a:prstGeom prst="rect">
             <a:avLst/>
@@ -11106,8 +11927,8 @@
         </p:nvSpPr>
         <p:spPr>
           <a:xfrm>
-            <a:off x="9784080" y="1554480"/>
-            <a:ext cx="1828800" cy="502920"/>
+            <a:off x="10149840" y="1554480"/>
+            <a:ext cx="1463040" cy="502920"/>
           </a:xfrm>
           <a:prstGeom prst="rect">
             <a:avLst/>
@@ -11131,8 +11952,8 @@
         </p:nvSpPr>
         <p:spPr>
           <a:xfrm>
-            <a:off x="9857232" y="1554480"/>
-            <a:ext cx="1828800" cy="502920"/>
+            <a:off x="10222992" y="1554480"/>
+            <a:ext cx="1463040" cy="502920"/>
           </a:xfrm>
           <a:prstGeom prst="rect">
             <a:avLst/>
@@ -11156,7 +11977,7 @@
                 <a:ea typeface="Montserrat" pitchFamily="34" charset="-122"/>
                 <a:cs typeface="Montserrat" pitchFamily="34" charset="-120"/>
               </a:rPr>
-              <a:t>Volumen/sem</a:t>
+              <a:t>Volumen/semana</a:t>
             </a:r>
             <a:endParaRPr lang="en-US" sz="1100" dirty="0"/>
           </a:p>
@@ -11171,7 +11992,7 @@
         <p:spPr>
           <a:xfrm>
             <a:off x="548640" y="2057400"/>
-            <a:ext cx="2011680" cy="548640"/>
+            <a:ext cx="2103120" cy="548640"/>
           </a:xfrm>
           <a:prstGeom prst="rect">
             <a:avLst/>
@@ -11196,7 +12017,7 @@
         <p:spPr>
           <a:xfrm>
             <a:off x="621792" y="2057400"/>
-            <a:ext cx="1920240" cy="548640"/>
+            <a:ext cx="2011680" cy="548640"/>
           </a:xfrm>
           <a:prstGeom prst="rect">
             <a:avLst/>
@@ -11234,8 +12055,8 @@
         </p:nvSpPr>
         <p:spPr>
           <a:xfrm>
-            <a:off x="2560320" y="2057400"/>
-            <a:ext cx="2377440" cy="548640"/>
+            <a:off x="2651760" y="2057400"/>
+            <a:ext cx="2468880" cy="548640"/>
           </a:xfrm>
           <a:prstGeom prst="rect">
             <a:avLst/>
@@ -11259,8 +12080,8 @@
         </p:nvSpPr>
         <p:spPr>
           <a:xfrm>
-            <a:off x="2633472" y="2057400"/>
-            <a:ext cx="2286000" cy="548640"/>
+            <a:off x="2724912" y="2057400"/>
+            <a:ext cx="2377440" cy="548640"/>
           </a:xfrm>
           <a:prstGeom prst="rect">
             <a:avLst/>
@@ -11298,8 +12119,8 @@
         </p:nvSpPr>
         <p:spPr>
           <a:xfrm>
-            <a:off x="4937760" y="2057400"/>
-            <a:ext cx="2194560" cy="548640"/>
+            <a:off x="5120640" y="2057400"/>
+            <a:ext cx="2286000" cy="548640"/>
           </a:xfrm>
           <a:prstGeom prst="rect">
             <a:avLst/>
@@ -11323,8 +12144,8 @@
         </p:nvSpPr>
         <p:spPr>
           <a:xfrm>
-            <a:off x="5010912" y="2057400"/>
-            <a:ext cx="2103120" cy="548640"/>
+            <a:off x="5193792" y="2057400"/>
+            <a:ext cx="2194560" cy="548640"/>
           </a:xfrm>
           <a:prstGeom prst="rect">
             <a:avLst/>
@@ -11362,8 +12183,8 @@
         </p:nvSpPr>
         <p:spPr>
           <a:xfrm>
-            <a:off x="7132320" y="2057400"/>
-            <a:ext cx="2651760" cy="548640"/>
+            <a:off x="7406640" y="2057400"/>
+            <a:ext cx="2743200" cy="548640"/>
           </a:xfrm>
           <a:prstGeom prst="rect">
             <a:avLst/>
@@ -11387,8 +12208,8 @@
         </p:nvSpPr>
         <p:spPr>
           <a:xfrm>
-            <a:off x="7205472" y="2057400"/>
-            <a:ext cx="2560320" cy="548640"/>
+            <a:off x="7479792" y="2057400"/>
+            <a:ext cx="2651760" cy="548640"/>
           </a:xfrm>
           <a:prstGeom prst="rect">
             <a:avLst/>
@@ -11426,8 +12247,8 @@
         </p:nvSpPr>
         <p:spPr>
           <a:xfrm>
-            <a:off x="9784080" y="2057400"/>
-            <a:ext cx="1828800" cy="548640"/>
+            <a:off x="10149840" y="2057400"/>
+            <a:ext cx="1463040" cy="548640"/>
           </a:xfrm>
           <a:prstGeom prst="rect">
             <a:avLst/>
@@ -11451,8 +12272,8 @@
         </p:nvSpPr>
         <p:spPr>
           <a:xfrm>
-            <a:off x="9857232" y="2057400"/>
-            <a:ext cx="1737360" cy="548640"/>
+            <a:off x="10222992" y="2057400"/>
+            <a:ext cx="1371600" cy="548640"/>
           </a:xfrm>
           <a:prstGeom prst="rect">
             <a:avLst/>
@@ -11491,7 +12312,7 @@
         <p:spPr>
           <a:xfrm>
             <a:off x="548640" y="2606040"/>
-            <a:ext cx="2011680" cy="548640"/>
+            <a:ext cx="2103120" cy="548640"/>
           </a:xfrm>
           <a:prstGeom prst="rect">
             <a:avLst/>
@@ -11516,7 +12337,7 @@
         <p:spPr>
           <a:xfrm>
             <a:off x="621792" y="2606040"/>
-            <a:ext cx="1920240" cy="548640"/>
+            <a:ext cx="2011680" cy="548640"/>
           </a:xfrm>
           <a:prstGeom prst="rect">
             <a:avLst/>
@@ -11554,8 +12375,8 @@
         </p:nvSpPr>
         <p:spPr>
           <a:xfrm>
-            <a:off x="2560320" y="2606040"/>
-            <a:ext cx="2377440" cy="548640"/>
+            <a:off x="2651760" y="2606040"/>
+            <a:ext cx="2468880" cy="548640"/>
           </a:xfrm>
           <a:prstGeom prst="rect">
             <a:avLst/>
@@ -11579,8 +12400,8 @@
         </p:nvSpPr>
         <p:spPr>
           <a:xfrm>
-            <a:off x="2633472" y="2606040"/>
-            <a:ext cx="2286000" cy="548640"/>
+            <a:off x="2724912" y="2606040"/>
+            <a:ext cx="2377440" cy="548640"/>
           </a:xfrm>
           <a:prstGeom prst="rect">
             <a:avLst/>
@@ -11618,8 +12439,8 @@
         </p:nvSpPr>
         <p:spPr>
           <a:xfrm>
-            <a:off x="4937760" y="2606040"/>
-            <a:ext cx="2194560" cy="548640"/>
+            <a:off x="5120640" y="2606040"/>
+            <a:ext cx="2286000" cy="548640"/>
           </a:xfrm>
           <a:prstGeom prst="rect">
             <a:avLst/>
@@ -11643,8 +12464,8 @@
         </p:nvSpPr>
         <p:spPr>
           <a:xfrm>
-            <a:off x="5010912" y="2606040"/>
-            <a:ext cx="2103120" cy="548640"/>
+            <a:off x="5193792" y="2606040"/>
+            <a:ext cx="2194560" cy="548640"/>
           </a:xfrm>
           <a:prstGeom prst="rect">
             <a:avLst/>
@@ -11682,8 +12503,8 @@
         </p:nvSpPr>
         <p:spPr>
           <a:xfrm>
-            <a:off x="7132320" y="2606040"/>
-            <a:ext cx="2651760" cy="548640"/>
+            <a:off x="7406640" y="2606040"/>
+            <a:ext cx="2743200" cy="548640"/>
           </a:xfrm>
           <a:prstGeom prst="rect">
             <a:avLst/>
@@ -11707,8 +12528,8 @@
         </p:nvSpPr>
         <p:spPr>
           <a:xfrm>
-            <a:off x="7205472" y="2606040"/>
-            <a:ext cx="2560320" cy="548640"/>
+            <a:off x="7479792" y="2606040"/>
+            <a:ext cx="2651760" cy="548640"/>
           </a:xfrm>
           <a:prstGeom prst="rect">
             <a:avLst/>
@@ -11746,8 +12567,8 @@
         </p:nvSpPr>
         <p:spPr>
           <a:xfrm>
-            <a:off x="9784080" y="2606040"/>
-            <a:ext cx="1828800" cy="548640"/>
+            <a:off x="10149840" y="2606040"/>
+            <a:ext cx="1463040" cy="548640"/>
           </a:xfrm>
           <a:prstGeom prst="rect">
             <a:avLst/>
@@ -11771,8 +12592,8 @@
         </p:nvSpPr>
         <p:spPr>
           <a:xfrm>
-            <a:off x="9857232" y="2606040"/>
-            <a:ext cx="1737360" cy="548640"/>
+            <a:off x="10222992" y="2606040"/>
+            <a:ext cx="1371600" cy="548640"/>
           </a:xfrm>
           <a:prstGeom prst="rect">
             <a:avLst/>
@@ -11811,7 +12632,7 @@
         <p:spPr>
           <a:xfrm>
             <a:off x="548640" y="3154680"/>
-            <a:ext cx="2011680" cy="548640"/>
+            <a:ext cx="2103120" cy="548640"/>
           </a:xfrm>
           <a:prstGeom prst="rect">
             <a:avLst/>
@@ -11836,7 +12657,7 @@
         <p:spPr>
           <a:xfrm>
             <a:off x="621792" y="3154680"/>
-            <a:ext cx="1920240" cy="548640"/>
+            <a:ext cx="2011680" cy="548640"/>
           </a:xfrm>
           <a:prstGeom prst="rect">
             <a:avLst/>
@@ -11874,8 +12695,8 @@
         </p:nvSpPr>
         <p:spPr>
           <a:xfrm>
-            <a:off x="2560320" y="3154680"/>
-            <a:ext cx="2377440" cy="548640"/>
+            <a:off x="2651760" y="3154680"/>
+            <a:ext cx="2468880" cy="548640"/>
           </a:xfrm>
           <a:prstGeom prst="rect">
             <a:avLst/>
@@ -11899,8 +12720,8 @@
         </p:nvSpPr>
         <p:spPr>
           <a:xfrm>
-            <a:off x="2633472" y="3154680"/>
-            <a:ext cx="2286000" cy="548640"/>
+            <a:off x="2724912" y="3154680"/>
+            <a:ext cx="2377440" cy="548640"/>
           </a:xfrm>
           <a:prstGeom prst="rect">
             <a:avLst/>
@@ -11938,8 +12759,8 @@
         </p:nvSpPr>
         <p:spPr>
           <a:xfrm>
-            <a:off x="4937760" y="3154680"/>
-            <a:ext cx="2194560" cy="548640"/>
+            <a:off x="5120640" y="3154680"/>
+            <a:ext cx="2286000" cy="548640"/>
           </a:xfrm>
           <a:prstGeom prst="rect">
             <a:avLst/>
@@ -11963,8 +12784,8 @@
         </p:nvSpPr>
         <p:spPr>
           <a:xfrm>
-            <a:off x="5010912" y="3154680"/>
-            <a:ext cx="2103120" cy="548640"/>
+            <a:off x="5193792" y="3154680"/>
+            <a:ext cx="2194560" cy="548640"/>
           </a:xfrm>
           <a:prstGeom prst="rect">
             <a:avLst/>
@@ -12002,8 +12823,8 @@
         </p:nvSpPr>
         <p:spPr>
           <a:xfrm>
-            <a:off x="7132320" y="3154680"/>
-            <a:ext cx="2651760" cy="548640"/>
+            <a:off x="7406640" y="3154680"/>
+            <a:ext cx="2743200" cy="548640"/>
           </a:xfrm>
           <a:prstGeom prst="rect">
             <a:avLst/>
@@ -12027,8 +12848,8 @@
         </p:nvSpPr>
         <p:spPr>
           <a:xfrm>
-            <a:off x="7205472" y="3154680"/>
-            <a:ext cx="2560320" cy="548640"/>
+            <a:off x="7479792" y="3154680"/>
+            <a:ext cx="2651760" cy="548640"/>
           </a:xfrm>
           <a:prstGeom prst="rect">
             <a:avLst/>
@@ -12066,8 +12887,8 @@
         </p:nvSpPr>
         <p:spPr>
           <a:xfrm>
-            <a:off x="9784080" y="3154680"/>
-            <a:ext cx="1828800" cy="548640"/>
+            <a:off x="10149840" y="3154680"/>
+            <a:ext cx="1463040" cy="548640"/>
           </a:xfrm>
           <a:prstGeom prst="rect">
             <a:avLst/>
@@ -12091,8 +12912,8 @@
         </p:nvSpPr>
         <p:spPr>
           <a:xfrm>
-            <a:off x="9857232" y="3154680"/>
-            <a:ext cx="1737360" cy="548640"/>
+            <a:off x="10222992" y="3154680"/>
+            <a:ext cx="1371600" cy="548640"/>
           </a:xfrm>
           <a:prstGeom prst="rect">
             <a:avLst/>
@@ -12131,7 +12952,7 @@
         <p:spPr>
           <a:xfrm>
             <a:off x="548640" y="3703320"/>
-            <a:ext cx="2011680" cy="548640"/>
+            <a:ext cx="2103120" cy="548640"/>
           </a:xfrm>
           <a:prstGeom prst="rect">
             <a:avLst/>
@@ -12156,7 +12977,7 @@
         <p:spPr>
           <a:xfrm>
             <a:off x="621792" y="3703320"/>
-            <a:ext cx="1920240" cy="548640"/>
+            <a:ext cx="2011680" cy="548640"/>
           </a:xfrm>
           <a:prstGeom prst="rect">
             <a:avLst/>
@@ -12194,8 +13015,8 @@
         </p:nvSpPr>
         <p:spPr>
           <a:xfrm>
-            <a:off x="2560320" y="3703320"/>
-            <a:ext cx="2377440" cy="548640"/>
+            <a:off x="2651760" y="3703320"/>
+            <a:ext cx="2468880" cy="548640"/>
           </a:xfrm>
           <a:prstGeom prst="rect">
             <a:avLst/>
@@ -12219,8 +13040,8 @@
         </p:nvSpPr>
         <p:spPr>
           <a:xfrm>
-            <a:off x="2633472" y="3703320"/>
-            <a:ext cx="2286000" cy="548640"/>
+            <a:off x="2724912" y="3703320"/>
+            <a:ext cx="2377440" cy="548640"/>
           </a:xfrm>
           <a:prstGeom prst="rect">
             <a:avLst/>
@@ -12258,8 +13079,8 @@
         </p:nvSpPr>
         <p:spPr>
           <a:xfrm>
-            <a:off x="4937760" y="3703320"/>
-            <a:ext cx="2194560" cy="548640"/>
+            <a:off x="5120640" y="3703320"/>
+            <a:ext cx="2286000" cy="548640"/>
           </a:xfrm>
           <a:prstGeom prst="rect">
             <a:avLst/>
@@ -12283,8 +13104,8 @@
         </p:nvSpPr>
         <p:spPr>
           <a:xfrm>
-            <a:off x="5010912" y="3703320"/>
-            <a:ext cx="2103120" cy="548640"/>
+            <a:off x="5193792" y="3703320"/>
+            <a:ext cx="2194560" cy="548640"/>
           </a:xfrm>
           <a:prstGeom prst="rect">
             <a:avLst/>
@@ -12322,8 +13143,8 @@
         </p:nvSpPr>
         <p:spPr>
           <a:xfrm>
-            <a:off x="7132320" y="3703320"/>
-            <a:ext cx="2651760" cy="548640"/>
+            <a:off x="7406640" y="3703320"/>
+            <a:ext cx="2743200" cy="548640"/>
           </a:xfrm>
           <a:prstGeom prst="rect">
             <a:avLst/>
@@ -12347,8 +13168,8 @@
         </p:nvSpPr>
         <p:spPr>
           <a:xfrm>
-            <a:off x="7205472" y="3703320"/>
-            <a:ext cx="2560320" cy="548640"/>
+            <a:off x="7479792" y="3703320"/>
+            <a:ext cx="2651760" cy="548640"/>
           </a:xfrm>
           <a:prstGeom prst="rect">
             <a:avLst/>
@@ -12386,8 +13207,8 @@
         </p:nvSpPr>
         <p:spPr>
           <a:xfrm>
-            <a:off x="9784080" y="3703320"/>
-            <a:ext cx="1828800" cy="548640"/>
+            <a:off x="10149840" y="3703320"/>
+            <a:ext cx="1463040" cy="548640"/>
           </a:xfrm>
           <a:prstGeom prst="rect">
             <a:avLst/>
@@ -12411,8 +13232,8 @@
         </p:nvSpPr>
         <p:spPr>
           <a:xfrm>
-            <a:off x="9857232" y="3703320"/>
-            <a:ext cx="1737360" cy="548640"/>
+            <a:off x="10222992" y="3703320"/>
+            <a:ext cx="1371600" cy="548640"/>
           </a:xfrm>
           <a:prstGeom prst="rect">
             <a:avLst/>
@@ -12451,7 +13272,7 @@
         <p:spPr>
           <a:xfrm>
             <a:off x="548640" y="4251960"/>
-            <a:ext cx="2011680" cy="548640"/>
+            <a:ext cx="2103120" cy="548640"/>
           </a:xfrm>
           <a:prstGeom prst="rect">
             <a:avLst/>
@@ -12476,7 +13297,7 @@
         <p:spPr>
           <a:xfrm>
             <a:off x="621792" y="4251960"/>
-            <a:ext cx="1920240" cy="548640"/>
+            <a:ext cx="2011680" cy="548640"/>
           </a:xfrm>
           <a:prstGeom prst="rect">
             <a:avLst/>
@@ -12514,8 +13335,8 @@
         </p:nvSpPr>
         <p:spPr>
           <a:xfrm>
-            <a:off x="2560320" y="4251960"/>
-            <a:ext cx="2377440" cy="548640"/>
+            <a:off x="2651760" y="4251960"/>
+            <a:ext cx="2468880" cy="548640"/>
           </a:xfrm>
           <a:prstGeom prst="rect">
             <a:avLst/>
@@ -12539,8 +13360,8 @@
         </p:nvSpPr>
         <p:spPr>
           <a:xfrm>
-            <a:off x="2633472" y="4251960"/>
-            <a:ext cx="2286000" cy="548640"/>
+            <a:off x="2724912" y="4251960"/>
+            <a:ext cx="2377440" cy="548640"/>
           </a:xfrm>
           <a:prstGeom prst="rect">
             <a:avLst/>
@@ -12578,8 +13399,8 @@
         </p:nvSpPr>
         <p:spPr>
           <a:xfrm>
-            <a:off x="4937760" y="4251960"/>
-            <a:ext cx="2194560" cy="548640"/>
+            <a:off x="5120640" y="4251960"/>
+            <a:ext cx="2286000" cy="548640"/>
           </a:xfrm>
           <a:prstGeom prst="rect">
             <a:avLst/>
@@ -12603,8 +13424,8 @@
         </p:nvSpPr>
         <p:spPr>
           <a:xfrm>
-            <a:off x="5010912" y="4251960"/>
-            <a:ext cx="2103120" cy="548640"/>
+            <a:off x="5193792" y="4251960"/>
+            <a:ext cx="2194560" cy="548640"/>
           </a:xfrm>
           <a:prstGeom prst="rect">
             <a:avLst/>
@@ -12642,8 +13463,8 @@
         </p:nvSpPr>
         <p:spPr>
           <a:xfrm>
-            <a:off x="7132320" y="4251960"/>
-            <a:ext cx="2651760" cy="548640"/>
+            <a:off x="7406640" y="4251960"/>
+            <a:ext cx="2743200" cy="548640"/>
           </a:xfrm>
           <a:prstGeom prst="rect">
             <a:avLst/>
@@ -12667,8 +13488,8 @@
         </p:nvSpPr>
         <p:spPr>
           <a:xfrm>
-            <a:off x="7205472" y="4251960"/>
-            <a:ext cx="2560320" cy="548640"/>
+            <a:off x="7479792" y="4251960"/>
+            <a:ext cx="2651760" cy="548640"/>
           </a:xfrm>
           <a:prstGeom prst="rect">
             <a:avLst/>
@@ -12706,8 +13527,8 @@
         </p:nvSpPr>
         <p:spPr>
           <a:xfrm>
-            <a:off x="9784080" y="4251960"/>
-            <a:ext cx="1828800" cy="548640"/>
+            <a:off x="10149840" y="4251960"/>
+            <a:ext cx="1463040" cy="548640"/>
           </a:xfrm>
           <a:prstGeom prst="rect">
             <a:avLst/>
@@ -12731,8 +13552,8 @@
         </p:nvSpPr>
         <p:spPr>
           <a:xfrm>
-            <a:off x="9857232" y="4251960"/>
-            <a:ext cx="1737360" cy="548640"/>
+            <a:off x="10222992" y="4251960"/>
+            <a:ext cx="1371600" cy="548640"/>
           </a:xfrm>
           <a:prstGeom prst="rect">
             <a:avLst/>
@@ -12820,7 +13641,7 @@
                 <a:ea typeface="Inter" pitchFamily="34" charset="-122"/>
                 <a:cs typeface="Inter" pitchFamily="34" charset="-120"/>
               </a:rPr>
-              <a:t>Total semana (ciclo activo): 19-22 piezas · 115-168k MXN/mes en pauta sugerida</a:t>
+              <a:t>Total semana (ciclo activo): 19-22 piezas publicadas en los 4 canales principales</a:t>
             </a:r>
             <a:endParaRPr lang="en-US" sz="1100" dirty="0"/>
           </a:p>
@@ -13868,7 +14689,7 @@
                 <a:ea typeface="Montserrat" pitchFamily="34" charset="-122"/>
                 <a:cs typeface="Montserrat" pitchFamily="34" charset="-120"/>
               </a:rPr>
-              <a:t>Presupuesto pauta</a:t>
+              <a:t>Capacidad de producción</a:t>
             </a:r>
             <a:endParaRPr lang="en-US" sz="1300" dirty="0"/>
           </a:p>
@@ -13907,7 +14728,7 @@
                 <a:ea typeface="Inter" pitchFamily="34" charset="-122"/>
                 <a:cs typeface="Inter" pitchFamily="34" charset="-120"/>
               </a:rPr>
-              <a:t>$ disponible por red</a:t>
+              <a:t>Pipeline creativo de la semana</a:t>
             </a:r>
             <a:endParaRPr lang="en-US" sz="1100" dirty="0"/>
           </a:p>
@@ -15524,7 +16345,7 @@
                 <a:ea typeface="Montserrat" pitchFamily="34" charset="-122"/>
                 <a:cs typeface="Montserrat" pitchFamily="34" charset="-120"/>
               </a:rPr>
-              <a:t>KOLs (5-8)</a:t>
+              <a:t>KOLs (6 pool)</a:t>
             </a:r>
             <a:endParaRPr lang="en-US" sz="1300" dirty="0"/>
           </a:p>
@@ -18146,7 +18967,7 @@
                 <a:ea typeface="Inter" pitchFamily="34" charset="-122"/>
                 <a:cs typeface="Inter" pitchFamily="34" charset="-120"/>
               </a:rPr>
-              <a:t>Dashboard gerencia 150 reps en tiempo real · KOLs Tier 2 y 3</a:t>
+              <a:t>Dashboard gerencia 150 reps en tiempo real · KOLs Tier 2 y 3 activados</a:t>
             </a:r>
             <a:endParaRPr lang="en-US" sz="1200" dirty="0"/>
           </a:p>
@@ -18720,7 +19541,7 @@
                 <a:ea typeface="Inter" pitchFamily="34" charset="-122"/>
                 <a:cs typeface="Inter" pitchFamily="34" charset="-120"/>
               </a:rPr>
-              <a:t>Confirmar roster final de KOLs Tier 1 · contratar Tier 2 en reclutamiento</a:t>
+              <a:t>Confirmar roster final de KOLs Tier 1 · contratar Tier 2 y 3 en reclutamiento</a:t>
             </a:r>
             <a:endParaRPr lang="en-US" sz="1200" dirty="0"/>
           </a:p>
@@ -18784,7 +19605,7 @@
                 <a:ea typeface="Inter" pitchFamily="34" charset="-122"/>
                 <a:cs typeface="Inter" pitchFamily="34" charset="-120"/>
               </a:rPr>
-              <a:t>Firmar transferencia repo a org polar-multimedia en GitHub</a:t>
+              <a:t>Revisión conjunta Polar-Carnot-AMG del piloto ciclo 1 al cierre de mayo</a:t>
             </a:r>
             <a:endParaRPr lang="en-US" sz="1200" dirty="0"/>
           </a:p>
@@ -18912,7 +19733,7 @@
                 <a:ea typeface="Inter" pitchFamily="34" charset="-122"/>
                 <a:cs typeface="Inter" pitchFamily="34" charset="-120"/>
               </a:rPr>
-              <a:t>Revisión conjunta Polar-Carnot-AMG del piloto ciclo 1 al cierre de mayo</a:t>
+              <a:t>Aprobación de ajustes Nov/Dic 2026 para tono familiar navideño</a:t>
             </a:r>
             <a:endParaRPr lang="en-US" sz="1200" dirty="0"/>
           </a:p>
@@ -21059,7 +21880,7 @@
                 <a:ea typeface="Inter" pitchFamily="34" charset="-122"/>
                 <a:cs typeface="Inter" pitchFamily="34" charset="-120"/>
               </a:rPr>
-              <a:t>gpt-image-1 + Nanobanana</a:t>
+              <a:t>gpt-image-1 (GPT Image 2)</a:t>
             </a:r>
             <a:endParaRPr lang="en-US" sz="1300" dirty="0"/>
           </a:p>
@@ -23970,7 +24791,7 @@
                 <a:ea typeface="Inter" pitchFamily="34" charset="-122"/>
                 <a:cs typeface="Inter" pitchFamily="34" charset="-120"/>
               </a:rPr>
-              <a:t>Pool de 5-8 influencers médicos</a:t>
+              <a:t>6 influencers médicos</a:t>
             </a:r>
             <a:endParaRPr lang="en-US" sz="1200" dirty="0"/>
           </a:p>

</xml_diff>

<commit_message>
Deploy AMG ecosystem · 2026-04-24 13:26
- Portal público (home, artículos, detección, para-médicos)
- Hub de revisión sistema_piezas_AMG_Hub.html con sidebar Dreamweaver
- Visita Médica PWA (visita-medica-amg/) — 3 ciclos + 4 interactivos offline
- Corpus visual HUB_AMG_PYLORI/ (brand_amg + brand_kicab)
- Documentos ejecutivos (.docx maestro, .xlsx métricas, .pptx pitch)

Firebase RTDB sync: polar-amg-hub-2026 (compartido entre hub y VM)
Org: polar-multimedia · github.com/polar-multimedia/amg-pylori-hub
</commit_message>
<xml_diff>
--- a/Pitch_Ejecutivo_AMG_2026.pptx
+++ b/Pitch_Ejecutivo_AMG_2026.pptx
@@ -2720,7 +2720,7 @@
               <a:buNone/>
             </a:pPr>
             <a:r>
-              <a:rPr lang="en-US" sz="1600" b="1" spc="800" kern="0" dirty="0">
+              <a:rPr lang="en-US" sz="1400" b="1" spc="600" kern="0" dirty="0">
                 <a:solidFill>
                   <a:srgbClr val="3DCEDD"/>
                 </a:solidFill>
@@ -2728,9 +2728,9 @@
                 <a:ea typeface="Montserrat" pitchFamily="34" charset="-122"/>
                 <a:cs typeface="Montserrat" pitchFamily="34" charset="-120"/>
               </a:rPr>
-              <a:t>SISTEMA AMG 2026</a:t>
-            </a:r>
-            <a:endParaRPr lang="en-US" sz="1600" dirty="0"/>
+              <a:t>SISTEMA AMG 2026 · COMUNIDAD DIGITAL APALANCADA</a:t>
+            </a:r>
+            <a:endParaRPr lang="en-US" sz="1400" dirty="0"/>
           </a:p>
         </p:txBody>
       </p:sp>
@@ -2762,7 +2762,7 @@
               <a:buNone/>
             </a:pPr>
             <a:r>
-              <a:rPr lang="en-US" sz="5600" b="1" dirty="0">
+              <a:rPr lang="en-US" sz="5200" b="1" dirty="0">
                 <a:solidFill>
                   <a:srgbClr val="FFFFFF"/>
                 </a:solidFill>
@@ -2770,9 +2770,9 @@
                 <a:ea typeface="Montserrat" pitchFamily="34" charset="-122"/>
                 <a:cs typeface="Montserrat" pitchFamily="34" charset="-120"/>
               </a:rPr>
-              <a:t>Ecosistema de comunicación</a:t>
-            </a:r>
-            <a:endParaRPr lang="en-US" sz="5600" dirty="0"/>
+              <a:t>Construir una comunidad</a:t>
+            </a:r>
+            <a:endParaRPr lang="en-US" sz="5200" dirty="0"/>
           </a:p>
           <a:p>
             <a:pPr indent="0" marL="0">
@@ -2782,7 +2782,7 @@
               <a:buNone/>
             </a:pPr>
             <a:r>
-              <a:rPr lang="en-US" sz="5600" b="1" dirty="0">
+              <a:rPr lang="en-US" sz="5200" b="1" dirty="0">
                 <a:solidFill>
                   <a:srgbClr val="FFFFFF"/>
                 </a:solidFill>
@@ -2790,9 +2790,9 @@
                 <a:ea typeface="Montserrat" pitchFamily="34" charset="-122"/>
                 <a:cs typeface="Montserrat" pitchFamily="34" charset="-120"/>
               </a:rPr>
-              <a:t>amplificado por IA</a:t>
-            </a:r>
-            <a:endParaRPr lang="en-US" sz="5600" dirty="0"/>
+              <a:t>permanente, no una campaña</a:t>
+            </a:r>
+            <a:endParaRPr lang="en-US" sz="5200" dirty="0"/>
           </a:p>
         </p:txBody>
       </p:sp>
@@ -2821,7 +2821,7 @@
               <a:buNone/>
             </a:pPr>
             <a:r>
-              <a:rPr lang="en-US" sz="1600" dirty="0">
+              <a:rPr lang="en-US" sz="1400" dirty="0">
                 <a:solidFill>
                   <a:srgbClr val="3DCEDD"/>
                 </a:solidFill>
@@ -2829,9 +2829,9 @@
                 <a:ea typeface="Inter" pitchFamily="34" charset="-122"/>
                 <a:cs typeface="Inter" pitchFamily="34" charset="-120"/>
               </a:rPr>
-              <a:t>México Sin Cáncer Gástrico · Carnot Ki-CAB · Aval AMG · Mayo–Diciembre 2026</a:t>
-            </a:r>
-            <a:endParaRPr lang="en-US" sz="1600" dirty="0"/>
+              <a:t>Portal avalado por AMG · Influencers médicos como motor · IA como amplificador · Mayo 2026 y los años que siguen</a:t>
+            </a:r>
+            <a:endParaRPr lang="en-US" sz="1400" dirty="0"/>
           </a:p>
         </p:txBody>
       </p:sp>
@@ -5207,7 +5207,7 @@
     <p:bg>
       <p:bgPr>
         <a:solidFill>
-          <a:srgbClr val="F5F7FA"/>
+          <a:srgbClr val="FFFFFF"/>
         </a:solidFill>
       </p:bgPr>
     </p:bg>
@@ -5283,7 +5283,7 @@
                 <a:ea typeface="Montserrat" pitchFamily="34" charset="-122"/>
                 <a:cs typeface="Montserrat" pitchFamily="34" charset="-120"/>
               </a:rPr>
-              <a:t>PORTAL PÚBLICO · PACIENTE Y MÉDICO</a:t>
+              <a:t>EL PORTAL · DESTINO CENTRAL DE LA COMUNIDAD</a:t>
             </a:r>
             <a:endParaRPr lang="en-US" sz="1100" dirty="0"/>
           </a:p>
@@ -5314,7 +5314,7 @@
               <a:buNone/>
             </a:pPr>
             <a:r>
-              <a:rPr lang="en-US" sz="3200" b="1" dirty="0">
+              <a:rPr lang="en-US" sz="2400" b="1" dirty="0">
                 <a:solidFill>
                   <a:srgbClr val="183888"/>
                 </a:solidFill>
@@ -5322,9 +5322,9 @@
                 <a:ea typeface="Montserrat" pitchFamily="34" charset="-122"/>
                 <a:cs typeface="Montserrat" pitchFamily="34" charset="-120"/>
               </a:rPr>
-              <a:t>mexicosincancergastrico.com.mx</a:t>
-            </a:r>
-            <a:endParaRPr lang="en-US" sz="3200" dirty="0"/>
+              <a:t>mexicosincancergastrico.com.mx no es campaña. Es asset permanente.</a:t>
+            </a:r>
+            <a:endParaRPr lang="en-US" sz="2400" dirty="0"/>
           </a:p>
         </p:txBody>
       </p:sp>
@@ -5336,185 +5336,18 @@
         </p:nvSpPr>
         <p:spPr>
           <a:xfrm>
-            <a:off x="548640" y="1463040"/>
-            <a:ext cx="5486400" cy="4572000"/>
+            <a:off x="548640" y="1371600"/>
+            <a:ext cx="11064240" cy="1005840"/>
           </a:xfrm>
           <a:prstGeom prst="roundRect">
             <a:avLst>
-              <a:gd name="adj" fmla="val 2000"/>
+              <a:gd name="adj" fmla="val 10909"/>
             </a:avLst>
           </a:prstGeom>
           <a:solidFill>
             <a:srgbClr val="0D2248"/>
           </a:solidFill>
-          <a:ln w="12700">
-            <a:solidFill>
-              <a:srgbClr val="0D2248"/>
-            </a:solidFill>
-            <a:prstDash val="solid"/>
-          </a:ln>
-        </p:spPr>
-      </p:sp>
-      <p:sp>
-        <p:nvSpPr>
-          <p:cNvPr id="6" name="Text 4"/>
-          <p:cNvSpPr/>
-          <p:nvPr/>
-        </p:nvSpPr>
-        <p:spPr>
-          <a:xfrm>
-            <a:off x="731520" y="1645920"/>
-            <a:ext cx="5120640" cy="365760"/>
-          </a:xfrm>
-          <a:prstGeom prst="rect">
-            <a:avLst/>
-          </a:prstGeom>
-          <a:noFill/>
-          <a:ln/>
-        </p:spPr>
-        <p:txBody>
-          <a:bodyPr wrap="square" rtlCol="0" anchor="ctr"/>
-          <a:lstStyle/>
-          <a:p>
-            <a:pPr indent="0" marL="0">
-              <a:buNone/>
-            </a:pPr>
-            <a:r>
-              <a:rPr lang="en-US" sz="1300" b="1" dirty="0">
-                <a:solidFill>
-                  <a:srgbClr val="3DCEDD"/>
-                </a:solidFill>
-                <a:latin typeface="Montserrat" pitchFamily="34" charset="0"/>
-                <a:ea typeface="Montserrat" pitchFamily="34" charset="-122"/>
-                <a:cs typeface="Montserrat" pitchFamily="34" charset="-120"/>
-              </a:rPr>
-              <a:t>Hero institucional</a:t>
-            </a:r>
-            <a:endParaRPr lang="en-US" sz="1300" dirty="0"/>
-          </a:p>
-        </p:txBody>
-      </p:sp>
-      <p:sp>
-        <p:nvSpPr>
-          <p:cNvPr id="7" name="Text 5"/>
-          <p:cNvSpPr/>
-          <p:nvPr/>
-        </p:nvSpPr>
-        <p:spPr>
-          <a:xfrm>
-            <a:off x="731520" y="2011680"/>
-            <a:ext cx="5120640" cy="1645920"/>
-          </a:xfrm>
-          <a:prstGeom prst="rect">
-            <a:avLst/>
-          </a:prstGeom>
-          <a:noFill/>
-          <a:ln/>
-        </p:spPr>
-        <p:txBody>
-          <a:bodyPr wrap="square" rtlCol="0" anchor="ctr"/>
-          <a:lstStyle/>
-          <a:p>
-            <a:pPr indent="0" marL="0">
-              <a:lnSpc>
-                <a:spcPct val="100000"/>
-              </a:lnSpc>
-              <a:buNone/>
-            </a:pPr>
-            <a:r>
-              <a:rPr lang="en-US" sz="3000" b="1" dirty="0">
-                <a:solidFill>
-                  <a:srgbClr val="FFFFFF"/>
-                </a:solidFill>
-                <a:latin typeface="Montserrat" pitchFamily="34" charset="0"/>
-                <a:ea typeface="Montserrat" pitchFamily="34" charset="-122"/>
-                <a:cs typeface="Montserrat" pitchFamily="34" charset="-120"/>
-              </a:rPr>
-              <a:t>¿Tu estómago tiene</a:t>
-            </a:r>
-            <a:endParaRPr lang="en-US" sz="3000" dirty="0"/>
-          </a:p>
-          <a:p>
-            <a:pPr indent="0" marL="0">
-              <a:lnSpc>
-                <a:spcPct val="100000"/>
-              </a:lnSpc>
-              <a:buNone/>
-            </a:pPr>
-            <a:r>
-              <a:rPr lang="en-US" sz="3000" b="1" dirty="0">
-                <a:solidFill>
-                  <a:srgbClr val="FFFFFF"/>
-                </a:solidFill>
-                <a:latin typeface="Montserrat" pitchFamily="34" charset="0"/>
-                <a:ea typeface="Montserrat" pitchFamily="34" charset="-122"/>
-                <a:cs typeface="Montserrat" pitchFamily="34" charset="-120"/>
-              </a:rPr>
-              <a:t>Helicobacter pylori?</a:t>
-            </a:r>
-            <a:endParaRPr lang="en-US" sz="3000" dirty="0"/>
-          </a:p>
-        </p:txBody>
-      </p:sp>
-      <p:sp>
-        <p:nvSpPr>
-          <p:cNvPr id="8" name="Text 6"/>
-          <p:cNvSpPr/>
-          <p:nvPr/>
-        </p:nvSpPr>
-        <p:spPr>
-          <a:xfrm>
-            <a:off x="731520" y="3840480"/>
-            <a:ext cx="5120640" cy="1188720"/>
-          </a:xfrm>
-          <a:prstGeom prst="rect">
-            <a:avLst/>
-          </a:prstGeom>
-          <a:noFill/>
-          <a:ln/>
-        </p:spPr>
-        <p:txBody>
-          <a:bodyPr wrap="square" rtlCol="0" anchor="ctr"/>
-          <a:lstStyle/>
-          <a:p>
-            <a:pPr indent="0" marL="0">
-              <a:buNone/>
-            </a:pPr>
-            <a:r>
-              <a:rPr lang="en-US" sz="1200" dirty="0">
-                <a:solidFill>
-                  <a:srgbClr val="D0DEFF"/>
-                </a:solidFill>
-                <a:latin typeface="Inter" pitchFamily="34" charset="0"/>
-                <a:ea typeface="Inter" pitchFamily="34" charset="-122"/>
-                <a:cs typeface="Inter" pitchFamily="34" charset="-120"/>
-              </a:rPr>
-              <a:t>7/10 mexicanos portan esta bacteria. 90% del cáncer gástrico inicia con ella. Una prueba de 20 minutos puede cambiarlo todo.</a:t>
-            </a:r>
-            <a:endParaRPr lang="en-US" sz="1200" dirty="0"/>
-          </a:p>
-        </p:txBody>
-      </p:sp>
-      <p:sp>
-        <p:nvSpPr>
-          <p:cNvPr id="9" name="Shape 7"/>
-          <p:cNvSpPr/>
-          <p:nvPr/>
-        </p:nvSpPr>
-        <p:spPr>
-          <a:xfrm>
-            <a:off x="731520" y="5212080"/>
-            <a:ext cx="2286000" cy="457200"/>
-          </a:xfrm>
-          <a:prstGeom prst="roundRect">
-            <a:avLst>
-              <a:gd name="adj" fmla="val 50000"/>
-            </a:avLst>
-          </a:prstGeom>
-          <a:solidFill>
-            <a:srgbClr val="30B8B0"/>
-          </a:solidFill>
-          <a:ln w="12700">
+          <a:ln w="25400">
             <a:solidFill>
               <a:srgbClr val="30B8B0"/>
             </a:solidFill>
@@ -5524,38 +5357,38 @@
       </p:sp>
       <p:sp>
         <p:nvSpPr>
-          <p:cNvPr id="10" name="Text 8"/>
-          <p:cNvSpPr/>
-          <p:nvPr/>
-        </p:nvSpPr>
-        <p:spPr>
-          <a:xfrm>
-            <a:off x="731520" y="5212080"/>
-            <a:ext cx="2286000" cy="457200"/>
-          </a:xfrm>
-          <a:prstGeom prst="rect">
-            <a:avLst/>
-          </a:prstGeom>
-          <a:noFill/>
-          <a:ln/>
-        </p:spPr>
-        <p:txBody>
-          <a:bodyPr wrap="square" rtlCol="0" anchor="ctr"/>
-          <a:lstStyle/>
-          <a:p>
-            <a:pPr algn="ctr" indent="0" marL="0">
-              <a:buNone/>
-            </a:pPr>
-            <a:r>
-              <a:rPr lang="en-US" sz="1300" b="1" dirty="0">
-                <a:solidFill>
-                  <a:srgbClr val="FFFFFF"/>
+          <p:cNvPr id="6" name="Text 4"/>
+          <p:cNvSpPr/>
+          <p:nvPr/>
+        </p:nvSpPr>
+        <p:spPr>
+          <a:xfrm>
+            <a:off x="777240" y="1463040"/>
+            <a:ext cx="10607040" cy="365760"/>
+          </a:xfrm>
+          <a:prstGeom prst="rect">
+            <a:avLst/>
+          </a:prstGeom>
+          <a:noFill/>
+          <a:ln/>
+        </p:spPr>
+        <p:txBody>
+          <a:bodyPr wrap="square" rtlCol="0" anchor="ctr"/>
+          <a:lstStyle/>
+          <a:p>
+            <a:pPr indent="0" marL="0">
+              <a:buNone/>
+            </a:pPr>
+            <a:r>
+              <a:rPr lang="en-US" sz="1300" b="1" spc="300" kern="0" dirty="0">
+                <a:solidFill>
+                  <a:srgbClr val="3DCEDD"/>
                 </a:solidFill>
                 <a:latin typeface="Montserrat" pitchFamily="34" charset="0"/>
                 <a:ea typeface="Montserrat" pitchFamily="34" charset="-122"/>
                 <a:cs typeface="Montserrat" pitchFamily="34" charset="-120"/>
               </a:rPr>
-              <a:t>Participa gratis</a:t>
+              <a:t>Todo el sistema lleva al mismo lugar</a:t>
             </a:r>
             <a:endParaRPr lang="en-US" sz="1300" dirty="0"/>
           </a:p>
@@ -5563,61 +5396,63 @@
       </p:sp>
       <p:sp>
         <p:nvSpPr>
-          <p:cNvPr id="11" name="Text 9"/>
-          <p:cNvSpPr/>
-          <p:nvPr/>
-        </p:nvSpPr>
-        <p:spPr>
-          <a:xfrm>
-            <a:off x="6400800" y="1554480"/>
-            <a:ext cx="5212080" cy="457200"/>
-          </a:xfrm>
-          <a:prstGeom prst="rect">
-            <a:avLst/>
-          </a:prstGeom>
-          <a:noFill/>
-          <a:ln/>
-        </p:spPr>
-        <p:txBody>
-          <a:bodyPr wrap="square" rtlCol="0" anchor="ctr"/>
-          <a:lstStyle/>
-          <a:p>
-            <a:pPr indent="0" marL="0">
-              <a:buNone/>
-            </a:pPr>
-            <a:r>
-              <a:rPr lang="en-US" sz="1700" b="1" dirty="0">
-                <a:solidFill>
-                  <a:srgbClr val="183888"/>
-                </a:solidFill>
-                <a:latin typeface="Montserrat" pitchFamily="34" charset="0"/>
-                <a:ea typeface="Montserrat" pitchFamily="34" charset="-122"/>
-                <a:cs typeface="Montserrat" pitchFamily="34" charset="-120"/>
-              </a:rPr>
-              <a:t>4 secciones navegables</a:t>
-            </a:r>
-            <a:endParaRPr lang="en-US" sz="1700" dirty="0"/>
-          </a:p>
-        </p:txBody>
-      </p:sp>
-      <p:sp>
-        <p:nvSpPr>
-          <p:cNvPr id="12" name="Shape 10"/>
-          <p:cNvSpPr/>
-          <p:nvPr/>
-        </p:nvSpPr>
-        <p:spPr>
-          <a:xfrm>
-            <a:off x="6400800" y="2286000"/>
-            <a:ext cx="457200" cy="457200"/>
-          </a:xfrm>
-          <a:prstGeom prst="ellipse">
-            <a:avLst/>
+          <p:cNvPr id="7" name="Text 5"/>
+          <p:cNvSpPr/>
+          <p:nvPr/>
+        </p:nvSpPr>
+        <p:spPr>
+          <a:xfrm>
+            <a:off x="777240" y="1874520"/>
+            <a:ext cx="10607040" cy="457200"/>
+          </a:xfrm>
+          <a:prstGeom prst="rect">
+            <a:avLst/>
+          </a:prstGeom>
+          <a:noFill/>
+          <a:ln/>
+        </p:spPr>
+        <p:txBody>
+          <a:bodyPr wrap="square" rtlCol="0" anchor="ctr"/>
+          <a:lstStyle/>
+          <a:p>
+            <a:pPr indent="0" marL="0">
+              <a:buNone/>
+            </a:pPr>
+            <a:r>
+              <a:rPr lang="en-US" sz="1100" i="1" dirty="0">
+                <a:solidFill>
+                  <a:srgbClr val="FFFFFF"/>
+                </a:solidFill>
+                <a:latin typeface="Inter" pitchFamily="34" charset="0"/>
+                <a:ea typeface="Inter" pitchFamily="34" charset="-122"/>
+                <a:cs typeface="Inter" pitchFamily="34" charset="-120"/>
+              </a:rPr>
+              <a:t>Redes sociales · Influencers · Fuerza de ventas · Materiales institucionales AMG — todos dirigen tráfico con UTM de atribución al portal, donde el visitante anónimo se convierte en usuario registrado y miembro recurrente de la comunidad.</a:t>
+            </a:r>
+            <a:endParaRPr lang="en-US" sz="1100" dirty="0"/>
+          </a:p>
+        </p:txBody>
+      </p:sp>
+      <p:sp>
+        <p:nvSpPr>
+          <p:cNvPr id="8" name="Shape 6"/>
+          <p:cNvSpPr/>
+          <p:nvPr/>
+        </p:nvSpPr>
+        <p:spPr>
+          <a:xfrm>
+            <a:off x="548640" y="2560320"/>
+            <a:ext cx="2697480" cy="1737360"/>
+          </a:xfrm>
+          <a:prstGeom prst="roundRect">
+            <a:avLst>
+              <a:gd name="adj" fmla="val 6316"/>
+            </a:avLst>
           </a:prstGeom>
           <a:solidFill>
-            <a:srgbClr val="30B8B0"/>
+            <a:srgbClr val="FFFFFF"/>
           </a:solidFill>
-          <a:ln w="12700">
+          <a:ln w="25400">
             <a:solidFill>
               <a:srgbClr val="30B8B0"/>
             </a:solidFill>
@@ -5627,14 +5462,14 @@
       </p:sp>
       <p:sp>
         <p:nvSpPr>
-          <p:cNvPr id="13" name="Text 11"/>
-          <p:cNvSpPr/>
-          <p:nvPr/>
-        </p:nvSpPr>
-        <p:spPr>
-          <a:xfrm>
-            <a:off x="6400800" y="2286000"/>
-            <a:ext cx="457200" cy="457200"/>
+          <p:cNvPr id="9" name="Text 7"/>
+          <p:cNvSpPr/>
+          <p:nvPr/>
+        </p:nvSpPr>
+        <p:spPr>
+          <a:xfrm>
+            <a:off x="548640" y="2651760"/>
+            <a:ext cx="2697480" cy="914400"/>
           </a:xfrm>
           <a:prstGeom prst="rect">
             <a:avLst/>
@@ -5650,46 +5485,129 @@
               <a:buNone/>
             </a:pPr>
             <a:r>
-              <a:rPr lang="en-US" sz="1800" b="1" dirty="0">
-                <a:solidFill>
-                  <a:srgbClr val="FFFFFF"/>
+              <a:rPr lang="en-US" sz="4400" b="1" i="1" dirty="0">
+                <a:solidFill>
+                  <a:srgbClr val="30B8B0"/>
                 </a:solidFill>
                 <a:latin typeface="Montserrat" pitchFamily="34" charset="0"/>
                 <a:ea typeface="Montserrat" pitchFamily="34" charset="-122"/>
                 <a:cs typeface="Montserrat" pitchFamily="34" charset="-120"/>
               </a:rPr>
-              <a:t>1</a:t>
-            </a:r>
-            <a:endParaRPr lang="en-US" sz="1800" dirty="0"/>
-          </a:p>
-        </p:txBody>
-      </p:sp>
-      <p:sp>
-        <p:nvSpPr>
-          <p:cNvPr id="14" name="Text 12"/>
-          <p:cNvSpPr/>
-          <p:nvPr/>
-        </p:nvSpPr>
-        <p:spPr>
-          <a:xfrm>
-            <a:off x="7040880" y="2240280"/>
-            <a:ext cx="4572000" cy="320040"/>
-          </a:xfrm>
-          <a:prstGeom prst="rect">
-            <a:avLst/>
-          </a:prstGeom>
-          <a:noFill/>
-          <a:ln/>
-        </p:spPr>
-        <p:txBody>
-          <a:bodyPr wrap="square" rtlCol="0" anchor="ctr"/>
-          <a:lstStyle/>
-          <a:p>
-            <a:pPr indent="0" marL="0">
-              <a:buNone/>
-            </a:pPr>
-            <a:r>
-              <a:rPr lang="en-US" sz="1400" b="1" dirty="0">
+              <a:t>+500k</a:t>
+            </a:r>
+            <a:endParaRPr lang="en-US" sz="4400" dirty="0"/>
+          </a:p>
+        </p:txBody>
+      </p:sp>
+      <p:sp>
+        <p:nvSpPr>
+          <p:cNvPr id="10" name="Text 8"/>
+          <p:cNvSpPr/>
+          <p:nvPr/>
+        </p:nvSpPr>
+        <p:spPr>
+          <a:xfrm>
+            <a:off x="640080" y="3566160"/>
+            <a:ext cx="2514600" cy="731520"/>
+          </a:xfrm>
+          <a:prstGeom prst="rect">
+            <a:avLst/>
+          </a:prstGeom>
+          <a:noFill/>
+          <a:ln/>
+        </p:spPr>
+        <p:txBody>
+          <a:bodyPr wrap="square" rtlCol="0" anchor="ctr"/>
+          <a:lstStyle/>
+          <a:p>
+            <a:pPr algn="ctr" indent="0" marL="0">
+              <a:buNone/>
+            </a:pPr>
+            <a:r>
+              <a:rPr lang="en-US" sz="1100" dirty="0">
+                <a:solidFill>
+                  <a:srgbClr val="2A2A2A"/>
+                </a:solidFill>
+                <a:latin typeface="Inter" pitchFamily="34" charset="0"/>
+                <a:ea typeface="Inter" pitchFamily="34" charset="-122"/>
+                <a:cs typeface="Inter" pitchFamily="34" charset="-120"/>
+              </a:rPr>
+              <a:t>visitas objetivo</a:t>
+            </a:r>
+            <a:endParaRPr lang="en-US" sz="1100" dirty="0"/>
+          </a:p>
+          <a:p>
+            <a:pPr algn="ctr" indent="0" marL="0">
+              <a:buNone/>
+            </a:pPr>
+            <a:r>
+              <a:rPr lang="en-US" sz="1100" dirty="0">
+                <a:solidFill>
+                  <a:srgbClr val="2A2A2A"/>
+                </a:solidFill>
+                <a:latin typeface="Inter" pitchFamily="34" charset="0"/>
+                <a:ea typeface="Inter" pitchFamily="34" charset="-122"/>
+                <a:cs typeface="Inter" pitchFamily="34" charset="-120"/>
+              </a:rPr>
+              <a:t>fin de campaña</a:t>
+            </a:r>
+            <a:endParaRPr lang="en-US" sz="1100" dirty="0"/>
+          </a:p>
+        </p:txBody>
+      </p:sp>
+      <p:sp>
+        <p:nvSpPr>
+          <p:cNvPr id="11" name="Shape 9"/>
+          <p:cNvSpPr/>
+          <p:nvPr/>
+        </p:nvSpPr>
+        <p:spPr>
+          <a:xfrm>
+            <a:off x="3429000" y="2560320"/>
+            <a:ext cx="2697480" cy="1737360"/>
+          </a:xfrm>
+          <a:prstGeom prst="roundRect">
+            <a:avLst>
+              <a:gd name="adj" fmla="val 6316"/>
+            </a:avLst>
+          </a:prstGeom>
+          <a:solidFill>
+            <a:srgbClr val="FFFFFF"/>
+          </a:solidFill>
+          <a:ln w="25400">
+            <a:solidFill>
+              <a:srgbClr val="183888"/>
+            </a:solidFill>
+            <a:prstDash val="solid"/>
+          </a:ln>
+        </p:spPr>
+      </p:sp>
+      <p:sp>
+        <p:nvSpPr>
+          <p:cNvPr id="12" name="Text 10"/>
+          <p:cNvSpPr/>
+          <p:nvPr/>
+        </p:nvSpPr>
+        <p:spPr>
+          <a:xfrm>
+            <a:off x="3429000" y="2651760"/>
+            <a:ext cx="2697480" cy="914400"/>
+          </a:xfrm>
+          <a:prstGeom prst="rect">
+            <a:avLst/>
+          </a:prstGeom>
+          <a:noFill/>
+          <a:ln/>
+        </p:spPr>
+        <p:txBody>
+          <a:bodyPr wrap="square" rtlCol="0" anchor="ctr"/>
+          <a:lstStyle/>
+          <a:p>
+            <a:pPr algn="ctr" indent="0" marL="0">
+              <a:buNone/>
+            </a:pPr>
+            <a:r>
+              <a:rPr lang="en-US" sz="4400" b="1" i="1" dirty="0">
                 <a:solidFill>
                   <a:srgbClr val="183888"/>
                 </a:solidFill>
@@ -5697,34 +5615,34 @@
                 <a:ea typeface="Montserrat" pitchFamily="34" charset="-122"/>
                 <a:cs typeface="Montserrat" pitchFamily="34" charset="-120"/>
               </a:rPr>
-              <a:t>Home</a:t>
-            </a:r>
-            <a:endParaRPr lang="en-US" sz="1400" dirty="0"/>
-          </a:p>
-        </p:txBody>
-      </p:sp>
-      <p:sp>
-        <p:nvSpPr>
-          <p:cNvPr id="15" name="Text 13"/>
-          <p:cNvSpPr/>
-          <p:nvPr/>
-        </p:nvSpPr>
-        <p:spPr>
-          <a:xfrm>
-            <a:off x="7040880" y="2560320"/>
-            <a:ext cx="4572000" cy="457200"/>
-          </a:xfrm>
-          <a:prstGeom prst="rect">
-            <a:avLst/>
-          </a:prstGeom>
-          <a:noFill/>
-          <a:ln/>
-        </p:spPr>
-        <p:txBody>
-          <a:bodyPr wrap="square" rtlCol="0" anchor="ctr"/>
-          <a:lstStyle/>
-          <a:p>
-            <a:pPr indent="0" marL="0">
+              <a:t>+80k</a:t>
+            </a:r>
+            <a:endParaRPr lang="en-US" sz="4400" dirty="0"/>
+          </a:p>
+        </p:txBody>
+      </p:sp>
+      <p:sp>
+        <p:nvSpPr>
+          <p:cNvPr id="13" name="Text 11"/>
+          <p:cNvSpPr/>
+          <p:nvPr/>
+        </p:nvSpPr>
+        <p:spPr>
+          <a:xfrm>
+            <a:off x="3520440" y="3566160"/>
+            <a:ext cx="2514600" cy="731520"/>
+          </a:xfrm>
+          <a:prstGeom prst="rect">
+            <a:avLst/>
+          </a:prstGeom>
+          <a:noFill/>
+          <a:ln/>
+        </p:spPr>
+        <p:txBody>
+          <a:bodyPr wrap="square" rtlCol="0" anchor="ctr"/>
+          <a:lstStyle/>
+          <a:p>
+            <a:pPr algn="ctr" indent="0" marL="0">
               <a:buNone/>
             </a:pPr>
             <a:r>
@@ -5736,30 +5654,171 @@
                 <a:ea typeface="Inter" pitchFamily="34" charset="-122"/>
                 <a:cs typeface="Inter" pitchFamily="34" charset="-120"/>
               </a:rPr>
-              <a:t>Hero de impacto + 3 cifras fuertes de campaña + aval AMG visible</a:t>
+              <a:t>usuarios registrados</a:t>
             </a:r>
             <a:endParaRPr lang="en-US" sz="1100" dirty="0"/>
           </a:p>
-        </p:txBody>
-      </p:sp>
-      <p:sp>
-        <p:nvSpPr>
-          <p:cNvPr id="16" name="Shape 14"/>
-          <p:cNvSpPr/>
-          <p:nvPr/>
-        </p:nvSpPr>
-        <p:spPr>
-          <a:xfrm>
-            <a:off x="6400800" y="3154680"/>
-            <a:ext cx="457200" cy="457200"/>
-          </a:xfrm>
-          <a:prstGeom prst="ellipse">
-            <a:avLst/>
+          <a:p>
+            <a:pPr algn="ctr" indent="0" marL="0">
+              <a:buNone/>
+            </a:pPr>
+            <a:r>
+              <a:rPr lang="en-US" sz="1100" dirty="0">
+                <a:solidFill>
+                  <a:srgbClr val="2A2A2A"/>
+                </a:solidFill>
+                <a:latin typeface="Inter" pitchFamily="34" charset="0"/>
+                <a:ea typeface="Inter" pitchFamily="34" charset="-122"/>
+                <a:cs typeface="Inter" pitchFamily="34" charset="-120"/>
+              </a:rPr>
+              <a:t>construyen comunidad</a:t>
+            </a:r>
+            <a:endParaRPr lang="en-US" sz="1100" dirty="0"/>
+          </a:p>
+        </p:txBody>
+      </p:sp>
+      <p:sp>
+        <p:nvSpPr>
+          <p:cNvPr id="14" name="Shape 12"/>
+          <p:cNvSpPr/>
+          <p:nvPr/>
+        </p:nvSpPr>
+        <p:spPr>
+          <a:xfrm>
+            <a:off x="6309360" y="2560320"/>
+            <a:ext cx="2697480" cy="1737360"/>
+          </a:xfrm>
+          <a:prstGeom prst="roundRect">
+            <a:avLst>
+              <a:gd name="adj" fmla="val 6316"/>
+            </a:avLst>
           </a:prstGeom>
           <a:solidFill>
-            <a:srgbClr val="30B8B0"/>
+            <a:srgbClr val="FFFFFF"/>
           </a:solidFill>
-          <a:ln w="12700">
+          <a:ln w="25400">
+            <a:solidFill>
+              <a:srgbClr val="887028"/>
+            </a:solidFill>
+            <a:prstDash val="solid"/>
+          </a:ln>
+        </p:spPr>
+      </p:sp>
+      <p:sp>
+        <p:nvSpPr>
+          <p:cNvPr id="15" name="Text 13"/>
+          <p:cNvSpPr/>
+          <p:nvPr/>
+        </p:nvSpPr>
+        <p:spPr>
+          <a:xfrm>
+            <a:off x="6309360" y="2651760"/>
+            <a:ext cx="2697480" cy="914400"/>
+          </a:xfrm>
+          <a:prstGeom prst="rect">
+            <a:avLst/>
+          </a:prstGeom>
+          <a:noFill/>
+          <a:ln/>
+        </p:spPr>
+        <p:txBody>
+          <a:bodyPr wrap="square" rtlCol="0" anchor="ctr"/>
+          <a:lstStyle/>
+          <a:p>
+            <a:pPr algn="ctr" indent="0" marL="0">
+              <a:buNone/>
+            </a:pPr>
+            <a:r>
+              <a:rPr lang="en-US" sz="4400" b="1" i="1" dirty="0">
+                <a:solidFill>
+                  <a:srgbClr val="887028"/>
+                </a:solidFill>
+                <a:latin typeface="Montserrat" pitchFamily="34" charset="0"/>
+                <a:ea typeface="Montserrat" pitchFamily="34" charset="-122"/>
+                <a:cs typeface="Montserrat" pitchFamily="34" charset="-120"/>
+              </a:rPr>
+              <a:t>8</a:t>
+            </a:r>
+            <a:endParaRPr lang="en-US" sz="4400" dirty="0"/>
+          </a:p>
+        </p:txBody>
+      </p:sp>
+      <p:sp>
+        <p:nvSpPr>
+          <p:cNvPr id="16" name="Text 14"/>
+          <p:cNvSpPr/>
+          <p:nvPr/>
+        </p:nvSpPr>
+        <p:spPr>
+          <a:xfrm>
+            <a:off x="6400800" y="3566160"/>
+            <a:ext cx="2514600" cy="731520"/>
+          </a:xfrm>
+          <a:prstGeom prst="rect">
+            <a:avLst/>
+          </a:prstGeom>
+          <a:noFill/>
+          <a:ln/>
+        </p:spPr>
+        <p:txBody>
+          <a:bodyPr wrap="square" rtlCol="0" anchor="ctr"/>
+          <a:lstStyle/>
+          <a:p>
+            <a:pPr algn="ctr" indent="0" marL="0">
+              <a:buNone/>
+            </a:pPr>
+            <a:r>
+              <a:rPr lang="en-US" sz="1100" dirty="0">
+                <a:solidFill>
+                  <a:srgbClr val="2A2A2A"/>
+                </a:solidFill>
+                <a:latin typeface="Inter" pitchFamily="34" charset="0"/>
+                <a:ea typeface="Inter" pitchFamily="34" charset="-122"/>
+                <a:cs typeface="Inter" pitchFamily="34" charset="-120"/>
+              </a:rPr>
+              <a:t>ciclos mensuales</a:t>
+            </a:r>
+            <a:endParaRPr lang="en-US" sz="1100" dirty="0"/>
+          </a:p>
+          <a:p>
+            <a:pPr algn="ctr" indent="0" marL="0">
+              <a:buNone/>
+            </a:pPr>
+            <a:r>
+              <a:rPr lang="en-US" sz="1100" dirty="0">
+                <a:solidFill>
+                  <a:srgbClr val="2A2A2A"/>
+                </a:solidFill>
+                <a:latin typeface="Inter" pitchFamily="34" charset="0"/>
+                <a:ea typeface="Inter" pitchFamily="34" charset="-122"/>
+                <a:cs typeface="Inter" pitchFamily="34" charset="-120"/>
+              </a:rPr>
+              <a:t>de contenido nuevo</a:t>
+            </a:r>
+            <a:endParaRPr lang="en-US" sz="1100" dirty="0"/>
+          </a:p>
+        </p:txBody>
+      </p:sp>
+      <p:sp>
+        <p:nvSpPr>
+          <p:cNvPr id="17" name="Shape 15"/>
+          <p:cNvSpPr/>
+          <p:nvPr/>
+        </p:nvSpPr>
+        <p:spPr>
+          <a:xfrm>
+            <a:off x="9189720" y="2560320"/>
+            <a:ext cx="2697480" cy="1737360"/>
+          </a:xfrm>
+          <a:prstGeom prst="roundRect">
+            <a:avLst>
+              <a:gd name="adj" fmla="val 6316"/>
+            </a:avLst>
+          </a:prstGeom>
+          <a:solidFill>
+            <a:srgbClr val="FFFFFF"/>
+          </a:solidFill>
+          <a:ln w="25400">
             <a:solidFill>
               <a:srgbClr val="30B8B0"/>
             </a:solidFill>
@@ -5769,14 +5828,14 @@
       </p:sp>
       <p:sp>
         <p:nvSpPr>
-          <p:cNvPr id="17" name="Text 15"/>
-          <p:cNvSpPr/>
-          <p:nvPr/>
-        </p:nvSpPr>
-        <p:spPr>
-          <a:xfrm>
-            <a:off x="6400800" y="3154680"/>
-            <a:ext cx="457200" cy="457200"/>
+          <p:cNvPr id="18" name="Text 16"/>
+          <p:cNvSpPr/>
+          <p:nvPr/>
+        </p:nvSpPr>
+        <p:spPr>
+          <a:xfrm>
+            <a:off x="9189720" y="2651760"/>
+            <a:ext cx="2697480" cy="914400"/>
           </a:xfrm>
           <a:prstGeom prst="rect">
             <a:avLst/>
@@ -5792,46 +5851,129 @@
               <a:buNone/>
             </a:pPr>
             <a:r>
-              <a:rPr lang="en-US" sz="1800" b="1" dirty="0">
-                <a:solidFill>
-                  <a:srgbClr val="FFFFFF"/>
+              <a:rPr lang="en-US" sz="4400" b="1" i="1" dirty="0">
+                <a:solidFill>
+                  <a:srgbClr val="30B8B0"/>
                 </a:solidFill>
                 <a:latin typeface="Montserrat" pitchFamily="34" charset="0"/>
                 <a:ea typeface="Montserrat" pitchFamily="34" charset="-122"/>
                 <a:cs typeface="Montserrat" pitchFamily="34" charset="-120"/>
               </a:rPr>
-              <a:t>2</a:t>
-            </a:r>
-            <a:endParaRPr lang="en-US" sz="1800" dirty="0"/>
-          </a:p>
-        </p:txBody>
-      </p:sp>
-      <p:sp>
-        <p:nvSpPr>
-          <p:cNvPr id="18" name="Text 16"/>
-          <p:cNvSpPr/>
-          <p:nvPr/>
-        </p:nvSpPr>
-        <p:spPr>
-          <a:xfrm>
-            <a:off x="7040880" y="3108960"/>
-            <a:ext cx="4572000" cy="320040"/>
-          </a:xfrm>
-          <a:prstGeom prst="rect">
-            <a:avLst/>
-          </a:prstGeom>
-          <a:noFill/>
-          <a:ln/>
-        </p:spPr>
-        <p:txBody>
-          <a:bodyPr wrap="square" rtlCol="0" anchor="ctr"/>
-          <a:lstStyle/>
-          <a:p>
-            <a:pPr indent="0" marL="0">
-              <a:buNone/>
-            </a:pPr>
-            <a:r>
-              <a:rPr lang="en-US" sz="1400" b="1" dirty="0">
+              <a:t>∞</a:t>
+            </a:r>
+            <a:endParaRPr lang="en-US" sz="4400" dirty="0"/>
+          </a:p>
+        </p:txBody>
+      </p:sp>
+      <p:sp>
+        <p:nvSpPr>
+          <p:cNvPr id="19" name="Text 17"/>
+          <p:cNvSpPr/>
+          <p:nvPr/>
+        </p:nvSpPr>
+        <p:spPr>
+          <a:xfrm>
+            <a:off x="9281160" y="3566160"/>
+            <a:ext cx="2514600" cy="731520"/>
+          </a:xfrm>
+          <a:prstGeom prst="rect">
+            <a:avLst/>
+          </a:prstGeom>
+          <a:noFill/>
+          <a:ln/>
+        </p:spPr>
+        <p:txBody>
+          <a:bodyPr wrap="square" rtlCol="0" anchor="ctr"/>
+          <a:lstStyle/>
+          <a:p>
+            <a:pPr algn="ctr" indent="0" marL="0">
+              <a:buNone/>
+            </a:pPr>
+            <a:r>
+              <a:rPr lang="en-US" sz="1100" dirty="0">
+                <a:solidFill>
+                  <a:srgbClr val="2A2A2A"/>
+                </a:solidFill>
+                <a:latin typeface="Inter" pitchFamily="34" charset="0"/>
+                <a:ea typeface="Inter" pitchFamily="34" charset="-122"/>
+                <a:cs typeface="Inter" pitchFamily="34" charset="-120"/>
+              </a:rPr>
+              <a:t>asset permanente</a:t>
+            </a:r>
+            <a:endParaRPr lang="en-US" sz="1100" dirty="0"/>
+          </a:p>
+          <a:p>
+            <a:pPr algn="ctr" indent="0" marL="0">
+              <a:buNone/>
+            </a:pPr>
+            <a:r>
+              <a:rPr lang="en-US" sz="1100" dirty="0">
+                <a:solidFill>
+                  <a:srgbClr val="2A2A2A"/>
+                </a:solidFill>
+                <a:latin typeface="Inter" pitchFamily="34" charset="0"/>
+                <a:ea typeface="Inter" pitchFamily="34" charset="-122"/>
+                <a:cs typeface="Inter" pitchFamily="34" charset="-120"/>
+              </a:rPr>
+              <a:t>post-campaña</a:t>
+            </a:r>
+            <a:endParaRPr lang="en-US" sz="1100" dirty="0"/>
+          </a:p>
+        </p:txBody>
+      </p:sp>
+      <p:sp>
+        <p:nvSpPr>
+          <p:cNvPr id="20" name="Shape 18"/>
+          <p:cNvSpPr/>
+          <p:nvPr/>
+        </p:nvSpPr>
+        <p:spPr>
+          <a:xfrm>
+            <a:off x="548640" y="4480560"/>
+            <a:ext cx="5394960" cy="1737360"/>
+          </a:xfrm>
+          <a:prstGeom prst="roundRect">
+            <a:avLst>
+              <a:gd name="adj" fmla="val 5263"/>
+            </a:avLst>
+          </a:prstGeom>
+          <a:solidFill>
+            <a:srgbClr val="F5F7FA"/>
+          </a:solidFill>
+          <a:ln w="12700">
+            <a:solidFill>
+              <a:srgbClr val="E5E7EB"/>
+            </a:solidFill>
+            <a:prstDash val="solid"/>
+          </a:ln>
+        </p:spPr>
+      </p:sp>
+      <p:sp>
+        <p:nvSpPr>
+          <p:cNvPr id="21" name="Text 19"/>
+          <p:cNvSpPr/>
+          <p:nvPr/>
+        </p:nvSpPr>
+        <p:spPr>
+          <a:xfrm>
+            <a:off x="777240" y="4572000"/>
+            <a:ext cx="5029200" cy="320040"/>
+          </a:xfrm>
+          <a:prstGeom prst="rect">
+            <a:avLst/>
+          </a:prstGeom>
+          <a:noFill/>
+          <a:ln/>
+        </p:spPr>
+        <p:txBody>
+          <a:bodyPr wrap="square" rtlCol="0" anchor="ctr"/>
+          <a:lstStyle/>
+          <a:p>
+            <a:pPr indent="0" marL="0">
+              <a:buNone/>
+            </a:pPr>
+            <a:r>
+              <a:rPr lang="en-US" sz="1300" b="1" dirty="0">
                 <a:solidFill>
                   <a:srgbClr val="183888"/>
                 </a:solidFill>
@@ -5839,38 +5981,38 @@
                 <a:ea typeface="Montserrat" pitchFamily="34" charset="-122"/>
                 <a:cs typeface="Montserrat" pitchFamily="34" charset="-120"/>
               </a:rPr>
-              <a:t>Artículos</a:t>
-            </a:r>
-            <a:endParaRPr lang="en-US" sz="1400" dirty="0"/>
-          </a:p>
-        </p:txBody>
-      </p:sp>
-      <p:sp>
-        <p:nvSpPr>
-          <p:cNvPr id="19" name="Text 17"/>
-          <p:cNvSpPr/>
-          <p:nvPr/>
-        </p:nvSpPr>
-        <p:spPr>
-          <a:xfrm>
-            <a:off x="7040880" y="3429000"/>
-            <a:ext cx="4572000" cy="457200"/>
-          </a:xfrm>
-          <a:prstGeom prst="rect">
-            <a:avLst/>
-          </a:prstGeom>
-          <a:noFill/>
-          <a:ln/>
-        </p:spPr>
-        <p:txBody>
-          <a:bodyPr wrap="square" rtlCol="0" anchor="ctr"/>
-          <a:lstStyle/>
-          <a:p>
-            <a:pPr indent="0" marL="0">
-              <a:buNone/>
-            </a:pPr>
-            <a:r>
-              <a:rPr lang="en-US" sz="1100" dirty="0">
+              <a:t>📈 Crecimiento por ciclos</a:t>
+            </a:r>
+            <a:endParaRPr lang="en-US" sz="1300" dirty="0"/>
+          </a:p>
+        </p:txBody>
+      </p:sp>
+      <p:sp>
+        <p:nvSpPr>
+          <p:cNvPr id="22" name="Text 20"/>
+          <p:cNvSpPr/>
+          <p:nvPr/>
+        </p:nvSpPr>
+        <p:spPr>
+          <a:xfrm>
+            <a:off x="777240" y="4937760"/>
+            <a:ext cx="5029200" cy="1280160"/>
+          </a:xfrm>
+          <a:prstGeom prst="rect">
+            <a:avLst/>
+          </a:prstGeom>
+          <a:noFill/>
+          <a:ln/>
+        </p:spPr>
+        <p:txBody>
+          <a:bodyPr wrap="square" rtlCol="0" anchor="ctr"/>
+          <a:lstStyle/>
+          <a:p>
+            <a:pPr indent="0" marL="0">
+              <a:buNone/>
+            </a:pPr>
+            <a:r>
+              <a:rPr lang="en-US" sz="1050" dirty="0">
                 <a:solidFill>
                   <a:srgbClr val="2A2A2A"/>
                 </a:solidFill>
@@ -5878,32 +6020,34 @@
                 <a:ea typeface="Inter" pitchFamily="34" charset="-122"/>
                 <a:cs typeface="Inter" pitchFamily="34" charset="-120"/>
               </a:rPr>
-              <a:t>Biblioteca educativa para pacientes · crece cada mes del ciclo</a:t>
-            </a:r>
-            <a:endParaRPr lang="en-US" sz="1100" dirty="0"/>
-          </a:p>
-        </p:txBody>
-      </p:sp>
-      <p:sp>
-        <p:nvSpPr>
-          <p:cNvPr id="20" name="Shape 18"/>
-          <p:cNvSpPr/>
-          <p:nvPr/>
-        </p:nvSpPr>
-        <p:spPr>
-          <a:xfrm>
-            <a:off x="6400800" y="4023360"/>
-            <a:ext cx="457200" cy="457200"/>
-          </a:xfrm>
-          <a:prstGeom prst="ellipse">
-            <a:avLst/>
+              <a:t>Cada mes el portal recibe contenido nuevo: artículos, casos clínicos anonimizados, testimonios, referencias bibliográficas. El usuario que se registra regresa mensualmente por lo nuevo — no es visita única, es comunidad recurrente.</a:t>
+            </a:r>
+            <a:endParaRPr lang="en-US" sz="1050" dirty="0"/>
+          </a:p>
+        </p:txBody>
+      </p:sp>
+      <p:sp>
+        <p:nvSpPr>
+          <p:cNvPr id="23" name="Shape 21"/>
+          <p:cNvSpPr/>
+          <p:nvPr/>
+        </p:nvSpPr>
+        <p:spPr>
+          <a:xfrm>
+            <a:off x="6217920" y="4480560"/>
+            <a:ext cx="5394960" cy="1737360"/>
+          </a:xfrm>
+          <a:prstGeom prst="roundRect">
+            <a:avLst>
+              <a:gd name="adj" fmla="val 5263"/>
+            </a:avLst>
           </a:prstGeom>
           <a:solidFill>
-            <a:srgbClr val="30B8B0"/>
+            <a:srgbClr val="F5F7FA"/>
           </a:solidFill>
           <a:ln w="12700">
             <a:solidFill>
-              <a:srgbClr val="30B8B0"/>
+              <a:srgbClr val="E5E7EB"/>
             </a:solidFill>
             <a:prstDash val="solid"/>
           </a:ln>
@@ -5911,108 +6055,69 @@
       </p:sp>
       <p:sp>
         <p:nvSpPr>
-          <p:cNvPr id="21" name="Text 19"/>
-          <p:cNvSpPr/>
-          <p:nvPr/>
-        </p:nvSpPr>
-        <p:spPr>
-          <a:xfrm>
-            <a:off x="6400800" y="4023360"/>
-            <a:ext cx="457200" cy="457200"/>
-          </a:xfrm>
-          <a:prstGeom prst="rect">
-            <a:avLst/>
-          </a:prstGeom>
-          <a:noFill/>
-          <a:ln/>
-        </p:spPr>
-        <p:txBody>
-          <a:bodyPr wrap="square" rtlCol="0" anchor="ctr"/>
-          <a:lstStyle/>
-          <a:p>
-            <a:pPr algn="ctr" indent="0" marL="0">
-              <a:buNone/>
-            </a:pPr>
-            <a:r>
-              <a:rPr lang="en-US" sz="1800" b="1" dirty="0">
-                <a:solidFill>
-                  <a:srgbClr val="FFFFFF"/>
+          <p:cNvPr id="24" name="Text 22"/>
+          <p:cNvSpPr/>
+          <p:nvPr/>
+        </p:nvSpPr>
+        <p:spPr>
+          <a:xfrm>
+            <a:off x="6446520" y="4572000"/>
+            <a:ext cx="5029200" cy="320040"/>
+          </a:xfrm>
+          <a:prstGeom prst="rect">
+            <a:avLst/>
+          </a:prstGeom>
+          <a:noFill/>
+          <a:ln/>
+        </p:spPr>
+        <p:txBody>
+          <a:bodyPr wrap="square" rtlCol="0" anchor="ctr"/>
+          <a:lstStyle/>
+          <a:p>
+            <a:pPr indent="0" marL="0">
+              <a:buNone/>
+            </a:pPr>
+            <a:r>
+              <a:rPr lang="en-US" sz="1300" b="1" dirty="0">
+                <a:solidFill>
+                  <a:srgbClr val="183888"/>
                 </a:solidFill>
                 <a:latin typeface="Montserrat" pitchFamily="34" charset="0"/>
                 <a:ea typeface="Montserrat" pitchFamily="34" charset="-122"/>
                 <a:cs typeface="Montserrat" pitchFamily="34" charset="-120"/>
               </a:rPr>
-              <a:t>3</a:t>
-            </a:r>
-            <a:endParaRPr lang="en-US" sz="1800" dirty="0"/>
-          </a:p>
-        </p:txBody>
-      </p:sp>
-      <p:sp>
-        <p:nvSpPr>
-          <p:cNvPr id="22" name="Text 20"/>
-          <p:cNvSpPr/>
-          <p:nvPr/>
-        </p:nvSpPr>
-        <p:spPr>
-          <a:xfrm>
-            <a:off x="7040880" y="3977640"/>
-            <a:ext cx="4572000" cy="320040"/>
-          </a:xfrm>
-          <a:prstGeom prst="rect">
-            <a:avLst/>
-          </a:prstGeom>
-          <a:noFill/>
-          <a:ln/>
-        </p:spPr>
-        <p:txBody>
-          <a:bodyPr wrap="square" rtlCol="0" anchor="ctr"/>
-          <a:lstStyle/>
-          <a:p>
-            <a:pPr indent="0" marL="0">
-              <a:buNone/>
-            </a:pPr>
-            <a:r>
-              <a:rPr lang="en-US" sz="1400" b="1" dirty="0">
-                <a:solidFill>
-                  <a:srgbClr val="183888"/>
-                </a:solidFill>
-                <a:latin typeface="Montserrat" pitchFamily="34" charset="0"/>
-                <a:ea typeface="Montserrat" pitchFamily="34" charset="-122"/>
-                <a:cs typeface="Montserrat" pitchFamily="34" charset="-120"/>
-              </a:rPr>
-              <a:t>Detección</a:t>
-            </a:r>
-            <a:endParaRPr lang="en-US" sz="1400" dirty="0"/>
-          </a:p>
-        </p:txBody>
-      </p:sp>
-      <p:sp>
-        <p:nvSpPr>
-          <p:cNvPr id="23" name="Text 21"/>
-          <p:cNvSpPr/>
-          <p:nvPr/>
-        </p:nvSpPr>
-        <p:spPr>
-          <a:xfrm>
-            <a:off x="7040880" y="4297680"/>
-            <a:ext cx="4572000" cy="457200"/>
-          </a:xfrm>
-          <a:prstGeom prst="rect">
-            <a:avLst/>
-          </a:prstGeom>
-          <a:noFill/>
-          <a:ln/>
-        </p:spPr>
-        <p:txBody>
-          <a:bodyPr wrap="square" rtlCol="0" anchor="ctr"/>
-          <a:lstStyle/>
-          <a:p>
-            <a:pPr indent="0" marL="0">
-              <a:buNone/>
-            </a:pPr>
-            <a:r>
-              <a:rPr lang="en-US" sz="1100" dirty="0">
+              <a:t>🏛️ Apalancamiento AMG permanente</a:t>
+            </a:r>
+            <a:endParaRPr lang="en-US" sz="1300" dirty="0"/>
+          </a:p>
+        </p:txBody>
+      </p:sp>
+      <p:sp>
+        <p:nvSpPr>
+          <p:cNvPr id="25" name="Text 23"/>
+          <p:cNvSpPr/>
+          <p:nvPr/>
+        </p:nvSpPr>
+        <p:spPr>
+          <a:xfrm>
+            <a:off x="6446520" y="4937760"/>
+            <a:ext cx="5029200" cy="1280160"/>
+          </a:xfrm>
+          <a:prstGeom prst="rect">
+            <a:avLst/>
+          </a:prstGeom>
+          <a:noFill/>
+          <a:ln/>
+        </p:spPr>
+        <p:txBody>
+          <a:bodyPr wrap="square" rtlCol="0" anchor="ctr"/>
+          <a:lstStyle/>
+          <a:p>
+            <a:pPr indent="0" marL="0">
+              <a:buNone/>
+            </a:pPr>
+            <a:r>
+              <a:rPr lang="en-US" sz="1050" dirty="0">
                 <a:solidFill>
                   <a:srgbClr val="2A2A2A"/>
                 </a:solidFill>
@@ -6020,73 +6125,9 @@
                 <a:ea typeface="Inter" pitchFamily="34" charset="-122"/>
                 <a:cs typeface="Inter" pitchFamily="34" charset="-120"/>
               </a:rPr>
-              <a:t>Landing de registro gratuito a campaña de prueba de aliento</a:t>
-            </a:r>
-            <a:endParaRPr lang="en-US" sz="1100" dirty="0"/>
-          </a:p>
-        </p:txBody>
-      </p:sp>
-      <p:sp>
-        <p:nvSpPr>
-          <p:cNvPr id="24" name="Shape 22"/>
-          <p:cNvSpPr/>
-          <p:nvPr/>
-        </p:nvSpPr>
-        <p:spPr>
-          <a:xfrm>
-            <a:off x="6400800" y="4892040"/>
-            <a:ext cx="457200" cy="457200"/>
-          </a:xfrm>
-          <a:prstGeom prst="ellipse">
-            <a:avLst/>
-          </a:prstGeom>
-          <a:solidFill>
-            <a:srgbClr val="30B8B0"/>
-          </a:solidFill>
-          <a:ln w="12700">
-            <a:solidFill>
-              <a:srgbClr val="30B8B0"/>
-            </a:solidFill>
-            <a:prstDash val="solid"/>
-          </a:ln>
-        </p:spPr>
-      </p:sp>
-      <p:sp>
-        <p:nvSpPr>
-          <p:cNvPr id="25" name="Text 23"/>
-          <p:cNvSpPr/>
-          <p:nvPr/>
-        </p:nvSpPr>
-        <p:spPr>
-          <a:xfrm>
-            <a:off x="6400800" y="4892040"/>
-            <a:ext cx="457200" cy="457200"/>
-          </a:xfrm>
-          <a:prstGeom prst="rect">
-            <a:avLst/>
-          </a:prstGeom>
-          <a:noFill/>
-          <a:ln/>
-        </p:spPr>
-        <p:txBody>
-          <a:bodyPr wrap="square" rtlCol="0" anchor="ctr"/>
-          <a:lstStyle/>
-          <a:p>
-            <a:pPr algn="ctr" indent="0" marL="0">
-              <a:buNone/>
-            </a:pPr>
-            <a:r>
-              <a:rPr lang="en-US" sz="1800" b="1" dirty="0">
-                <a:solidFill>
-                  <a:srgbClr val="FFFFFF"/>
-                </a:solidFill>
-                <a:latin typeface="Montserrat" pitchFamily="34" charset="0"/>
-                <a:ea typeface="Montserrat" pitchFamily="34" charset="-122"/>
-                <a:cs typeface="Montserrat" pitchFamily="34" charset="-120"/>
-              </a:rPr>
-              <a:t>4</a:t>
-            </a:r>
-            <a:endParaRPr lang="en-US" sz="1800" dirty="0"/>
+              <a:t>El aval institucional de la AMG trasciende el calendario Carnot. Al cerrar los 8 ciclos, el portal no se apaga: queda como referencia pública permanente sobre H. pylori en México, avalada por la AMG — un asset digital con valor de años.</a:t>
+            </a:r>
+            <a:endParaRPr lang="en-US" sz="1050" dirty="0"/>
           </a:p>
         </p:txBody>
       </p:sp>
@@ -6098,109 +6139,31 @@
         </p:nvSpPr>
         <p:spPr>
           <a:xfrm>
-            <a:off x="7040880" y="4846320"/>
-            <a:ext cx="4572000" cy="320040"/>
-          </a:xfrm>
-          <a:prstGeom prst="rect">
-            <a:avLst/>
-          </a:prstGeom>
-          <a:noFill/>
-          <a:ln/>
-        </p:spPr>
-        <p:txBody>
-          <a:bodyPr wrap="square" rtlCol="0" anchor="ctr"/>
-          <a:lstStyle/>
-          <a:p>
-            <a:pPr indent="0" marL="0">
-              <a:buNone/>
-            </a:pPr>
-            <a:r>
-              <a:rPr lang="en-US" sz="1400" b="1" dirty="0">
-                <a:solidFill>
-                  <a:srgbClr val="183888"/>
-                </a:solidFill>
-                <a:latin typeface="Montserrat" pitchFamily="34" charset="0"/>
-                <a:ea typeface="Montserrat" pitchFamily="34" charset="-122"/>
-                <a:cs typeface="Montserrat" pitchFamily="34" charset="-120"/>
-              </a:rPr>
-              <a:t>Para médicos</a:t>
-            </a:r>
-            <a:endParaRPr lang="en-US" sz="1400" dirty="0"/>
-          </a:p>
-        </p:txBody>
-      </p:sp>
-      <p:sp>
-        <p:nvSpPr>
-          <p:cNvPr id="27" name="Text 25"/>
-          <p:cNvSpPr/>
-          <p:nvPr/>
-        </p:nvSpPr>
-        <p:spPr>
-          <a:xfrm>
-            <a:off x="7040880" y="5166360"/>
-            <a:ext cx="4572000" cy="457200"/>
-          </a:xfrm>
-          <a:prstGeom prst="rect">
-            <a:avLst/>
-          </a:prstGeom>
-          <a:noFill/>
-          <a:ln/>
-        </p:spPr>
-        <p:txBody>
-          <a:bodyPr wrap="square" rtlCol="0" anchor="ctr"/>
-          <a:lstStyle/>
-          <a:p>
-            <a:pPr indent="0" marL="0">
-              <a:buNone/>
-            </a:pPr>
-            <a:r>
-              <a:rPr lang="en-US" sz="1100" dirty="0">
-                <a:solidFill>
-                  <a:srgbClr val="2A2A2A"/>
+            <a:off x="548640" y="6446520"/>
+            <a:ext cx="8229600" cy="274320"/>
+          </a:xfrm>
+          <a:prstGeom prst="rect">
+            <a:avLst/>
+          </a:prstGeom>
+          <a:noFill/>
+          <a:ln/>
+        </p:spPr>
+        <p:txBody>
+          <a:bodyPr wrap="square" rtlCol="0" anchor="ctr"/>
+          <a:lstStyle/>
+          <a:p>
+            <a:pPr indent="0" marL="0">
+              <a:buNone/>
+            </a:pPr>
+            <a:r>
+              <a:rPr lang="en-US" sz="900" dirty="0">
+                <a:solidFill>
+                  <a:srgbClr val="9CA3AF"/>
                 </a:solidFill>
                 <a:latin typeface="Inter" pitchFamily="34" charset="0"/>
                 <a:ea typeface="Inter" pitchFamily="34" charset="-122"/>
                 <a:cs typeface="Inter" pitchFamily="34" charset="-120"/>
               </a:rPr>
-              <a:t>Evidencia clínica + referencias Maastricht + acceso a Ki-CAB</a:t>
-            </a:r>
-            <a:endParaRPr lang="en-US" sz="1100" dirty="0"/>
-          </a:p>
-        </p:txBody>
-      </p:sp>
-      <p:sp>
-        <p:nvSpPr>
-          <p:cNvPr id="28" name="Text 26"/>
-          <p:cNvSpPr/>
-          <p:nvPr/>
-        </p:nvSpPr>
-        <p:spPr>
-          <a:xfrm>
-            <a:off x="548640" y="6446520"/>
-            <a:ext cx="8229600" cy="274320"/>
-          </a:xfrm>
-          <a:prstGeom prst="rect">
-            <a:avLst/>
-          </a:prstGeom>
-          <a:noFill/>
-          <a:ln/>
-        </p:spPr>
-        <p:txBody>
-          <a:bodyPr wrap="square" rtlCol="0" anchor="ctr"/>
-          <a:lstStyle/>
-          <a:p>
-            <a:pPr indent="0" marL="0">
-              <a:buNone/>
-            </a:pPr>
-            <a:r>
-              <a:rPr lang="en-US" sz="900" dirty="0">
-                <a:solidFill>
-                  <a:srgbClr val="9CA3AF"/>
-                </a:solidFill>
-                <a:latin typeface="Inter" pitchFamily="34" charset="0"/>
-                <a:ea typeface="Inter" pitchFamily="34" charset="-122"/>
-                <a:cs typeface="Inter" pitchFamily="34" charset="-120"/>
-              </a:rPr>
               <a:t>Polar Multimedia · Sistema AMG 2026 · Confidencial Carnot/AMG</a:t>
             </a:r>
             <a:endParaRPr lang="en-US" sz="900" dirty="0"/>
@@ -6209,7 +6172,7 @@
       </p:sp>
       <p:sp>
         <p:nvSpPr>
-          <p:cNvPr id="29" name="Text 27"/>
+          <p:cNvPr id="27" name="Text 25"/>
           <p:cNvSpPr/>
           <p:nvPr/>
         </p:nvSpPr>
@@ -6336,7 +6299,7 @@
                 <a:ea typeface="Montserrat" pitchFamily="34" charset="-122"/>
                 <a:cs typeface="Montserrat" pitchFamily="34" charset="-120"/>
               </a:rPr>
-              <a:t>INFLUENCERS MÉDICOS (KOLs) · 6 PERFILES</a:t>
+              <a:t>INFLUENCERS MÉDICOS · MOTOR PRINCIPAL DE LA COMUNIDAD</a:t>
             </a:r>
             <a:endParaRPr lang="en-US" sz="1100" dirty="0"/>
           </a:p>
@@ -6367,7 +6330,7 @@
               <a:buNone/>
             </a:pPr>
             <a:r>
-              <a:rPr lang="en-US" sz="2800" b="1" dirty="0">
+              <a:rPr lang="en-US" sz="2600" b="1" dirty="0">
                 <a:solidFill>
                   <a:srgbClr val="183888"/>
                 </a:solidFill>
@@ -6375,9 +6338,9 @@
                 <a:ea typeface="Montserrat" pitchFamily="34" charset="-122"/>
                 <a:cs typeface="Montserrat" pitchFamily="34" charset="-120"/>
               </a:rPr>
-              <a:t>Roster contratado para amplificación orgánica</a:t>
-            </a:r>
-            <a:endParaRPr lang="en-US" sz="2800" dirty="0"/>
+              <a:t>Los 6 que llevan al paciente mexicano al portal</a:t>
+            </a:r>
+            <a:endParaRPr lang="en-US" sz="2600" dirty="0"/>
           </a:p>
         </p:txBody>
       </p:sp>
@@ -16760,7 +16723,7 @@
               <a:buNone/>
             </a:pPr>
             <a:r>
-              <a:rPr lang="en-US" sz="5600" b="1" i="1" dirty="0">
+              <a:rPr lang="en-US" sz="5200" b="1" i="1" dirty="0">
                 <a:solidFill>
                   <a:srgbClr val="30B8B0"/>
                 </a:solidFill>
@@ -16768,9 +16731,9 @@
                 <a:ea typeface="Montserrat" pitchFamily="34" charset="-122"/>
                 <a:cs typeface="Montserrat" pitchFamily="34" charset="-120"/>
               </a:rPr>
-              <a:t>+500k</a:t>
-            </a:r>
-            <a:endParaRPr lang="en-US" sz="5600" dirty="0"/>
+              <a:t>+80k</a:t>
+            </a:r>
+            <a:endParaRPr lang="en-US" sz="5200" dirty="0"/>
           </a:p>
         </p:txBody>
       </p:sp>
@@ -16799,7 +16762,7 @@
               <a:buNone/>
             </a:pPr>
             <a:r>
-              <a:rPr lang="en-US" sz="1300" dirty="0">
+              <a:rPr lang="en-US" sz="1250" dirty="0">
                 <a:solidFill>
                   <a:srgbClr val="2A2A2A"/>
                 </a:solidFill>
@@ -16807,9 +16770,26 @@
                 <a:ea typeface="Inter" pitchFamily="34" charset="-122"/>
                 <a:cs typeface="Inter" pitchFamily="34" charset="-120"/>
               </a:rPr>
-              <a:t>registros en landing detección</a:t>
-            </a:r>
-            <a:endParaRPr lang="en-US" sz="1300" dirty="0"/>
+              <a:t>usuarios registrados</a:t>
+            </a:r>
+            <a:endParaRPr lang="en-US" sz="1250" dirty="0"/>
+          </a:p>
+          <a:p>
+            <a:pPr algn="ctr" indent="0" marL="0">
+              <a:buNone/>
+            </a:pPr>
+            <a:r>
+              <a:rPr lang="en-US" sz="1250" dirty="0">
+                <a:solidFill>
+                  <a:srgbClr val="2A2A2A"/>
+                </a:solidFill>
+                <a:latin typeface="Inter" pitchFamily="34" charset="0"/>
+                <a:ea typeface="Inter" pitchFamily="34" charset="-122"/>
+                <a:cs typeface="Inter" pitchFamily="34" charset="-120"/>
+              </a:rPr>
+              <a:t>en el portal (comunidad)</a:t>
+            </a:r>
+            <a:endParaRPr lang="en-US" sz="1250" dirty="0"/>
           </a:p>
         </p:txBody>
       </p:sp>
@@ -16865,7 +16845,7 @@
               <a:buNone/>
             </a:pPr>
             <a:r>
-              <a:rPr lang="en-US" sz="5600" b="1" i="1" dirty="0">
+              <a:rPr lang="en-US" sz="5200" b="1" i="1" dirty="0">
                 <a:solidFill>
                   <a:srgbClr val="183888"/>
                 </a:solidFill>
@@ -16873,9 +16853,9 @@
                 <a:ea typeface="Montserrat" pitchFamily="34" charset="-122"/>
                 <a:cs typeface="Montserrat" pitchFamily="34" charset="-120"/>
               </a:rPr>
-              <a:t>+35%</a:t>
-            </a:r>
-            <a:endParaRPr lang="en-US" sz="5600" dirty="0"/>
+              <a:t>+500k</a:t>
+            </a:r>
+            <a:endParaRPr lang="en-US" sz="5200" dirty="0"/>
           </a:p>
         </p:txBody>
       </p:sp>
@@ -16904,7 +16884,7 @@
               <a:buNone/>
             </a:pPr>
             <a:r>
-              <a:rPr lang="en-US" sz="1300" dirty="0">
+              <a:rPr lang="en-US" sz="1250" dirty="0">
                 <a:solidFill>
                   <a:srgbClr val="2A2A2A"/>
                 </a:solidFill>
@@ -16912,16 +16892,16 @@
                 <a:ea typeface="Inter" pitchFamily="34" charset="-122"/>
                 <a:cs typeface="Inter" pitchFamily="34" charset="-120"/>
               </a:rPr>
-              <a:t>adopción de vocabulario</a:t>
-            </a:r>
-            <a:endParaRPr lang="en-US" sz="1300" dirty="0"/>
+              <a:t>visitas únicas</a:t>
+            </a:r>
+            <a:endParaRPr lang="en-US" sz="1250" dirty="0"/>
           </a:p>
           <a:p>
             <a:pPr algn="ctr" indent="0" marL="0">
               <a:buNone/>
             </a:pPr>
             <a:r>
-              <a:rPr lang="en-US" sz="1300" dirty="0">
+              <a:rPr lang="en-US" sz="1250" dirty="0">
                 <a:solidFill>
                   <a:srgbClr val="2A2A2A"/>
                 </a:solidFill>
@@ -16929,9 +16909,9 @@
                 <a:ea typeface="Inter" pitchFamily="34" charset="-122"/>
                 <a:cs typeface="Inter" pitchFamily="34" charset="-120"/>
               </a:rPr>
-              <a:t>H. pylori en pacientes</a:t>
-            </a:r>
-            <a:endParaRPr lang="en-US" sz="1300" dirty="0"/>
+              <a:t>mexicosincancergastrico.com.mx</a:t>
+            </a:r>
+            <a:endParaRPr lang="en-US" sz="1250" dirty="0"/>
           </a:p>
         </p:txBody>
       </p:sp>
@@ -16987,7 +16967,7 @@
               <a:buNone/>
             </a:pPr>
             <a:r>
-              <a:rPr lang="en-US" sz="5600" b="1" i="1" dirty="0">
+              <a:rPr lang="en-US" sz="5200" b="1" i="1" dirty="0">
                 <a:solidFill>
                   <a:srgbClr val="887028"/>
                 </a:solidFill>
@@ -16995,9 +16975,9 @@
                 <a:ea typeface="Montserrat" pitchFamily="34" charset="-122"/>
                 <a:cs typeface="Montserrat" pitchFamily="34" charset="-120"/>
               </a:rPr>
-              <a:t>+22%</a:t>
-            </a:r>
-            <a:endParaRPr lang="en-US" sz="5600" dirty="0"/>
+              <a:t>+35%</a:t>
+            </a:r>
+            <a:endParaRPr lang="en-US" sz="5200" dirty="0"/>
           </a:p>
         </p:txBody>
       </p:sp>
@@ -17026,7 +17006,7 @@
               <a:buNone/>
             </a:pPr>
             <a:r>
-              <a:rPr lang="en-US" sz="1300" dirty="0">
+              <a:rPr lang="en-US" sz="1250" dirty="0">
                 <a:solidFill>
                   <a:srgbClr val="2A2A2A"/>
                 </a:solidFill>
@@ -17034,16 +17014,16 @@
                 <a:ea typeface="Inter" pitchFamily="34" charset="-122"/>
                 <a:cs typeface="Inter" pitchFamily="34" charset="-120"/>
               </a:rPr>
-              <a:t>prescripciones Ki-CAB</a:t>
-            </a:r>
-            <a:endParaRPr lang="en-US" sz="1300" dirty="0"/>
+              <a:t>adopción de vocabulario</a:t>
+            </a:r>
+            <a:endParaRPr lang="en-US" sz="1250" dirty="0"/>
           </a:p>
           <a:p>
             <a:pPr algn="ctr" indent="0" marL="0">
               <a:buNone/>
             </a:pPr>
             <a:r>
-              <a:rPr lang="en-US" sz="1300" dirty="0">
+              <a:rPr lang="en-US" sz="1250" dirty="0">
                 <a:solidFill>
                   <a:srgbClr val="2A2A2A"/>
                 </a:solidFill>
@@ -17051,9 +17031,9 @@
                 <a:ea typeface="Inter" pitchFamily="34" charset="-122"/>
                 <a:cs typeface="Inter" pitchFamily="34" charset="-120"/>
               </a:rPr>
-              <a:t>nuevas vs baseline</a:t>
-            </a:r>
-            <a:endParaRPr lang="en-US" sz="1300" dirty="0"/>
+              <a:t>H. pylori en pacientes</a:t>
+            </a:r>
+            <a:endParaRPr lang="en-US" sz="1250" dirty="0"/>
           </a:p>
         </p:txBody>
       </p:sp>
@@ -17109,7 +17089,7 @@
               <a:buNone/>
             </a:pPr>
             <a:r>
-              <a:rPr lang="en-US" sz="5600" b="1" i="1" dirty="0">
+              <a:rPr lang="en-US" sz="5200" b="1" i="1" dirty="0">
                 <a:solidFill>
                   <a:srgbClr val="30B8B0"/>
                 </a:solidFill>
@@ -17119,7 +17099,7 @@
               </a:rPr>
               <a:t>75k</a:t>
             </a:r>
-            <a:endParaRPr lang="en-US" sz="5600" dirty="0"/>
+            <a:endParaRPr lang="en-US" sz="5200" dirty="0"/>
           </a:p>
         </p:txBody>
       </p:sp>
@@ -17148,7 +17128,7 @@
               <a:buNone/>
             </a:pPr>
             <a:r>
-              <a:rPr lang="en-US" sz="1300" dirty="0">
+              <a:rPr lang="en-US" sz="1250" dirty="0">
                 <a:solidFill>
                   <a:srgbClr val="2A2A2A"/>
                 </a:solidFill>
@@ -17158,14 +17138,14 @@
               </a:rPr>
               <a:t>alcance por post KOL</a:t>
             </a:r>
-            <a:endParaRPr lang="en-US" sz="1300" dirty="0"/>
+            <a:endParaRPr lang="en-US" sz="1250" dirty="0"/>
           </a:p>
           <a:p>
             <a:pPr algn="ctr" indent="0" marL="0">
               <a:buNone/>
             </a:pPr>
             <a:r>
-              <a:rPr lang="en-US" sz="1300" dirty="0">
+              <a:rPr lang="en-US" sz="1250" dirty="0">
                 <a:solidFill>
                   <a:srgbClr val="2A2A2A"/>
                 </a:solidFill>
@@ -17175,7 +17155,7 @@
               </a:rPr>
               <a:t>en comunidad HCP</a:t>
             </a:r>
-            <a:endParaRPr lang="en-US" sz="1300" dirty="0"/>
+            <a:endParaRPr lang="en-US" sz="1250" dirty="0"/>
           </a:p>
         </p:txBody>
       </p:sp>
@@ -17270,7 +17250,7 @@
               <a:buNone/>
             </a:pPr>
             <a:r>
-              <a:rPr lang="en-US" sz="1800" b="1" i="1" dirty="0">
+              <a:rPr lang="en-US" sz="1500" b="1" i="1" dirty="0">
                 <a:solidFill>
                   <a:srgbClr val="FFFFFF"/>
                 </a:solidFill>
@@ -17278,9 +17258,9 @@
                 <a:ea typeface="Montserrat" pitchFamily="34" charset="-122"/>
                 <a:cs typeface="Montserrat" pitchFamily="34" charset="-120"/>
               </a:rPr>
-              <a:t>Reducción del 46% en riesgo absoluto de cáncer gástrico en población detectada y tratada.</a:t>
-            </a:r>
-            <a:endParaRPr lang="en-US" sz="1800" dirty="0"/>
+              <a:t>Una comunidad digital permanente avalada por la AMG, con 80 mil usuarios registrados que regresan cada mes al portal — asset de largo plazo para Carnot y para la salud pública de México.</a:t>
+            </a:r>
+            <a:endParaRPr lang="en-US" sz="1500" dirty="0"/>
           </a:p>
         </p:txBody>
       </p:sp>

</xml_diff>